<commit_message>
Update trail store workshop presentation
</commit_message>
<xml_diff>
--- a/docs/trail-store-workshop.pptx
+++ b/docs/trail-store-workshop.pptx
@@ -4,6 +4,9 @@
   <p:sldMasterIdLst>
     <p:sldMasterId id="2147483648" r:id="rId1"/>
   </p:sldMasterIdLst>
+  <p:notesMasterIdLst>
+    <p:notesMasterId r:id="rId14"/>
+  </p:notesMasterIdLst>
   <p:sldIdLst>
     <p:sldId id="256" r:id="rId2"/>
     <p:sldId id="257" r:id="rId3"/>
@@ -18,9 +21,6 @@
     <p:sldId id="266" r:id="rId12"/>
     <p:sldId id="267" r:id="rId13"/>
   </p:sldIdLst>
-  <p:notesMasterIdLst>
-    <p:notesMasterId r:id="rId14"/>
-  </p:notesMasterIdLst>
   <p:sldSz cx="12192000" cy="6858000"/>
   <p:notesSz cx="6858000" cy="12192000"/>
   <p:defaultTextStyle>
@@ -115,6 +115,11 @@
       </a:defRPr>
     </a:lvl9pPr>
   </p:defaultTextStyle>
+  <p:extLst>
+    <p:ext uri="{EFAFB233-063F-42B5-8137-9DF3F51BA10A}">
+      <p15:sldGuideLst xmlns:p15="http://schemas.microsoft.com/office/powerpoint/2012/main"/>
+    </p:ext>
+  </p:extLst>
 </p:presentation>
 </file>
 
@@ -140,234 +145,10 @@
           <a:chExt cx="0" cy="0"/>
         </a:xfrm>
       </p:grpSpPr>
-      <p:sp>
-        <p:nvSpPr>
-          <p:cNvPr id="2" name="Header Placeholder 1"/>
-          <p:cNvSpPr>
-            <a:spLocks noGrp="1"/>
-          </p:cNvSpPr>
-          <p:nvPr>
-            <p:ph type="hdr" sz="quarter"/>
-          </p:nvPr>
-        </p:nvSpPr>
-        <p:spPr>
-          <a:xfrm>
-            <a:off x="0" y="0"/>
-            <a:ext cx="2971800" cy="458788"/>
-          </a:xfrm>
-          <a:prstGeom prst="rect">
-            <a:avLst/>
-          </a:prstGeom>
-        </p:spPr>
-        <p:txBody>
-          <a:bodyPr vert="horz" lIns="91440" tIns="45720" rIns="91440" bIns="45720" rtlCol="0"/>
-          <a:lstStyle>
-            <a:lvl1pPr algn="l">
-              <a:defRPr sz="1200"/>
-            </a:lvl1pPr>
-          </a:lstStyle>
-          <a:p>
-            <a:endParaRPr lang="en-US"/>
-          </a:p>
-        </p:txBody>
-      </p:sp>
-      <p:sp>
-        <p:nvSpPr>
-          <p:cNvPr id="3" name="Date Placeholder 2"/>
-          <p:cNvSpPr>
-            <a:spLocks noGrp="1"/>
-          </p:cNvSpPr>
-          <p:nvPr>
-            <p:ph type="dt" idx="1"/>
-          </p:nvPr>
-        </p:nvSpPr>
-        <p:spPr>
-          <a:xfrm>
-            <a:off x="3884613" y="0"/>
-            <a:ext cx="2971800" cy="458788"/>
-          </a:xfrm>
-          <a:prstGeom prst="rect">
-            <a:avLst/>
-          </a:prstGeom>
-        </p:spPr>
-        <p:txBody>
-          <a:bodyPr vert="horz" lIns="91440" tIns="45720" rIns="91440" bIns="45720" rtlCol="0"/>
-          <a:lstStyle>
-            <a:lvl1pPr algn="r">
-              <a:defRPr sz="1200"/>
-            </a:lvl1pPr>
-          </a:lstStyle>
-          <a:p>
-            <a:fld id="{5282F153-3F37-0F45-9E97-73ACFA13230C}" type="datetimeFigureOut">
-              <a:rPr lang="en-US"/>
-              <a:t>7/23/19</a:t>
-            </a:fld>
-            <a:endParaRPr lang="en-US"/>
-          </a:p>
-        </p:txBody>
-      </p:sp>
-      <p:sp>
-        <p:nvSpPr>
-          <p:cNvPr id="4" name="Slide Image Placeholder 3"/>
-          <p:cNvSpPr>
-            <a:spLocks noGrp="1" noRot="1" noChangeAspect="1"/>
-          </p:cNvSpPr>
-          <p:nvPr>
-            <p:ph type="sldImg" idx="2"/>
-          </p:nvPr>
-        </p:nvSpPr>
-        <p:spPr>
-          <a:xfrm>
-            <a:off x="685800" y="1143000"/>
-            <a:ext cx="5486400" cy="3086100"/>
-          </a:xfrm>
-          <a:prstGeom prst="rect">
-            <a:avLst/>
-          </a:prstGeom>
-          <a:noFill/>
-          <a:ln w="12700">
-            <a:solidFill>
-              <a:prstClr val="black"/>
-            </a:solidFill>
-          </a:ln>
-        </p:spPr>
-        <p:txBody>
-          <a:bodyPr vert="horz" lIns="91440" tIns="45720" rIns="91440" bIns="45720" rtlCol="0" anchor="ctr"/>
-          <a:lstStyle/>
-          <a:p>
-            <a:endParaRPr lang="en-US"/>
-          </a:p>
-        </p:txBody>
-      </p:sp>
-      <p:sp>
-        <p:nvSpPr>
-          <p:cNvPr id="5" name="Notes Placeholder 4"/>
-          <p:cNvSpPr>
-            <a:spLocks noGrp="1"/>
-          </p:cNvSpPr>
-          <p:nvPr>
-            <p:ph type="body" sz="quarter" idx="3"/>
-          </p:nvPr>
-        </p:nvSpPr>
-        <p:spPr>
-          <a:xfrm>
-            <a:off x="685800" y="4400550"/>
-            <a:ext cx="5486400" cy="3600450"/>
-          </a:xfrm>
-          <a:prstGeom prst="rect">
-            <a:avLst/>
-          </a:prstGeom>
-        </p:spPr>
-        <p:txBody>
-          <a:bodyPr vert="horz" lIns="91440" tIns="45720" rIns="91440" bIns="45720" rtlCol="0"/>
-          <a:lstStyle/>
-          <a:p>
-            <a:pPr lvl="0"/>
-            <a:r>
-              <a:rPr lang="en-US"/>
-              <a:t>Click to edit Master text styles</a:t>
-            </a:r>
-          </a:p>
-          <a:p>
-            <a:pPr lvl="1"/>
-            <a:r>
-              <a:rPr lang="en-US"/>
-              <a:t>Second level</a:t>
-            </a:r>
-          </a:p>
-          <a:p>
-            <a:pPr lvl="2"/>
-            <a:r>
-              <a:rPr lang="en-US"/>
-              <a:t>Third level</a:t>
-            </a:r>
-          </a:p>
-          <a:p>
-            <a:pPr lvl="3"/>
-            <a:r>
-              <a:rPr lang="en-US"/>
-              <a:t>Fourth level</a:t>
-            </a:r>
-          </a:p>
-          <a:p>
-            <a:pPr lvl="4"/>
-            <a:r>
-              <a:rPr lang="en-US"/>
-              <a:t>Fifth level</a:t>
-            </a:r>
-          </a:p>
-        </p:txBody>
-      </p:sp>
-      <p:sp>
-        <p:nvSpPr>
-          <p:cNvPr id="6" name="Footer Placeholder 5"/>
-          <p:cNvSpPr>
-            <a:spLocks noGrp="1"/>
-          </p:cNvSpPr>
-          <p:nvPr>
-            <p:ph type="ftr" sz="quarter" idx="4"/>
-          </p:nvPr>
-        </p:nvSpPr>
-        <p:spPr>
-          <a:xfrm>
-            <a:off x="0" y="8685213"/>
-            <a:ext cx="2971800" cy="458787"/>
-          </a:xfrm>
-          <a:prstGeom prst="rect">
-            <a:avLst/>
-          </a:prstGeom>
-        </p:spPr>
-        <p:txBody>
-          <a:bodyPr vert="horz" lIns="91440" tIns="45720" rIns="91440" bIns="45720" rtlCol="0" anchor="b"/>
-          <a:lstStyle>
-            <a:lvl1pPr algn="l">
-              <a:defRPr sz="1200"/>
-            </a:lvl1pPr>
-          </a:lstStyle>
-          <a:p>
-            <a:endParaRPr lang="en-US"/>
-          </a:p>
-        </p:txBody>
-      </p:sp>
-      <p:sp>
-        <p:nvSpPr>
-          <p:cNvPr id="7" name="Slide Number Placeholder 6"/>
-          <p:cNvSpPr>
-            <a:spLocks noGrp="1"/>
-          </p:cNvSpPr>
-          <p:nvPr>
-            <p:ph type="sldNum" sz="quarter" idx="5"/>
-          </p:nvPr>
-        </p:nvSpPr>
-        <p:spPr>
-          <a:xfrm>
-            <a:off x="3884613" y="8685213"/>
-            <a:ext cx="2971800" cy="458787"/>
-          </a:xfrm>
-          <a:prstGeom prst="rect">
-            <a:avLst/>
-          </a:prstGeom>
-        </p:spPr>
-        <p:txBody>
-          <a:bodyPr vert="horz" lIns="91440" tIns="45720" rIns="91440" bIns="45720" rtlCol="0" anchor="b"/>
-          <a:lstStyle>
-            <a:lvl1pPr algn="r">
-              <a:defRPr sz="1200"/>
-            </a:lvl1pPr>
-          </a:lstStyle>
-          <a:p>
-            <a:fld id="{CE5E9CC1-C706-0F49-92D6-E571CC5EEA8F}" type="slidenum">
-              <a:rPr lang="en-US"/>
-              <a:t>‹#›</a:t>
-            </a:fld>
-            <a:endParaRPr lang="en-US"/>
-          </a:p>
-        </p:txBody>
-      </p:sp>
     </p:spTree>
     <p:extLst>
       <p:ext uri="{BB962C8B-B14F-4D97-AF65-F5344CB8AC3E}">
-        <p14:creationId xmlns:p14="http://schemas.microsoft.com/office/powerpoint/2010/main" val="1024086991"/>
+        <p14:creationId xmlns:p14="http://schemas.microsoft.com/office/powerpoint/2010/main" val="2707115110"/>
       </p:ext>
     </p:extLst>
   </p:cSld>
@@ -515,7 +296,6 @@
               <a:rPr lang="en-US" dirty="0"/>
               <a:t>Welcome. In 45 minutes we take one small Java web store from a laptop to Azure, add an AI assistant, and then look inside every answer. You only need a browser.</a:t>
             </a:r>
-            <a:endParaRPr lang="en-US" dirty="0"/>
           </a:p>
         </p:txBody>
       </p:sp>
@@ -603,7 +383,6 @@
               <a:rPr lang="en-US" dirty="0"/>
               <a:t>The model is the cheap part: a question costs less than a hundredth of a cent. The main fixed cost is the container registry. The model's per-minute limit also caps the worst case.</a:t>
             </a:r>
-            <a:endParaRPr lang="en-US" dirty="0"/>
           </a:p>
         </p:txBody>
       </p:sp>
@@ -691,7 +470,6 @@
               <a:rPr lang="en-US" dirty="0"/>
               <a:t>Go through the answers together. The details are in docs/workshop.md.</a:t>
             </a:r>
-            <a:endParaRPr lang="en-US" dirty="0"/>
           </a:p>
         </p:txBody>
       </p:sp>
@@ -779,7 +557,6 @@
               <a:rPr lang="en-US" dirty="0"/>
               <a:t>Run it, ship it, add AI, see inside it. To try it yourself, run azd up in any step folder, and azd down --purge when you're done.</a:t>
             </a:r>
-            <a:endParaRPr lang="en-US" dirty="0"/>
           </a:p>
         </p:txBody>
       </p:sp>
@@ -867,7 +644,6 @@
               <a:rPr lang="en-US" dirty="0"/>
               <a:t>One store, four steps. Each step is a folder in the repo, and each adds one idea: run it, ship it, add AI, and see inside it. The six products stay the same all the way through.</a:t>
             </a:r>
-            <a:endParaRPr lang="en-US" dirty="0"/>
           </a:p>
         </p:txBody>
       </p:sp>
@@ -955,7 +731,6 @@
               <a:rPr lang="en-US" dirty="0"/>
               <a:t>Everything runs in your browser: read the code on GitHub and try the live apps. For each step: look at the diagram, read the code, try the app, then answer the Find questions. We check the answers at the end.</a:t>
             </a:r>
-            <a:endParaRPr lang="en-US" dirty="0"/>
           </a:p>
         </p:txBody>
       </p:sp>
@@ -1043,7 +818,6 @@
               <a:rPr lang="en-US" dirty="0"/>
               <a:t>Follow the numbers: the browser asks for the page, the controller gets six products from the catalog and fills in the page. It works, but only on my laptop. Nobody else can use it, and I start it by hand. Time: 7 minutes.</a:t>
             </a:r>
-            <a:endParaRPr lang="en-US" dirty="0"/>
           </a:p>
         </p:txBody>
       </p:sp>
@@ -1131,7 +905,6 @@
               <a:rPr lang="en-US" dirty="0"/>
               <a:t>The Java code didn't change. We added a Dockerfile to pack the app, azure.yaml to name it, and Bicep to describe the Azure resources. One command, azd up, creates all of this in about 5 minutes. The app pulls its image with its managed identity, so there's no password, and it scales to zero when nobody uses it. Time: 10 minutes.</a:t>
             </a:r>
-            <a:endParaRPr lang="en-US" dirty="0"/>
           </a:p>
         </p:txBody>
       </p:sp>
@@ -1219,7 +992,6 @@
               <a:rPr lang="en-US" dirty="0"/>
               <a:t>Follow the numbers: two calls to the model, and one call to our own Java code in between. The model can't see our catalog, so we give it a tool: one method with @Tool. There are no API keys: they're switched off in Foundry, and the app signs in with its managed identity. Time: 12 minutes for step 3, including the next slide.</a:t>
             </a:r>
-            <a:endParaRPr lang="en-US" dirty="0"/>
           </a:p>
         </p:txBody>
       </p:sp>
@@ -1307,7 +1079,6 @@
               <a:rPr lang="en-US" dirty="0"/>
               <a:t>Everyone: find the two files and answer the questions, then ask the store one question. The Summit jacket is out of stock, and the assistant says so, then suggests jackets that are in stock: real facts, not guesses. The poem question shows it stays on topic.</a:t>
             </a:r>
-            <a:endParaRPr lang="en-US" dirty="0"/>
           </a:p>
         </p:txBody>
       </p:sp>
@@ -1395,7 +1166,6 @@
               <a:rPr lang="en-US" dirty="0"/>
               <a:t>The app's code didn't change: one dependency, three settings, and Application Insights in Bicep. Container Apps tells the app where to send traces. Time: 8 minutes for step 4, including the next slide.</a:t>
             </a:r>
-            <a:endParaRPr lang="en-US" dirty="0"/>
           </a:p>
         </p:txBody>
       </p:sp>
@@ -1483,7 +1253,6 @@
               <a:rPr lang="en-US" dirty="0"/>
               <a:t>This is a real trace from step 4. Two model calls and one tool call. Here are the tokens, and here's the cost: less than a hundredth of a cent. The traces keep timings and token counts, not the questions or the answers.</a:t>
             </a:r>
-            <a:endParaRPr lang="en-US" dirty="0"/>
           </a:p>
         </p:txBody>
       </p:sp>
@@ -1556,6 +1325,11 @@
 <file path=ppt/slideMasters/slideMaster1.xml><?xml version="1.0" encoding="utf-8"?>
 <p:sldMaster xmlns:a="http://schemas.openxmlformats.org/drawingml/2006/main" xmlns:r="http://schemas.openxmlformats.org/officeDocument/2006/relationships" xmlns:p="http://schemas.openxmlformats.org/presentationml/2006/main">
   <p:cSld>
+    <p:bg>
+      <p:bgRef idx="1001">
+        <a:schemeClr val="bg1"/>
+      </p:bgRef>
+    </p:bg>
     <p:spTree>
       <p:nvGrpSpPr>
         <p:cNvPr id="1" name=""/>
@@ -1838,6 +1612,7 @@
         <a:solidFill>
           <a:srgbClr val="2E2A28"/>
         </a:solidFill>
+        <a:effectLst/>
       </p:bgPr>
     </p:bg>
     <p:spTree>
@@ -1875,11 +1650,11 @@
           <a:bodyPr wrap="square" lIns="0" tIns="0" rIns="0" bIns="0" rtlCol="0" anchor="ctr"/>
           <a:lstStyle/>
           <a:p>
-            <a:pPr indent="0" marL="0">
-              <a:buNone/>
-            </a:pPr>
-            <a:r>
-              <a:rPr lang="en-US" sz="1400" spc="400" kern="0" dirty="0">
+            <a:pPr marL="0" indent="0">
+              <a:buNone/>
+            </a:pPr>
+            <a:r>
+              <a:rPr lang="en-US" sz="1400" kern="0" spc="400" dirty="0">
                 <a:solidFill>
                   <a:srgbClr val="FD8EA1"/>
                 </a:solidFill>
@@ -1914,7 +1689,7 @@
           <a:bodyPr wrap="square" lIns="0" tIns="0" rIns="0" bIns="0" rtlCol="0" anchor="ctr"/>
           <a:lstStyle/>
           <a:p>
-            <a:pPr indent="0" marL="0">
+            <a:pPr marL="0" indent="0">
               <a:buNone/>
             </a:pPr>
             <a:r>
@@ -1953,7 +1728,7 @@
           <a:bodyPr wrap="square" lIns="0" tIns="0" rIns="0" bIns="0" rtlCol="0" anchor="t"/>
           <a:lstStyle/>
           <a:p>
-            <a:pPr indent="0" marL="0">
+            <a:pPr marL="0" indent="0">
               <a:buNone/>
             </a:pPr>
             <a:r>
@@ -1970,7 +1745,7 @@
             <a:endParaRPr lang="en-US" sz="2600" dirty="0"/>
           </a:p>
           <a:p>
-            <a:pPr indent="0" marL="0">
+            <a:pPr marL="0" indent="0">
               <a:buNone/>
             </a:pPr>
             <a:r>
@@ -2009,7 +1784,7 @@
           <a:bodyPr wrap="square" lIns="0" tIns="0" rIns="0" bIns="0" rtlCol="0" anchor="t"/>
           <a:lstStyle/>
           <a:p>
-            <a:pPr indent="0" marL="0">
+            <a:pPr marL="0" indent="0">
               <a:buNone/>
             </a:pPr>
             <a:r>
@@ -2026,7 +1801,7 @@
             <a:endParaRPr lang="en-US" sz="1500" dirty="0"/>
           </a:p>
           <a:p>
-            <a:pPr indent="0" marL="0">
+            <a:pPr marL="0" indent="0">
               <a:buNone/>
             </a:pPr>
             <a:r>
@@ -2065,7 +1840,7 @@
           <a:bodyPr wrap="square" lIns="0" tIns="0" rIns="0" bIns="0" rtlCol="0" anchor="ctr"/>
           <a:lstStyle/>
           <a:p>
-            <a:pPr indent="0" marL="0">
+            <a:pPr marL="0" indent="0">
               <a:buNone/>
             </a:pPr>
             <a:r>
@@ -2107,24 +1882,31 @@
             <a:prstDash val="solid"/>
           </a:ln>
           <a:effectLst>
-            <a:outerShdw sx="100000" sy="100000" kx="0" ky="0" algn="bl" rotWithShape="0" blurRad="228600" dist="76200" dir="5400000">
+            <a:outerShdw blurRad="228600" dist="76200" dir="5400000" algn="bl" rotWithShape="0">
               <a:srgbClr val="000000">
                 <a:alpha val="35000"/>
               </a:srgbClr>
             </a:outerShdw>
           </a:effectLst>
         </p:spPr>
+        <p:txBody>
+          <a:bodyPr/>
+          <a:lstStyle/>
+          <a:p>
+            <a:endParaRPr lang="en-ZA"/>
+          </a:p>
+        </p:txBody>
       </p:sp>
       <p:pic>
         <p:nvPicPr>
-          <p:cNvPr id="8" name="Image 0" descr="The Trail Store page, with the AI assistant answering a question">    </p:cNvPr>
+          <p:cNvPr id="8" name="Image 0" descr="The Trail Store page, with the AI assistant answering a question"/>
           <p:cNvPicPr>
             <a:picLocks noChangeAspect="1"/>
           </p:cNvPicPr>
           <p:nvPr/>
         </p:nvPicPr>
         <p:blipFill>
-          <a:blip r:embed="rId1"/>
+          <a:blip r:embed="rId3"/>
           <a:stretch>
             <a:fillRect/>
           </a:stretch>
@@ -2155,6 +1937,7 @@
         <a:solidFill>
           <a:srgbClr val="F7F4EF"/>
         </a:solidFill>
+        <a:effectLst/>
       </p:bgPr>
     </p:bg>
     <p:spTree>
@@ -2192,7 +1975,7 @@
           <a:bodyPr wrap="square" lIns="0" tIns="0" rIns="0" bIns="0" rtlCol="0" anchor="ctr"/>
           <a:lstStyle/>
           <a:p>
-            <a:pPr indent="0" marL="0">
+            <a:pPr marL="0" indent="0">
               <a:buNone/>
             </a:pPr>
             <a:r>
@@ -2234,13 +2017,20 @@
             <a:prstDash val="solid"/>
           </a:ln>
           <a:effectLst>
-            <a:outerShdw sx="100000" sy="100000" kx="0" ky="0" algn="bl" rotWithShape="0" blurRad="101600" dist="25400" dir="5400000">
+            <a:outerShdw blurRad="101600" dist="25400" dir="5400000" algn="bl" rotWithShape="0">
               <a:srgbClr val="000000">
                 <a:alpha val="12000"/>
               </a:srgbClr>
             </a:outerShdw>
           </a:effectLst>
         </p:spPr>
+        <p:txBody>
+          <a:bodyPr/>
+          <a:lstStyle/>
+          <a:p>
+            <a:endParaRPr lang="en-ZA"/>
+          </a:p>
+        </p:txBody>
       </p:sp>
       <p:sp>
         <p:nvSpPr>
@@ -2266,6 +2056,13 @@
             <a:prstDash val="solid"/>
           </a:ln>
         </p:spPr>
+        <p:txBody>
+          <a:bodyPr/>
+          <a:lstStyle/>
+          <a:p>
+            <a:endParaRPr lang="en-ZA"/>
+          </a:p>
+        </p:txBody>
       </p:sp>
       <p:sp>
         <p:nvSpPr>
@@ -2288,7 +2085,7 @@
           <a:bodyPr wrap="square" lIns="0" tIns="0" rIns="0" bIns="0" rtlCol="0" anchor="ctr"/>
           <a:lstStyle/>
           <a:p>
-            <a:pPr indent="0" marL="0">
+            <a:pPr marL="0" indent="0">
               <a:buNone/>
             </a:pPr>
             <a:r>
@@ -2327,7 +2124,7 @@
           <a:bodyPr wrap="square" lIns="0" tIns="0" rIns="0" bIns="0" rtlCol="0" anchor="ctr"/>
           <a:lstStyle/>
           <a:p>
-            <a:pPr indent="0" marL="0">
+            <a:pPr marL="0" indent="0">
               <a:buNone/>
             </a:pPr>
             <a:r>
@@ -2366,7 +2163,7 @@
           <a:bodyPr wrap="square" lIns="0" tIns="0" rIns="0" bIns="0" rtlCol="0" anchor="t"/>
           <a:lstStyle/>
           <a:p>
-            <a:pPr indent="0" marL="0">
+            <a:pPr marL="0" indent="0">
               <a:buNone/>
             </a:pPr>
             <a:r>
@@ -2408,13 +2205,20 @@
             <a:prstDash val="solid"/>
           </a:ln>
           <a:effectLst>
-            <a:outerShdw sx="100000" sy="100000" kx="0" ky="0" algn="bl" rotWithShape="0" blurRad="101600" dist="25400" dir="5400000">
+            <a:outerShdw blurRad="101600" dist="25400" dir="5400000" algn="bl" rotWithShape="0">
               <a:srgbClr val="000000">
                 <a:alpha val="12000"/>
               </a:srgbClr>
             </a:outerShdw>
           </a:effectLst>
         </p:spPr>
+        <p:txBody>
+          <a:bodyPr/>
+          <a:lstStyle/>
+          <a:p>
+            <a:endParaRPr lang="en-ZA"/>
+          </a:p>
+        </p:txBody>
       </p:sp>
       <p:sp>
         <p:nvSpPr>
@@ -2440,6 +2244,13 @@
             <a:prstDash val="solid"/>
           </a:ln>
         </p:spPr>
+        <p:txBody>
+          <a:bodyPr/>
+          <a:lstStyle/>
+          <a:p>
+            <a:endParaRPr lang="en-ZA"/>
+          </a:p>
+        </p:txBody>
       </p:sp>
       <p:sp>
         <p:nvSpPr>
@@ -2462,7 +2273,7 @@
           <a:bodyPr wrap="square" lIns="0" tIns="0" rIns="0" bIns="0" rtlCol="0" anchor="ctr"/>
           <a:lstStyle/>
           <a:p>
-            <a:pPr indent="0" marL="0">
+            <a:pPr marL="0" indent="0">
               <a:buNone/>
             </a:pPr>
             <a:r>
@@ -2501,7 +2312,7 @@
           <a:bodyPr wrap="square" lIns="0" tIns="0" rIns="0" bIns="0" rtlCol="0" anchor="ctr"/>
           <a:lstStyle/>
           <a:p>
-            <a:pPr indent="0" marL="0">
+            <a:pPr marL="0" indent="0">
               <a:buNone/>
             </a:pPr>
             <a:r>
@@ -2540,7 +2351,7 @@
           <a:bodyPr wrap="square" lIns="0" tIns="0" rIns="0" bIns="0" rtlCol="0" anchor="t"/>
           <a:lstStyle/>
           <a:p>
-            <a:pPr indent="0" marL="0">
+            <a:pPr marL="0" indent="0">
               <a:buNone/>
             </a:pPr>
             <a:r>
@@ -2582,13 +2393,20 @@
             <a:prstDash val="solid"/>
           </a:ln>
           <a:effectLst>
-            <a:outerShdw sx="100000" sy="100000" kx="0" ky="0" algn="bl" rotWithShape="0" blurRad="101600" dist="25400" dir="5400000">
+            <a:outerShdw blurRad="101600" dist="25400" dir="5400000" algn="bl" rotWithShape="0">
               <a:srgbClr val="000000">
                 <a:alpha val="12000"/>
               </a:srgbClr>
             </a:outerShdw>
           </a:effectLst>
         </p:spPr>
+        <p:txBody>
+          <a:bodyPr/>
+          <a:lstStyle/>
+          <a:p>
+            <a:endParaRPr lang="en-ZA"/>
+          </a:p>
+        </p:txBody>
       </p:sp>
       <p:sp>
         <p:nvSpPr>
@@ -2614,6 +2432,13 @@
             <a:prstDash val="solid"/>
           </a:ln>
         </p:spPr>
+        <p:txBody>
+          <a:bodyPr/>
+          <a:lstStyle/>
+          <a:p>
+            <a:endParaRPr lang="en-ZA"/>
+          </a:p>
+        </p:txBody>
       </p:sp>
       <p:sp>
         <p:nvSpPr>
@@ -2636,7 +2461,7 @@
           <a:bodyPr wrap="square" lIns="0" tIns="0" rIns="0" bIns="0" rtlCol="0" anchor="ctr"/>
           <a:lstStyle/>
           <a:p>
-            <a:pPr indent="0" marL="0">
+            <a:pPr marL="0" indent="0">
               <a:buNone/>
             </a:pPr>
             <a:r>
@@ -2675,7 +2500,7 @@
           <a:bodyPr wrap="square" lIns="0" tIns="0" rIns="0" bIns="0" rtlCol="0" anchor="ctr"/>
           <a:lstStyle/>
           <a:p>
-            <a:pPr indent="0" marL="0">
+            <a:pPr marL="0" indent="0">
               <a:buNone/>
             </a:pPr>
             <a:r>
@@ -2714,7 +2539,7 @@
           <a:bodyPr wrap="square" lIns="0" tIns="0" rIns="0" bIns="0" rtlCol="0" anchor="t"/>
           <a:lstStyle/>
           <a:p>
-            <a:pPr indent="0" marL="0">
+            <a:pPr marL="0" indent="0">
               <a:buNone/>
             </a:pPr>
             <a:r>
@@ -2756,13 +2581,20 @@
             <a:prstDash val="solid"/>
           </a:ln>
           <a:effectLst>
-            <a:outerShdw sx="100000" sy="100000" kx="0" ky="0" algn="bl" rotWithShape="0" blurRad="101600" dist="25400" dir="5400000">
+            <a:outerShdw blurRad="101600" dist="25400" dir="5400000" algn="bl" rotWithShape="0">
               <a:srgbClr val="000000">
                 <a:alpha val="12000"/>
               </a:srgbClr>
             </a:outerShdw>
           </a:effectLst>
         </p:spPr>
+        <p:txBody>
+          <a:bodyPr/>
+          <a:lstStyle/>
+          <a:p>
+            <a:endParaRPr lang="en-ZA"/>
+          </a:p>
+        </p:txBody>
       </p:sp>
       <p:sp>
         <p:nvSpPr>
@@ -2788,6 +2620,13 @@
             <a:prstDash val="solid"/>
           </a:ln>
         </p:spPr>
+        <p:txBody>
+          <a:bodyPr/>
+          <a:lstStyle/>
+          <a:p>
+            <a:endParaRPr lang="en-ZA"/>
+          </a:p>
+        </p:txBody>
       </p:sp>
       <p:sp>
         <p:nvSpPr>
@@ -2810,7 +2649,7 @@
           <a:bodyPr wrap="square" lIns="0" tIns="0" rIns="0" bIns="0" rtlCol="0" anchor="ctr"/>
           <a:lstStyle/>
           <a:p>
-            <a:pPr indent="0" marL="0">
+            <a:pPr marL="0" indent="0">
               <a:buNone/>
             </a:pPr>
             <a:r>
@@ -2849,7 +2688,7 @@
           <a:bodyPr wrap="square" lIns="0" tIns="0" rIns="0" bIns="0" rtlCol="0" anchor="ctr"/>
           <a:lstStyle/>
           <a:p>
-            <a:pPr indent="0" marL="0">
+            <a:pPr marL="0" indent="0">
               <a:buNone/>
             </a:pPr>
             <a:r>
@@ -2888,7 +2727,7 @@
           <a:bodyPr wrap="square" lIns="0" tIns="0" rIns="0" bIns="0" rtlCol="0" anchor="t"/>
           <a:lstStyle/>
           <a:p>
-            <a:pPr indent="0" marL="0">
+            <a:pPr marL="0" indent="0">
               <a:buNone/>
             </a:pPr>
             <a:r>
@@ -2927,7 +2766,7 @@
           <a:bodyPr wrap="square" lIns="0" tIns="0" rIns="0" bIns="0" rtlCol="0" anchor="t"/>
           <a:lstStyle/>
           <a:p>
-            <a:pPr indent="0" marL="0">
+            <a:pPr marL="0" indent="0">
               <a:buNone/>
             </a:pPr>
             <a:r>
@@ -2944,7 +2783,7 @@
             <a:endParaRPr lang="en-US" sz="1200" dirty="0"/>
           </a:p>
           <a:p>
-            <a:pPr indent="0" marL="0">
+            <a:pPr marL="0" indent="0">
               <a:buNone/>
             </a:pPr>
             <a:r>
@@ -2978,6 +2817,7 @@
         <a:solidFill>
           <a:srgbClr val="F7F4EF"/>
         </a:solidFill>
+        <a:effectLst/>
       </p:bgPr>
     </p:bg>
     <p:spTree>
@@ -3015,7 +2855,7 @@
           <a:bodyPr wrap="square" lIns="0" tIns="0" rIns="0" bIns="0" rtlCol="0" anchor="ctr"/>
           <a:lstStyle/>
           <a:p>
-            <a:pPr indent="0" marL="0">
+            <a:pPr marL="0" indent="0">
               <a:buNone/>
             </a:pPr>
             <a:r>
@@ -3057,13 +2897,20 @@
             <a:prstDash val="solid"/>
           </a:ln>
           <a:effectLst>
-            <a:outerShdw sx="100000" sy="100000" kx="0" ky="0" algn="bl" rotWithShape="0" blurRad="101600" dist="25400" dir="5400000">
+            <a:outerShdw blurRad="101600" dist="25400" dir="5400000" algn="bl" rotWithShape="0">
               <a:srgbClr val="000000">
                 <a:alpha val="12000"/>
               </a:srgbClr>
             </a:outerShdw>
           </a:effectLst>
         </p:spPr>
+        <p:txBody>
+          <a:bodyPr/>
+          <a:lstStyle/>
+          <a:p>
+            <a:endParaRPr lang="en-ZA"/>
+          </a:p>
+        </p:txBody>
       </p:sp>
       <p:sp>
         <p:nvSpPr>
@@ -3089,6 +2936,13 @@
             <a:prstDash val="solid"/>
           </a:ln>
         </p:spPr>
+        <p:txBody>
+          <a:bodyPr/>
+          <a:lstStyle/>
+          <a:p>
+            <a:endParaRPr lang="en-ZA"/>
+          </a:p>
+        </p:txBody>
       </p:sp>
       <p:sp>
         <p:nvSpPr>
@@ -3111,11 +2965,11 @@
           <a:bodyPr wrap="square" lIns="0" tIns="0" rIns="0" bIns="0" rtlCol="0" anchor="ctr"/>
           <a:lstStyle/>
           <a:p>
-            <a:pPr indent="0" marL="0">
-              <a:buNone/>
-            </a:pPr>
-            <a:r>
-              <a:rPr lang="en-US" sz="1300" spc="300" kern="0" dirty="0">
+            <a:pPr marL="0" indent="0">
+              <a:buNone/>
+            </a:pPr>
+            <a:r>
+              <a:rPr lang="en-US" sz="1300" kern="0" spc="300" dirty="0">
                 <a:solidFill>
                   <a:srgbClr val="B11F4B"/>
                 </a:solidFill>
@@ -3150,7 +3004,7 @@
           <a:bodyPr wrap="square" lIns="0" tIns="0" rIns="0" bIns="0" rtlCol="0" anchor="t"/>
           <a:lstStyle/>
           <a:p>
-            <a:pPr indent="0" marL="0">
+            <a:pPr marL="0" indent="0">
               <a:buNone/>
             </a:pPr>
             <a:r>
@@ -3167,7 +3021,7 @@
             <a:endParaRPr lang="en-US" sz="1500" dirty="0"/>
           </a:p>
           <a:p>
-            <a:pPr indent="0" marL="0">
+            <a:pPr marL="0" indent="0">
               <a:buNone/>
             </a:pPr>
             <a:r>
@@ -3206,7 +3060,7 @@
           <a:bodyPr wrap="square" lIns="0" tIns="0" rIns="0" bIns="0" rtlCol="0" anchor="t"/>
           <a:lstStyle/>
           <a:p>
-            <a:pPr indent="0" marL="0">
+            <a:pPr marL="0" indent="0">
               <a:buNone/>
             </a:pPr>
             <a:r>
@@ -3248,13 +3102,20 @@
             <a:prstDash val="solid"/>
           </a:ln>
           <a:effectLst>
-            <a:outerShdw sx="100000" sy="100000" kx="0" ky="0" algn="bl" rotWithShape="0" blurRad="101600" dist="25400" dir="5400000">
+            <a:outerShdw blurRad="101600" dist="25400" dir="5400000" algn="bl" rotWithShape="0">
               <a:srgbClr val="000000">
                 <a:alpha val="12000"/>
               </a:srgbClr>
             </a:outerShdw>
           </a:effectLst>
         </p:spPr>
+        <p:txBody>
+          <a:bodyPr/>
+          <a:lstStyle/>
+          <a:p>
+            <a:endParaRPr lang="en-ZA"/>
+          </a:p>
+        </p:txBody>
       </p:sp>
       <p:sp>
         <p:nvSpPr>
@@ -3280,6 +3141,13 @@
             <a:prstDash val="solid"/>
           </a:ln>
         </p:spPr>
+        <p:txBody>
+          <a:bodyPr/>
+          <a:lstStyle/>
+          <a:p>
+            <a:endParaRPr lang="en-ZA"/>
+          </a:p>
+        </p:txBody>
       </p:sp>
       <p:sp>
         <p:nvSpPr>
@@ -3302,11 +3170,11 @@
           <a:bodyPr wrap="square" lIns="0" tIns="0" rIns="0" bIns="0" rtlCol="0" anchor="ctr"/>
           <a:lstStyle/>
           <a:p>
-            <a:pPr indent="0" marL="0">
-              <a:buNone/>
-            </a:pPr>
-            <a:r>
-              <a:rPr lang="en-US" sz="1300" spc="300" kern="0" dirty="0">
+            <a:pPr marL="0" indent="0">
+              <a:buNone/>
+            </a:pPr>
+            <a:r>
+              <a:rPr lang="en-US" sz="1300" kern="0" spc="300" dirty="0">
                 <a:solidFill>
                   <a:srgbClr val="005A9E"/>
                 </a:solidFill>
@@ -3341,7 +3209,7 @@
           <a:bodyPr wrap="square" lIns="0" tIns="0" rIns="0" bIns="0" rtlCol="0" anchor="t"/>
           <a:lstStyle/>
           <a:p>
-            <a:pPr indent="0" marL="0">
+            <a:pPr marL="0" indent="0">
               <a:buNone/>
             </a:pPr>
             <a:r>
@@ -3358,7 +3226,7 @@
             <a:endParaRPr lang="en-US" sz="1500" dirty="0"/>
           </a:p>
           <a:p>
-            <a:pPr indent="0" marL="0">
+            <a:pPr marL="0" indent="0">
               <a:buNone/>
             </a:pPr>
             <a:r>
@@ -3397,7 +3265,7 @@
           <a:bodyPr wrap="square" lIns="0" tIns="0" rIns="0" bIns="0" rtlCol="0" anchor="t"/>
           <a:lstStyle/>
           <a:p>
-            <a:pPr indent="0" marL="0">
+            <a:pPr marL="0" indent="0">
               <a:buNone/>
             </a:pPr>
             <a:r>
@@ -3411,9 +3279,6 @@
               </a:rPr>
               <a:t>minReplicas: 0</a:t>
             </a:r>
-            <a:pPr indent="0" marL="0">
-              <a:buNone/>
-            </a:pPr>
             <a:r>
               <a:rPr lang="en-US" sz="1500" dirty="0">
                 <a:solidFill>
@@ -3453,13 +3318,20 @@
             <a:prstDash val="solid"/>
           </a:ln>
           <a:effectLst>
-            <a:outerShdw sx="100000" sy="100000" kx="0" ky="0" algn="bl" rotWithShape="0" blurRad="101600" dist="25400" dir="5400000">
+            <a:outerShdw blurRad="101600" dist="25400" dir="5400000" algn="bl" rotWithShape="0">
               <a:srgbClr val="000000">
                 <a:alpha val="12000"/>
               </a:srgbClr>
             </a:outerShdw>
           </a:effectLst>
         </p:spPr>
+        <p:txBody>
+          <a:bodyPr/>
+          <a:lstStyle/>
+          <a:p>
+            <a:endParaRPr lang="en-ZA"/>
+          </a:p>
+        </p:txBody>
       </p:sp>
       <p:sp>
         <p:nvSpPr>
@@ -3485,6 +3357,13 @@
             <a:prstDash val="solid"/>
           </a:ln>
         </p:spPr>
+        <p:txBody>
+          <a:bodyPr/>
+          <a:lstStyle/>
+          <a:p>
+            <a:endParaRPr lang="en-ZA"/>
+          </a:p>
+        </p:txBody>
       </p:sp>
       <p:sp>
         <p:nvSpPr>
@@ -3507,11 +3386,11 @@
           <a:bodyPr wrap="square" lIns="0" tIns="0" rIns="0" bIns="0" rtlCol="0" anchor="ctr"/>
           <a:lstStyle/>
           <a:p>
-            <a:pPr indent="0" marL="0">
-              <a:buNone/>
-            </a:pPr>
-            <a:r>
-              <a:rPr lang="en-US" sz="1300" spc="300" kern="0" dirty="0">
+            <a:pPr marL="0" indent="0">
+              <a:buNone/>
+            </a:pPr>
+            <a:r>
+              <a:rPr lang="en-US" sz="1300" kern="0" spc="300" dirty="0">
                 <a:solidFill>
                   <a:srgbClr val="5C2D91"/>
                 </a:solidFill>
@@ -3546,7 +3425,7 @@
           <a:bodyPr wrap="square" lIns="0" tIns="0" rIns="0" bIns="0" rtlCol="0" anchor="t"/>
           <a:lstStyle/>
           <a:p>
-            <a:pPr indent="0" marL="0">
+            <a:pPr marL="0" indent="0">
               <a:buNone/>
             </a:pPr>
             <a:r>
@@ -3563,7 +3442,7 @@
             <a:endParaRPr lang="en-US" sz="1500" dirty="0"/>
           </a:p>
           <a:p>
-            <a:pPr indent="0" marL="0">
+            <a:pPr marL="0" indent="0">
               <a:buNone/>
             </a:pPr>
             <a:r>
@@ -3602,7 +3481,7 @@
           <a:bodyPr wrap="square" lIns="0" tIns="0" rIns="0" bIns="0" rtlCol="0" anchor="t"/>
           <a:lstStyle/>
           <a:p>
-            <a:pPr indent="0" marL="0">
+            <a:pPr marL="0" indent="0">
               <a:buNone/>
             </a:pPr>
             <a:r>
@@ -3616,9 +3495,6 @@
               </a:rPr>
               <a:t>The managed identity has the Foundry User role. Keys are off: </a:t>
             </a:r>
-            <a:pPr indent="0" marL="0">
-              <a:buNone/>
-            </a:pPr>
             <a:r>
               <a:rPr lang="en-US" sz="1500" dirty="0">
                 <a:solidFill>
@@ -3630,9 +3506,6 @@
               </a:rPr>
               <a:t>disableLocalAuth: true</a:t>
             </a:r>
-            <a:pPr indent="0" marL="0">
-              <a:buNone/>
-            </a:pPr>
             <a:r>
               <a:rPr lang="en-US" sz="1500" dirty="0">
                 <a:solidFill>
@@ -3672,13 +3545,20 @@
             <a:prstDash val="solid"/>
           </a:ln>
           <a:effectLst>
-            <a:outerShdw sx="100000" sy="100000" kx="0" ky="0" algn="bl" rotWithShape="0" blurRad="101600" dist="25400" dir="5400000">
+            <a:outerShdw blurRad="101600" dist="25400" dir="5400000" algn="bl" rotWithShape="0">
               <a:srgbClr val="000000">
                 <a:alpha val="12000"/>
               </a:srgbClr>
             </a:outerShdw>
           </a:effectLst>
         </p:spPr>
+        <p:txBody>
+          <a:bodyPr/>
+          <a:lstStyle/>
+          <a:p>
+            <a:endParaRPr lang="en-ZA"/>
+          </a:p>
+        </p:txBody>
       </p:sp>
       <p:sp>
         <p:nvSpPr>
@@ -3704,6 +3584,13 @@
             <a:prstDash val="solid"/>
           </a:ln>
         </p:spPr>
+        <p:txBody>
+          <a:bodyPr/>
+          <a:lstStyle/>
+          <a:p>
+            <a:endParaRPr lang="en-ZA"/>
+          </a:p>
+        </p:txBody>
       </p:sp>
       <p:sp>
         <p:nvSpPr>
@@ -3726,11 +3613,11 @@
           <a:bodyPr wrap="square" lIns="0" tIns="0" rIns="0" bIns="0" rtlCol="0" anchor="ctr"/>
           <a:lstStyle/>
           <a:p>
-            <a:pPr indent="0" marL="0">
-              <a:buNone/>
-            </a:pPr>
-            <a:r>
-              <a:rPr lang="en-US" sz="1300" spc="300" kern="0" dirty="0">
+            <a:pPr marL="0" indent="0">
+              <a:buNone/>
+            </a:pPr>
+            <a:r>
+              <a:rPr lang="en-US" sz="1300" kern="0" spc="300" dirty="0">
                 <a:solidFill>
                   <a:srgbClr val="107C10"/>
                 </a:solidFill>
@@ -3765,7 +3652,7 @@
           <a:bodyPr wrap="square" lIns="0" tIns="0" rIns="0" bIns="0" rtlCol="0" anchor="t"/>
           <a:lstStyle/>
           <a:p>
-            <a:pPr indent="0" marL="0">
+            <a:pPr marL="0" indent="0">
               <a:buNone/>
             </a:pPr>
             <a:r>
@@ -3782,7 +3669,7 @@
             <a:endParaRPr lang="en-US" sz="1500" dirty="0"/>
           </a:p>
           <a:p>
-            <a:pPr indent="0" marL="0">
+            <a:pPr marL="0" indent="0">
               <a:buNone/>
             </a:pPr>
             <a:r>
@@ -3821,7 +3708,7 @@
           <a:bodyPr wrap="square" lIns="0" tIns="0" rIns="0" bIns="0" rtlCol="0" anchor="t"/>
           <a:lstStyle/>
           <a:p>
-            <a:pPr indent="0" marL="0">
+            <a:pPr marL="0" indent="0">
               <a:buNone/>
             </a:pPr>
             <a:r>
@@ -3835,9 +3722,6 @@
               </a:rPr>
               <a:t>Two: it asks for </a:t>
             </a:r>
-            <a:pPr indent="0" marL="0">
-              <a:buNone/>
-            </a:pPr>
             <a:r>
               <a:rPr lang="en-US" sz="1500" dirty="0">
                 <a:solidFill>
@@ -3849,9 +3733,6 @@
               </a:rPr>
               <a:t>listProducts</a:t>
             </a:r>
-            <a:pPr indent="0" marL="0">
-              <a:buNone/>
-            </a:pPr>
             <a:r>
               <a:rPr lang="en-US" sz="1500" dirty="0">
                 <a:solidFill>
@@ -3883,6 +3764,7 @@
         <a:solidFill>
           <a:srgbClr val="2E2A28"/>
         </a:solidFill>
+        <a:effectLst/>
       </p:bgPr>
     </p:bg>
     <p:spTree>
@@ -3920,7 +3802,7 @@
           <a:bodyPr wrap="square" lIns="0" tIns="0" rIns="0" bIns="0" rtlCol="0" anchor="ctr"/>
           <a:lstStyle/>
           <a:p>
-            <a:pPr indent="0" marL="0">
+            <a:pPr marL="0" indent="0">
               <a:buNone/>
             </a:pPr>
             <a:r>
@@ -3959,7 +3841,7 @@
           <a:bodyPr wrap="square" lIns="0" tIns="0" rIns="0" bIns="0" rtlCol="0" anchor="ctr"/>
           <a:lstStyle/>
           <a:p>
-            <a:pPr indent="0" marL="0">
+            <a:pPr marL="0" indent="0">
               <a:buNone/>
             </a:pPr>
             <a:r>
@@ -4001,6 +3883,13 @@
             <a:prstDash val="solid"/>
           </a:ln>
         </p:spPr>
+        <p:txBody>
+          <a:bodyPr/>
+          <a:lstStyle/>
+          <a:p>
+            <a:endParaRPr lang="en-ZA"/>
+          </a:p>
+        </p:txBody>
       </p:sp>
       <p:sp>
         <p:nvSpPr>
@@ -4023,7 +3912,7 @@
           <a:bodyPr wrap="square" lIns="0" tIns="0" rIns="0" bIns="0" rtlCol="0" anchor="ctr"/>
           <a:lstStyle/>
           <a:p>
-            <a:pPr indent="0" marL="0">
+            <a:pPr marL="0" indent="0">
               <a:spcAft>
                 <a:spcPts val="400"/>
               </a:spcAft>
@@ -4043,7 +3932,7 @@
             <a:endParaRPr lang="en-US" sz="1600" dirty="0"/>
           </a:p>
           <a:p>
-            <a:pPr indent="0" marL="0">
+            <a:pPr marL="0" indent="0">
               <a:spcAft>
                 <a:spcPts val="400"/>
               </a:spcAft>
@@ -4063,7 +3952,7 @@
             <a:endParaRPr lang="en-US" sz="1600" dirty="0"/>
           </a:p>
           <a:p>
-            <a:pPr indent="0" marL="0">
+            <a:pPr marL="0" indent="0">
               <a:spcAft>
                 <a:spcPts val="400"/>
               </a:spcAft>
@@ -4083,7 +3972,7 @@
             <a:endParaRPr lang="en-US" sz="1600" dirty="0"/>
           </a:p>
           <a:p>
-            <a:pPr indent="0" marL="0">
+            <a:pPr marL="0" indent="0">
               <a:spcAft>
                 <a:spcPts val="400"/>
               </a:spcAft>
@@ -4103,7 +3992,7 @@
             <a:endParaRPr lang="en-US" sz="1600" dirty="0"/>
           </a:p>
           <a:p>
-            <a:pPr indent="0" marL="0">
+            <a:pPr marL="0" indent="0">
               <a:spcAft>
                 <a:spcPts val="400"/>
               </a:spcAft>
@@ -4120,12 +4009,6 @@
               </a:rPr>
               <a:t>azd down --purge</a:t>
             </a:r>
-            <a:pPr indent="0" marL="0">
-              <a:spcAft>
-                <a:spcPts val="400"/>
-              </a:spcAft>
-              <a:buNone/>
-            </a:pPr>
             <a:r>
               <a:rPr lang="en-US" sz="1600" dirty="0">
                 <a:solidFill>
@@ -4162,7 +4045,7 @@
           <a:bodyPr wrap="square" lIns="0" tIns="0" rIns="0" bIns="0" rtlCol="0" anchor="t"/>
           <a:lstStyle/>
           <a:p>
-            <a:pPr indent="0" marL="0">
+            <a:pPr marL="0" indent="0">
               <a:buNone/>
             </a:pPr>
             <a:r>
@@ -4201,7 +4084,7 @@
           <a:bodyPr wrap="square" lIns="0" tIns="0" rIns="0" bIns="0" rtlCol="0" anchor="t"/>
           <a:lstStyle/>
           <a:p>
-            <a:pPr indent="0" marL="0">
+            <a:pPr marL="0" indent="0">
               <a:buNone/>
             </a:pPr>
             <a:r>
@@ -4240,7 +4123,7 @@
           <a:bodyPr wrap="square" lIns="0" tIns="0" rIns="0" bIns="0" rtlCol="0" anchor="ctr"/>
           <a:lstStyle/>
           <a:p>
-            <a:pPr indent="0" marL="0">
+            <a:pPr marL="0" indent="0">
               <a:buNone/>
             </a:pPr>
             <a:r>
@@ -4274,6 +4157,7 @@
         <a:solidFill>
           <a:srgbClr val="F7F4EF"/>
         </a:solidFill>
+        <a:effectLst/>
       </p:bgPr>
     </p:bg>
     <p:spTree>
@@ -4311,7 +4195,7 @@
           <a:bodyPr wrap="square" lIns="0" tIns="0" rIns="0" bIns="0" rtlCol="0" anchor="ctr"/>
           <a:lstStyle/>
           <a:p>
-            <a:pPr indent="0" marL="0">
+            <a:pPr marL="0" indent="0">
               <a:buNone/>
             </a:pPr>
             <a:r>
@@ -4350,7 +4234,7 @@
           <a:bodyPr wrap="square" lIns="0" tIns="0" rIns="0" bIns="0" rtlCol="0" anchor="ctr"/>
           <a:lstStyle/>
           <a:p>
-            <a:pPr indent="0" marL="0">
+            <a:pPr marL="0" indent="0">
               <a:buNone/>
             </a:pPr>
             <a:r>
@@ -4370,14 +4254,14 @@
       </p:sp>
       <p:pic>
         <p:nvPicPr>
-          <p:cNvPr id="4" name="Image 0" descr="The four steps: 1, run it on your laptop; 2, ship it to Azure with azd up; 3, add an AI assistant with Microsoft Foundry; 4, see inside with OpenTelemetry">    </p:cNvPr>
+          <p:cNvPr id="4" name="Image 0" descr="The four steps: 1, run it on your laptop; 2, ship it to Azure with azd up; 3, add an AI assistant with Microsoft Foundry; 4, see inside with OpenTelemetry"/>
           <p:cNvPicPr>
             <a:picLocks noChangeAspect="1"/>
           </p:cNvPicPr>
           <p:nvPr/>
         </p:nvPicPr>
         <p:blipFill>
-          <a:blip r:embed="rId1"/>
+          <a:blip r:embed="rId3"/>
           <a:stretch>
             <a:fillRect/>
           </a:stretch>
@@ -4408,6 +4292,7 @@
         <a:solidFill>
           <a:srgbClr val="F7F4EF"/>
         </a:solidFill>
+        <a:effectLst/>
       </p:bgPr>
     </p:bg>
     <p:spTree>
@@ -4445,7 +4330,7 @@
           <a:bodyPr wrap="square" lIns="0" tIns="0" rIns="0" bIns="0" rtlCol="0" anchor="ctr"/>
           <a:lstStyle/>
           <a:p>
-            <a:pPr indent="0" marL="0">
+            <a:pPr marL="0" indent="0">
               <a:buNone/>
             </a:pPr>
             <a:r>
@@ -4487,6 +4372,13 @@
             <a:prstDash val="solid"/>
           </a:ln>
         </p:spPr>
+        <p:txBody>
+          <a:bodyPr/>
+          <a:lstStyle/>
+          <a:p>
+            <a:endParaRPr lang="en-ZA"/>
+          </a:p>
+        </p:txBody>
       </p:sp>
       <p:sp>
         <p:nvSpPr>
@@ -4509,7 +4401,7 @@
           <a:bodyPr wrap="square" lIns="0" tIns="0" rIns="0" bIns="0" rtlCol="0" anchor="ctr"/>
           <a:lstStyle/>
           <a:p>
-            <a:pPr algn="ctr" indent="0" marL="0">
+            <a:pPr marL="0" indent="0" algn="ctr">
               <a:buNone/>
             </a:pPr>
             <a:r>
@@ -4548,7 +4440,7 @@
           <a:bodyPr wrap="square" lIns="0" tIns="0" rIns="0" bIns="0" rtlCol="0" anchor="t"/>
           <a:lstStyle/>
           <a:p>
-            <a:pPr indent="0" marL="0">
+            <a:pPr marL="0" indent="0">
               <a:buNone/>
             </a:pPr>
             <a:r>
@@ -4590,6 +4482,13 @@
             <a:prstDash val="solid"/>
           </a:ln>
         </p:spPr>
+        <p:txBody>
+          <a:bodyPr/>
+          <a:lstStyle/>
+          <a:p>
+            <a:endParaRPr lang="en-ZA"/>
+          </a:p>
+        </p:txBody>
       </p:sp>
       <p:sp>
         <p:nvSpPr>
@@ -4612,7 +4511,7 @@
           <a:bodyPr wrap="square" lIns="0" tIns="0" rIns="0" bIns="0" rtlCol="0" anchor="ctr"/>
           <a:lstStyle/>
           <a:p>
-            <a:pPr algn="ctr" indent="0" marL="0">
+            <a:pPr marL="0" indent="0" algn="ctr">
               <a:buNone/>
             </a:pPr>
             <a:r>
@@ -4651,7 +4550,7 @@
           <a:bodyPr wrap="square" lIns="0" tIns="0" rIns="0" bIns="0" rtlCol="0" anchor="t"/>
           <a:lstStyle/>
           <a:p>
-            <a:pPr indent="0" marL="0">
+            <a:pPr marL="0" indent="0">
               <a:buNone/>
             </a:pPr>
             <a:r>
@@ -4668,7 +4567,7 @@
             <a:endParaRPr lang="en-US" sz="1400" dirty="0"/>
           </a:p>
           <a:p>
-            <a:pPr indent="0" marL="0">
+            <a:pPr marL="0" indent="0">
               <a:buNone/>
             </a:pPr>
             <a:r>
@@ -4710,6 +4609,13 @@
             <a:prstDash val="solid"/>
           </a:ln>
         </p:spPr>
+        <p:txBody>
+          <a:bodyPr/>
+          <a:lstStyle/>
+          <a:p>
+            <a:endParaRPr lang="en-ZA"/>
+          </a:p>
+        </p:txBody>
       </p:sp>
       <p:sp>
         <p:nvSpPr>
@@ -4732,7 +4638,7 @@
           <a:bodyPr wrap="square" lIns="0" tIns="0" rIns="0" bIns="0" rtlCol="0" anchor="ctr"/>
           <a:lstStyle/>
           <a:p>
-            <a:pPr algn="ctr" indent="0" marL="0">
+            <a:pPr marL="0" indent="0" algn="ctr">
               <a:buNone/>
             </a:pPr>
             <a:r>
@@ -4771,7 +4677,7 @@
           <a:bodyPr wrap="square" lIns="0" tIns="0" rIns="0" bIns="0" rtlCol="0" anchor="t"/>
           <a:lstStyle/>
           <a:p>
-            <a:pPr indent="0" marL="0">
+            <a:pPr marL="0" indent="0">
               <a:buNone/>
             </a:pPr>
             <a:r>
@@ -4788,7 +4694,7 @@
             <a:endParaRPr lang="en-US" sz="1400" dirty="0"/>
           </a:p>
           <a:p>
-            <a:pPr indent="0" marL="0">
+            <a:pPr marL="0" indent="0">
               <a:buNone/>
             </a:pPr>
             <a:r>
@@ -4830,6 +4736,13 @@
             <a:prstDash val="solid"/>
           </a:ln>
         </p:spPr>
+        <p:txBody>
+          <a:bodyPr/>
+          <a:lstStyle/>
+          <a:p>
+            <a:endParaRPr lang="en-ZA"/>
+          </a:p>
+        </p:txBody>
       </p:sp>
       <p:sp>
         <p:nvSpPr>
@@ -4852,7 +4765,7 @@
           <a:bodyPr wrap="square" lIns="0" tIns="0" rIns="0" bIns="0" rtlCol="0" anchor="ctr"/>
           <a:lstStyle/>
           <a:p>
-            <a:pPr algn="ctr" indent="0" marL="0">
+            <a:pPr marL="0" indent="0" algn="ctr">
               <a:buNone/>
             </a:pPr>
             <a:r>
@@ -4891,7 +4804,7 @@
           <a:bodyPr wrap="square" lIns="0" tIns="0" rIns="0" bIns="0" rtlCol="0" anchor="t"/>
           <a:lstStyle/>
           <a:p>
-            <a:pPr indent="0" marL="0">
+            <a:pPr marL="0" indent="0">
               <a:buNone/>
             </a:pPr>
             <a:r>
@@ -4908,7 +4821,7 @@
             <a:endParaRPr lang="en-US" sz="1400" dirty="0"/>
           </a:p>
           <a:p>
-            <a:pPr indent="0" marL="0">
+            <a:pPr marL="0" indent="0">
               <a:buNone/>
             </a:pPr>
             <a:r>
@@ -4950,6 +4863,13 @@
             <a:prstDash val="solid"/>
           </a:ln>
         </p:spPr>
+        <p:txBody>
+          <a:bodyPr/>
+          <a:lstStyle/>
+          <a:p>
+            <a:endParaRPr lang="en-ZA"/>
+          </a:p>
+        </p:txBody>
       </p:sp>
       <p:sp>
         <p:nvSpPr>
@@ -4972,7 +4892,7 @@
           <a:bodyPr wrap="square" lIns="0" tIns="0" rIns="0" bIns="0" rtlCol="0" anchor="ctr"/>
           <a:lstStyle/>
           <a:p>
-            <a:pPr algn="ctr" indent="0" marL="0">
+            <a:pPr marL="0" indent="0" algn="ctr">
               <a:buNone/>
             </a:pPr>
             <a:r>
@@ -5011,7 +4931,7 @@
           <a:bodyPr wrap="square" lIns="0" tIns="0" rIns="0" bIns="0" rtlCol="0" anchor="t"/>
           <a:lstStyle/>
           <a:p>
-            <a:pPr indent="0" marL="0">
+            <a:pPr marL="0" indent="0">
               <a:buNone/>
             </a:pPr>
             <a:r>
@@ -5028,7 +4948,7 @@
             <a:endParaRPr lang="en-US" sz="1400" dirty="0"/>
           </a:p>
           <a:p>
-            <a:pPr indent="0" marL="0">
+            <a:pPr marL="0" indent="0">
               <a:buNone/>
             </a:pPr>
             <a:r>
@@ -5070,6 +4990,13 @@
             <a:prstDash val="solid"/>
           </a:ln>
         </p:spPr>
+        <p:txBody>
+          <a:bodyPr/>
+          <a:lstStyle/>
+          <a:p>
+            <a:endParaRPr lang="en-ZA"/>
+          </a:p>
+        </p:txBody>
       </p:sp>
       <p:sp>
         <p:nvSpPr>
@@ -5092,7 +5019,7 @@
           <a:bodyPr wrap="square" lIns="0" tIns="0" rIns="0" bIns="0" rtlCol="0" anchor="ctr"/>
           <a:lstStyle/>
           <a:p>
-            <a:pPr algn="ctr" indent="0" marL="0">
+            <a:pPr marL="0" indent="0" algn="ctr">
               <a:buNone/>
             </a:pPr>
             <a:r>
@@ -5131,7 +5058,7 @@
           <a:bodyPr wrap="square" lIns="0" tIns="0" rIns="0" bIns="0" rtlCol="0" anchor="t"/>
           <a:lstStyle/>
           <a:p>
-            <a:pPr indent="0" marL="0">
+            <a:pPr marL="0" indent="0">
               <a:buNone/>
             </a:pPr>
             <a:r>
@@ -5173,13 +5100,20 @@
             <a:prstDash val="solid"/>
           </a:ln>
           <a:effectLst>
-            <a:outerShdw sx="100000" sy="100000" kx="0" ky="0" algn="bl" rotWithShape="0" blurRad="101600" dist="25400" dir="5400000">
+            <a:outerShdw blurRad="101600" dist="25400" dir="5400000" algn="bl" rotWithShape="0">
               <a:srgbClr val="000000">
                 <a:alpha val="12000"/>
               </a:srgbClr>
             </a:outerShdw>
           </a:effectLst>
         </p:spPr>
+        <p:txBody>
+          <a:bodyPr/>
+          <a:lstStyle/>
+          <a:p>
+            <a:endParaRPr lang="en-ZA"/>
+          </a:p>
+        </p:txBody>
       </p:sp>
       <p:sp>
         <p:nvSpPr>
@@ -5205,6 +5139,13 @@
             <a:prstDash val="solid"/>
           </a:ln>
         </p:spPr>
+        <p:txBody>
+          <a:bodyPr/>
+          <a:lstStyle/>
+          <a:p>
+            <a:endParaRPr lang="en-ZA"/>
+          </a:p>
+        </p:txBody>
       </p:sp>
       <p:sp>
         <p:nvSpPr>
@@ -5227,11 +5168,11 @@
           <a:bodyPr wrap="square" lIns="0" tIns="0" rIns="0" bIns="0" rtlCol="0" anchor="ctr"/>
           <a:lstStyle/>
           <a:p>
-            <a:pPr indent="0" marL="0">
-              <a:buNone/>
-            </a:pPr>
-            <a:r>
-              <a:rPr lang="en-US" sz="1300" spc="300" kern="0" dirty="0">
+            <a:pPr marL="0" indent="0">
+              <a:buNone/>
+            </a:pPr>
+            <a:r>
+              <a:rPr lang="en-US" sz="1300" kern="0" spc="300" dirty="0">
                 <a:solidFill>
                   <a:srgbClr val="B11F4B"/>
                 </a:solidFill>
@@ -5266,7 +5207,7 @@
           <a:bodyPr wrap="square" lIns="0" tIns="0" rIns="0" bIns="0" rtlCol="0" anchor="ctr"/>
           <a:lstStyle/>
           <a:p>
-            <a:pPr indent="0" marL="0">
+            <a:pPr marL="0" indent="0">
               <a:buNone/>
             </a:pPr>
             <a:r>
@@ -5305,7 +5246,7 @@
           <a:bodyPr wrap="square" lIns="0" tIns="0" rIns="0" bIns="0" rtlCol="0" anchor="t"/>
           <a:lstStyle/>
           <a:p>
-            <a:pPr indent="0" marL="0">
+            <a:pPr marL="0" indent="0">
               <a:buNone/>
             </a:pPr>
             <a:r>
@@ -5322,7 +5263,7 @@
             <a:endParaRPr lang="en-US" sz="1500" dirty="0"/>
           </a:p>
           <a:p>
-            <a:pPr indent="0" marL="0">
+            <a:pPr marL="0" indent="0">
               <a:buNone/>
             </a:pPr>
             <a:r>
@@ -5339,7 +5280,7 @@
             <a:endParaRPr lang="en-US" sz="1500" dirty="0"/>
           </a:p>
           <a:p>
-            <a:pPr indent="0" marL="0">
+            <a:pPr marL="0" indent="0">
               <a:buNone/>
             </a:pPr>
             <a:r>
@@ -5356,7 +5297,7 @@
             <a:endParaRPr lang="en-US" sz="1500" dirty="0"/>
           </a:p>
           <a:p>
-            <a:pPr indent="0" marL="0">
+            <a:pPr marL="0" indent="0">
               <a:buNone/>
             </a:pPr>
             <a:r>
@@ -5373,7 +5314,7 @@
             <a:endParaRPr lang="en-US" sz="1500" dirty="0"/>
           </a:p>
           <a:p>
-            <a:pPr indent="0" marL="0">
+            <a:pPr marL="0" indent="0">
               <a:buNone/>
             </a:pPr>
             <a:r>
@@ -5415,13 +5356,20 @@
             <a:prstDash val="solid"/>
           </a:ln>
           <a:effectLst>
-            <a:outerShdw sx="100000" sy="100000" kx="0" ky="0" algn="bl" rotWithShape="0" blurRad="101600" dist="25400" dir="5400000">
+            <a:outerShdw blurRad="101600" dist="25400" dir="5400000" algn="bl" rotWithShape="0">
               <a:srgbClr val="000000">
                 <a:alpha val="12000"/>
               </a:srgbClr>
             </a:outerShdw>
           </a:effectLst>
         </p:spPr>
+        <p:txBody>
+          <a:bodyPr/>
+          <a:lstStyle/>
+          <a:p>
+            <a:endParaRPr lang="en-ZA"/>
+          </a:p>
+        </p:txBody>
       </p:sp>
       <p:sp>
         <p:nvSpPr>
@@ -5447,6 +5395,13 @@
             <a:prstDash val="solid"/>
           </a:ln>
         </p:spPr>
+        <p:txBody>
+          <a:bodyPr/>
+          <a:lstStyle/>
+          <a:p>
+            <a:endParaRPr lang="en-ZA"/>
+          </a:p>
+        </p:txBody>
       </p:sp>
       <p:sp>
         <p:nvSpPr>
@@ -5469,11 +5424,11 @@
           <a:bodyPr wrap="square" lIns="0" tIns="0" rIns="0" bIns="0" rtlCol="0" anchor="ctr"/>
           <a:lstStyle/>
           <a:p>
-            <a:pPr indent="0" marL="0">
-              <a:buNone/>
-            </a:pPr>
-            <a:r>
-              <a:rPr lang="en-US" sz="1300" spc="300" kern="0" dirty="0">
+            <a:pPr marL="0" indent="0">
+              <a:buNone/>
+            </a:pPr>
+            <a:r>
+              <a:rPr lang="en-US" sz="1300" kern="0" spc="300" dirty="0">
                 <a:solidFill>
                   <a:srgbClr val="B11F4B"/>
                 </a:solidFill>
@@ -5511,6 +5466,13 @@
             <a:prstDash val="solid"/>
           </a:ln>
         </p:spPr>
+        <p:txBody>
+          <a:bodyPr/>
+          <a:lstStyle/>
+          <a:p>
+            <a:endParaRPr lang="en-ZA"/>
+          </a:p>
+        </p:txBody>
       </p:sp>
       <p:sp>
         <p:nvSpPr>
@@ -5533,7 +5495,7 @@
           <a:bodyPr wrap="square" lIns="0" tIns="0" rIns="0" bIns="0" rtlCol="0" anchor="ctr"/>
           <a:lstStyle/>
           <a:p>
-            <a:pPr algn="ctr" indent="0" marL="0">
+            <a:pPr marL="0" indent="0" algn="ctr">
               <a:buNone/>
             </a:pPr>
             <a:r>
@@ -5572,7 +5534,7 @@
           <a:bodyPr wrap="square" lIns="0" tIns="0" rIns="0" bIns="0" rtlCol="0" anchor="ctr"/>
           <a:lstStyle/>
           <a:p>
-            <a:pPr indent="0" marL="0">
+            <a:pPr marL="0" indent="0">
               <a:buNone/>
             </a:pPr>
             <a:r>
@@ -5614,6 +5576,13 @@
             <a:prstDash val="solid"/>
           </a:ln>
         </p:spPr>
+        <p:txBody>
+          <a:bodyPr/>
+          <a:lstStyle/>
+          <a:p>
+            <a:endParaRPr lang="en-ZA"/>
+          </a:p>
+        </p:txBody>
       </p:sp>
       <p:sp>
         <p:nvSpPr>
@@ -5636,7 +5605,7 @@
           <a:bodyPr wrap="square" lIns="0" tIns="0" rIns="0" bIns="0" rtlCol="0" anchor="ctr"/>
           <a:lstStyle/>
           <a:p>
-            <a:pPr algn="ctr" indent="0" marL="0">
+            <a:pPr marL="0" indent="0" algn="ctr">
               <a:buNone/>
             </a:pPr>
             <a:r>
@@ -5675,7 +5644,7 @@
           <a:bodyPr wrap="square" lIns="0" tIns="0" rIns="0" bIns="0" rtlCol="0" anchor="ctr"/>
           <a:lstStyle/>
           <a:p>
-            <a:pPr indent="0" marL="0">
+            <a:pPr marL="0" indent="0">
               <a:buNone/>
             </a:pPr>
             <a:r>
@@ -5717,6 +5686,13 @@
             <a:prstDash val="solid"/>
           </a:ln>
         </p:spPr>
+        <p:txBody>
+          <a:bodyPr/>
+          <a:lstStyle/>
+          <a:p>
+            <a:endParaRPr lang="en-ZA"/>
+          </a:p>
+        </p:txBody>
       </p:sp>
       <p:sp>
         <p:nvSpPr>
@@ -5739,7 +5715,7 @@
           <a:bodyPr wrap="square" lIns="0" tIns="0" rIns="0" bIns="0" rtlCol="0" anchor="ctr"/>
           <a:lstStyle/>
           <a:p>
-            <a:pPr algn="ctr" indent="0" marL="0">
+            <a:pPr marL="0" indent="0" algn="ctr">
               <a:buNone/>
             </a:pPr>
             <a:r>
@@ -5778,7 +5754,7 @@
           <a:bodyPr wrap="square" lIns="0" tIns="0" rIns="0" bIns="0" rtlCol="0" anchor="ctr"/>
           <a:lstStyle/>
           <a:p>
-            <a:pPr indent="0" marL="0">
+            <a:pPr marL="0" indent="0">
               <a:buNone/>
             </a:pPr>
             <a:r>
@@ -5820,6 +5796,13 @@
             <a:prstDash val="solid"/>
           </a:ln>
         </p:spPr>
+        <p:txBody>
+          <a:bodyPr/>
+          <a:lstStyle/>
+          <a:p>
+            <a:endParaRPr lang="en-ZA"/>
+          </a:p>
+        </p:txBody>
       </p:sp>
       <p:sp>
         <p:nvSpPr>
@@ -5842,7 +5825,7 @@
           <a:bodyPr wrap="square" lIns="0" tIns="0" rIns="0" bIns="0" rtlCol="0" anchor="ctr"/>
           <a:lstStyle/>
           <a:p>
-            <a:pPr algn="ctr" indent="0" marL="0">
+            <a:pPr marL="0" indent="0" algn="ctr">
               <a:buNone/>
             </a:pPr>
             <a:r>
@@ -5881,7 +5864,7 @@
           <a:bodyPr wrap="square" lIns="0" tIns="0" rIns="0" bIns="0" rtlCol="0" anchor="ctr"/>
           <a:lstStyle/>
           <a:p>
-            <a:pPr indent="0" marL="0">
+            <a:pPr marL="0" indent="0">
               <a:buNone/>
             </a:pPr>
             <a:r>
@@ -5915,6 +5898,7 @@
         <a:solidFill>
           <a:srgbClr val="F7F4EF"/>
         </a:solidFill>
+        <a:effectLst/>
       </p:bgPr>
     </p:bg>
     <p:spTree>
@@ -5952,7 +5936,7 @@
           <a:bodyPr wrap="square" lIns="0" tIns="0" rIns="0" bIns="0" rtlCol="0" anchor="ctr"/>
           <a:lstStyle/>
           <a:p>
-            <a:pPr indent="0" marL="0">
+            <a:pPr marL="0" indent="0">
               <a:buNone/>
             </a:pPr>
             <a:r>
@@ -5966,9 +5950,6 @@
               </a:rPr>
               <a:t>Step 1   </a:t>
             </a:r>
-            <a:pPr indent="0" marL="0">
-              <a:buNone/>
-            </a:pPr>
             <a:r>
               <a:rPr lang="en-US" sz="3200" dirty="0">
                 <a:solidFill>
@@ -5986,14 +5967,14 @@
       </p:sp>
       <p:pic>
         <p:nvPicPr>
-          <p:cNvPr id="3" name="Image 0" descr="The browser sends GET / to StoreController, which gets six products from Catalog, fills in index.html, and sends the page back">    </p:cNvPr>
+          <p:cNvPr id="3" name="Image 0" descr="The browser sends GET / to StoreController, which gets six products from Catalog, fills in index.html, and sends the page back"/>
           <p:cNvPicPr>
             <a:picLocks noChangeAspect="1"/>
           </p:cNvPicPr>
           <p:nvPr/>
         </p:nvPicPr>
         <p:blipFill>
-          <a:blip r:embed="rId1"/>
+          <a:blip r:embed="rId3"/>
           <a:stretch>
             <a:fillRect/>
           </a:stretch>
@@ -6032,13 +6013,20 @@
             <a:prstDash val="solid"/>
           </a:ln>
           <a:effectLst>
-            <a:outerShdw sx="100000" sy="100000" kx="0" ky="0" algn="bl" rotWithShape="0" blurRad="101600" dist="25400" dir="5400000">
+            <a:outerShdw blurRad="101600" dist="25400" dir="5400000" algn="bl" rotWithShape="0">
               <a:srgbClr val="000000">
                 <a:alpha val="12000"/>
               </a:srgbClr>
             </a:outerShdw>
           </a:effectLst>
         </p:spPr>
+        <p:txBody>
+          <a:bodyPr/>
+          <a:lstStyle/>
+          <a:p>
+            <a:endParaRPr lang="en-ZA"/>
+          </a:p>
+        </p:txBody>
       </p:sp>
       <p:sp>
         <p:nvSpPr>
@@ -6064,6 +6052,13 @@
             <a:prstDash val="solid"/>
           </a:ln>
         </p:spPr>
+        <p:txBody>
+          <a:bodyPr/>
+          <a:lstStyle/>
+          <a:p>
+            <a:endParaRPr lang="en-ZA"/>
+          </a:p>
+        </p:txBody>
       </p:sp>
       <p:sp>
         <p:nvSpPr>
@@ -6086,11 +6081,11 @@
           <a:bodyPr wrap="square" lIns="0" tIns="0" rIns="0" bIns="0" rtlCol="0" anchor="ctr"/>
           <a:lstStyle/>
           <a:p>
-            <a:pPr indent="0" marL="0">
-              <a:buNone/>
-            </a:pPr>
-            <a:r>
-              <a:rPr lang="en-US" sz="1300" spc="300" kern="0" dirty="0">
+            <a:pPr marL="0" indent="0">
+              <a:buNone/>
+            </a:pPr>
+            <a:r>
+              <a:rPr lang="en-US" sz="1300" kern="0" spc="300" dirty="0">
                 <a:solidFill>
                   <a:srgbClr val="B11F4B"/>
                 </a:solidFill>
@@ -6125,7 +6120,7 @@
           <a:bodyPr wrap="square" lIns="0" tIns="0" rIns="0" bIns="0" rtlCol="0" anchor="t"/>
           <a:lstStyle/>
           <a:p>
-            <a:pPr indent="0" marL="0">
+            <a:pPr marL="0" indent="0">
               <a:buNone/>
             </a:pPr>
             <a:r>
@@ -6164,11 +6159,11 @@
           <a:bodyPr wrap="square" lIns="0" tIns="0" rIns="0" bIns="0" rtlCol="0" anchor="ctr"/>
           <a:lstStyle/>
           <a:p>
-            <a:pPr indent="0" marL="0">
-              <a:buNone/>
-            </a:pPr>
-            <a:r>
-              <a:rPr lang="en-US" sz="1300" spc="300" kern="0" dirty="0">
+            <a:pPr marL="0" indent="0">
+              <a:buNone/>
+            </a:pPr>
+            <a:r>
+              <a:rPr lang="en-US" sz="1300" kern="0" spc="300" dirty="0">
                 <a:solidFill>
                   <a:srgbClr val="B11F4B"/>
                 </a:solidFill>
@@ -6203,7 +6198,7 @@
           <a:bodyPr wrap="square" lIns="0" tIns="0" rIns="0" bIns="0" rtlCol="0" anchor="t"/>
           <a:lstStyle/>
           <a:p>
-            <a:pPr indent="0" marL="0">
+            <a:pPr marL="0" indent="0">
               <a:buNone/>
             </a:pPr>
             <a:r>
@@ -6220,7 +6215,7 @@
             <a:endParaRPr lang="en-US" sz="1400" dirty="0"/>
           </a:p>
           <a:p>
-            <a:pPr indent="0" marL="0">
+            <a:pPr marL="0" indent="0">
               <a:buNone/>
             </a:pPr>
             <a:r>
@@ -6254,6 +6249,7 @@
         <a:solidFill>
           <a:srgbClr val="F7F4EF"/>
         </a:solidFill>
+        <a:effectLst/>
       </p:bgPr>
     </p:bg>
     <p:spTree>
@@ -6291,7 +6287,7 @@
           <a:bodyPr wrap="square" lIns="0" tIns="0" rIns="0" bIns="0" rtlCol="0" anchor="ctr"/>
           <a:lstStyle/>
           <a:p>
-            <a:pPr indent="0" marL="0">
+            <a:pPr marL="0" indent="0">
               <a:buNone/>
             </a:pPr>
             <a:r>
@@ -6305,9 +6301,6 @@
               </a:rPr>
               <a:t>Step 2   </a:t>
             </a:r>
-            <a:pPr indent="0" marL="0">
-              <a:buNone/>
-            </a:pPr>
             <a:r>
               <a:rPr lang="en-US" sz="3200" dirty="0">
                 <a:solidFill>
@@ -6325,14 +6318,14 @@
       </p:sp>
       <p:pic>
         <p:nvPicPr>
-          <p:cNvPr id="3" name="Image 0" descr="azd up creates a container registry, a managed identity and a container app in one resource group, builds the image in Azure, and deploys it behind a public HTTPS address">    </p:cNvPr>
+          <p:cNvPr id="3" name="Image 0" descr="azd up creates a container registry, a managed identity and a container app in one resource group, builds the image in Azure, and deploys it behind a public HTTPS address"/>
           <p:cNvPicPr>
             <a:picLocks noChangeAspect="1"/>
           </p:cNvPicPr>
           <p:nvPr/>
         </p:nvPicPr>
         <p:blipFill>
-          <a:blip r:embed="rId1"/>
+          <a:blip r:embed="rId3"/>
           <a:stretch>
             <a:fillRect/>
           </a:stretch>
@@ -6371,13 +6364,20 @@
             <a:prstDash val="solid"/>
           </a:ln>
           <a:effectLst>
-            <a:outerShdw sx="100000" sy="100000" kx="0" ky="0" algn="bl" rotWithShape="0" blurRad="101600" dist="25400" dir="5400000">
+            <a:outerShdw blurRad="101600" dist="25400" dir="5400000" algn="bl" rotWithShape="0">
               <a:srgbClr val="000000">
                 <a:alpha val="12000"/>
               </a:srgbClr>
             </a:outerShdw>
           </a:effectLst>
         </p:spPr>
+        <p:txBody>
+          <a:bodyPr/>
+          <a:lstStyle/>
+          <a:p>
+            <a:endParaRPr lang="en-ZA"/>
+          </a:p>
+        </p:txBody>
       </p:sp>
       <p:sp>
         <p:nvSpPr>
@@ -6403,6 +6403,13 @@
             <a:prstDash val="solid"/>
           </a:ln>
         </p:spPr>
+        <p:txBody>
+          <a:bodyPr/>
+          <a:lstStyle/>
+          <a:p>
+            <a:endParaRPr lang="en-ZA"/>
+          </a:p>
+        </p:txBody>
       </p:sp>
       <p:sp>
         <p:nvSpPr>
@@ -6425,11 +6432,11 @@
           <a:bodyPr wrap="square" lIns="0" tIns="0" rIns="0" bIns="0" rtlCol="0" anchor="ctr"/>
           <a:lstStyle/>
           <a:p>
-            <a:pPr indent="0" marL="0">
-              <a:buNone/>
-            </a:pPr>
-            <a:r>
-              <a:rPr lang="en-US" sz="1300" spc="300" kern="0" dirty="0">
+            <a:pPr marL="0" indent="0">
+              <a:buNone/>
+            </a:pPr>
+            <a:r>
+              <a:rPr lang="en-US" sz="1300" kern="0" spc="300" dirty="0">
                 <a:solidFill>
                   <a:srgbClr val="005A9E"/>
                 </a:solidFill>
@@ -6464,7 +6471,7 @@
           <a:bodyPr wrap="square" lIns="0" tIns="0" rIns="0" bIns="0" rtlCol="0" anchor="t"/>
           <a:lstStyle/>
           <a:p>
-            <a:pPr indent="0" marL="0">
+            <a:pPr marL="0" indent="0">
               <a:buNone/>
             </a:pPr>
             <a:r>
@@ -6503,11 +6510,11 @@
           <a:bodyPr wrap="square" lIns="0" tIns="0" rIns="0" bIns="0" rtlCol="0" anchor="ctr"/>
           <a:lstStyle/>
           <a:p>
-            <a:pPr indent="0" marL="0">
-              <a:buNone/>
-            </a:pPr>
-            <a:r>
-              <a:rPr lang="en-US" sz="1300" spc="300" kern="0" dirty="0">
+            <a:pPr marL="0" indent="0">
+              <a:buNone/>
+            </a:pPr>
+            <a:r>
+              <a:rPr lang="en-US" sz="1300" kern="0" spc="300" dirty="0">
                 <a:solidFill>
                   <a:srgbClr val="005A9E"/>
                 </a:solidFill>
@@ -6542,7 +6549,7 @@
           <a:bodyPr wrap="square" lIns="0" tIns="0" rIns="0" bIns="0" rtlCol="0" anchor="t"/>
           <a:lstStyle/>
           <a:p>
-            <a:pPr indent="0" marL="0">
+            <a:pPr marL="0" indent="0">
               <a:buNone/>
             </a:pPr>
             <a:r>
@@ -6559,7 +6566,7 @@
             <a:endParaRPr lang="en-US" sz="1400" dirty="0"/>
           </a:p>
           <a:p>
-            <a:pPr indent="0" marL="0">
+            <a:pPr marL="0" indent="0">
               <a:buNone/>
             </a:pPr>
             <a:r>
@@ -6593,6 +6600,7 @@
         <a:solidFill>
           <a:srgbClr val="F7F4EF"/>
         </a:solidFill>
+        <a:effectLst/>
       </p:bgPr>
     </p:bg>
     <p:spTree>
@@ -6630,7 +6638,7 @@
           <a:bodyPr wrap="square" lIns="0" tIns="0" rIns="0" bIns="0" rtlCol="0" anchor="ctr"/>
           <a:lstStyle/>
           <a:p>
-            <a:pPr indent="0" marL="0">
+            <a:pPr marL="0" indent="0">
               <a:buNone/>
             </a:pPr>
             <a:r>
@@ -6644,9 +6652,6 @@
               </a:rPr>
               <a:t>Step 3   </a:t>
             </a:r>
-            <a:pPr indent="0" marL="0">
-              <a:buNone/>
-            </a:pPr>
             <a:r>
               <a:rPr lang="en-US" sz="3200" dirty="0">
                 <a:solidFill>
@@ -6664,14 +6669,14 @@
       </p:sp>
       <p:pic>
         <p:nvPicPr>
-          <p:cNvPr id="3" name="Image 0" descr="Eight numbered messages between you, the app, the listProducts tool and the model: two calls to the model, with one call to the Java tool in between">    </p:cNvPr>
+          <p:cNvPr id="3" name="Image 0" descr="Eight numbered messages between you, the app, the listProducts tool and the model: two calls to the model, with one call to the Java tool in between"/>
           <p:cNvPicPr>
             <a:picLocks noChangeAspect="1"/>
           </p:cNvPicPr>
           <p:nvPr/>
         </p:nvPicPr>
         <p:blipFill>
-          <a:blip r:embed="rId1"/>
+          <a:blip r:embed="rId3"/>
           <a:stretch>
             <a:fillRect/>
           </a:stretch>
@@ -6702,6 +6707,7 @@
         <a:solidFill>
           <a:srgbClr val="F7F4EF"/>
         </a:solidFill>
+        <a:effectLst/>
       </p:bgPr>
     </p:bg>
     <p:spTree>
@@ -6739,7 +6745,7 @@
           <a:bodyPr wrap="square" lIns="0" tIns="0" rIns="0" bIns="0" rtlCol="0" anchor="ctr"/>
           <a:lstStyle/>
           <a:p>
-            <a:pPr indent="0" marL="0">
+            <a:pPr marL="0" indent="0">
               <a:buNone/>
             </a:pPr>
             <a:r>
@@ -6781,24 +6787,31 @@
             <a:prstDash val="solid"/>
           </a:ln>
           <a:effectLst>
-            <a:outerShdw sx="100000" sy="100000" kx="0" ky="0" algn="bl" rotWithShape="0" blurRad="101600" dist="25400" dir="5400000">
+            <a:outerShdw blurRad="101600" dist="25400" dir="5400000" algn="bl" rotWithShape="0">
               <a:srgbClr val="000000">
                 <a:alpha val="12000"/>
               </a:srgbClr>
             </a:outerShdw>
           </a:effectLst>
         </p:spPr>
+        <p:txBody>
+          <a:bodyPr/>
+          <a:lstStyle/>
+          <a:p>
+            <a:endParaRPr lang="en-ZA"/>
+          </a:p>
+        </p:txBody>
       </p:sp>
       <p:pic>
         <p:nvPicPr>
-          <p:cNvPr id="4" name="Image 0" descr="The step 3 store page, answering whether the Summit Waterproof Jacket is in stock">    </p:cNvPr>
+          <p:cNvPr id="4" name="Image 0" descr="The step 3 store page, answering whether the Summit Waterproof Jacket is in stock"/>
           <p:cNvPicPr>
             <a:picLocks noChangeAspect="1"/>
           </p:cNvPicPr>
           <p:nvPr/>
         </p:nvPicPr>
         <p:blipFill>
-          <a:blip r:embed="rId1"/>
+          <a:blip r:embed="rId3"/>
           <a:stretch>
             <a:fillRect/>
           </a:stretch>
@@ -6837,13 +6850,20 @@
             <a:prstDash val="solid"/>
           </a:ln>
           <a:effectLst>
-            <a:outerShdw sx="100000" sy="100000" kx="0" ky="0" algn="bl" rotWithShape="0" blurRad="101600" dist="25400" dir="5400000">
+            <a:outerShdw blurRad="101600" dist="25400" dir="5400000" algn="bl" rotWithShape="0">
               <a:srgbClr val="000000">
                 <a:alpha val="12000"/>
               </a:srgbClr>
             </a:outerShdw>
           </a:effectLst>
         </p:spPr>
+        <p:txBody>
+          <a:bodyPr/>
+          <a:lstStyle/>
+          <a:p>
+            <a:endParaRPr lang="en-ZA"/>
+          </a:p>
+        </p:txBody>
       </p:sp>
       <p:sp>
         <p:nvSpPr>
@@ -6869,6 +6889,13 @@
             <a:prstDash val="solid"/>
           </a:ln>
         </p:spPr>
+        <p:txBody>
+          <a:bodyPr/>
+          <a:lstStyle/>
+          <a:p>
+            <a:endParaRPr lang="en-ZA"/>
+          </a:p>
+        </p:txBody>
       </p:sp>
       <p:sp>
         <p:nvSpPr>
@@ -6891,11 +6918,11 @@
           <a:bodyPr wrap="square" lIns="0" tIns="0" rIns="0" bIns="0" rtlCol="0" anchor="ctr"/>
           <a:lstStyle/>
           <a:p>
-            <a:pPr indent="0" marL="0">
-              <a:buNone/>
-            </a:pPr>
-            <a:r>
-              <a:rPr lang="en-US" sz="1300" spc="300" kern="0" dirty="0">
+            <a:pPr marL="0" indent="0">
+              <a:buNone/>
+            </a:pPr>
+            <a:r>
+              <a:rPr lang="en-US" sz="1300" kern="0" spc="300" dirty="0">
                 <a:solidFill>
                   <a:srgbClr val="5C2D91"/>
                 </a:solidFill>
@@ -6930,7 +6957,7 @@
           <a:bodyPr wrap="square" lIns="0" tIns="0" rIns="0" bIns="0" rtlCol="0" anchor="t"/>
           <a:lstStyle/>
           <a:p>
-            <a:pPr indent="0" marL="0">
+            <a:pPr marL="0" indent="0">
               <a:buNone/>
             </a:pPr>
             <a:r>
@@ -6969,11 +6996,11 @@
           <a:bodyPr wrap="square" lIns="0" tIns="0" rIns="0" bIns="0" rtlCol="0" anchor="ctr"/>
           <a:lstStyle/>
           <a:p>
-            <a:pPr indent="0" marL="0">
-              <a:buNone/>
-            </a:pPr>
-            <a:r>
-              <a:rPr lang="en-US" sz="1300" spc="300" kern="0" dirty="0">
+            <a:pPr marL="0" indent="0">
+              <a:buNone/>
+            </a:pPr>
+            <a:r>
+              <a:rPr lang="en-US" sz="1300" kern="0" spc="300" dirty="0">
                 <a:solidFill>
                   <a:srgbClr val="5C2D91"/>
                 </a:solidFill>
@@ -7008,7 +7035,7 @@
           <a:bodyPr wrap="square" lIns="0" tIns="0" rIns="0" bIns="0" rtlCol="0" anchor="t"/>
           <a:lstStyle/>
           <a:p>
-            <a:pPr indent="0" marL="0">
+            <a:pPr marL="0" indent="0">
               <a:buNone/>
             </a:pPr>
             <a:r>
@@ -7025,7 +7052,7 @@
             <a:endParaRPr lang="en-US" sz="1400" dirty="0"/>
           </a:p>
           <a:p>
-            <a:pPr indent="0" marL="0">
+            <a:pPr marL="0" indent="0">
               <a:buNone/>
             </a:pPr>
             <a:r>
@@ -7064,7 +7091,7 @@
           <a:bodyPr wrap="square" lIns="0" tIns="0" rIns="0" bIns="0" rtlCol="0" anchor="ctr"/>
           <a:lstStyle/>
           <a:p>
-            <a:pPr indent="0" marL="0">
+            <a:pPr marL="0" indent="0">
               <a:buNone/>
             </a:pPr>
             <a:r>
@@ -7106,13 +7133,20 @@
             <a:prstDash val="solid"/>
           </a:ln>
           <a:effectLst>
-            <a:outerShdw sx="100000" sy="100000" kx="0" ky="0" algn="bl" rotWithShape="0" blurRad="101600" dist="25400" dir="5400000">
+            <a:outerShdw blurRad="101600" dist="25400" dir="5400000" algn="bl" rotWithShape="0">
               <a:srgbClr val="000000">
                 <a:alpha val="12000"/>
               </a:srgbClr>
             </a:outerShdw>
           </a:effectLst>
         </p:spPr>
+        <p:txBody>
+          <a:bodyPr/>
+          <a:lstStyle/>
+          <a:p>
+            <a:endParaRPr lang="en-ZA"/>
+          </a:p>
+        </p:txBody>
       </p:sp>
       <p:sp>
         <p:nvSpPr>
@@ -7138,6 +7172,13 @@
             <a:prstDash val="solid"/>
           </a:ln>
         </p:spPr>
+        <p:txBody>
+          <a:bodyPr/>
+          <a:lstStyle/>
+          <a:p>
+            <a:endParaRPr lang="en-ZA"/>
+          </a:p>
+        </p:txBody>
       </p:sp>
       <p:sp>
         <p:nvSpPr>
@@ -7160,7 +7201,7 @@
           <a:bodyPr wrap="square" lIns="0" tIns="0" rIns="0" bIns="0" rtlCol="0" anchor="ctr"/>
           <a:lstStyle/>
           <a:p>
-            <a:pPr indent="0" marL="0">
+            <a:pPr marL="0" indent="0">
               <a:buNone/>
             </a:pPr>
             <a:r>
@@ -7202,13 +7243,20 @@
             <a:prstDash val="solid"/>
           </a:ln>
           <a:effectLst>
-            <a:outerShdw sx="100000" sy="100000" kx="0" ky="0" algn="bl" rotWithShape="0" blurRad="101600" dist="25400" dir="5400000">
+            <a:outerShdw blurRad="101600" dist="25400" dir="5400000" algn="bl" rotWithShape="0">
               <a:srgbClr val="000000">
                 <a:alpha val="12000"/>
               </a:srgbClr>
             </a:outerShdw>
           </a:effectLst>
         </p:spPr>
+        <p:txBody>
+          <a:bodyPr/>
+          <a:lstStyle/>
+          <a:p>
+            <a:endParaRPr lang="en-ZA"/>
+          </a:p>
+        </p:txBody>
       </p:sp>
       <p:sp>
         <p:nvSpPr>
@@ -7234,6 +7282,13 @@
             <a:prstDash val="solid"/>
           </a:ln>
         </p:spPr>
+        <p:txBody>
+          <a:bodyPr/>
+          <a:lstStyle/>
+          <a:p>
+            <a:endParaRPr lang="en-ZA"/>
+          </a:p>
+        </p:txBody>
       </p:sp>
       <p:sp>
         <p:nvSpPr>
@@ -7256,7 +7311,7 @@
           <a:bodyPr wrap="square" lIns="0" tIns="0" rIns="0" bIns="0" rtlCol="0" anchor="ctr"/>
           <a:lstStyle/>
           <a:p>
-            <a:pPr indent="0" marL="0">
+            <a:pPr marL="0" indent="0">
               <a:buNone/>
             </a:pPr>
             <a:r>
@@ -7298,13 +7353,20 @@
             <a:prstDash val="solid"/>
           </a:ln>
           <a:effectLst>
-            <a:outerShdw sx="100000" sy="100000" kx="0" ky="0" algn="bl" rotWithShape="0" blurRad="101600" dist="25400" dir="5400000">
+            <a:outerShdw blurRad="101600" dist="25400" dir="5400000" algn="bl" rotWithShape="0">
               <a:srgbClr val="000000">
                 <a:alpha val="12000"/>
               </a:srgbClr>
             </a:outerShdw>
           </a:effectLst>
         </p:spPr>
+        <p:txBody>
+          <a:bodyPr/>
+          <a:lstStyle/>
+          <a:p>
+            <a:endParaRPr lang="en-ZA"/>
+          </a:p>
+        </p:txBody>
       </p:sp>
       <p:sp>
         <p:nvSpPr>
@@ -7330,6 +7392,13 @@
             <a:prstDash val="solid"/>
           </a:ln>
         </p:spPr>
+        <p:txBody>
+          <a:bodyPr/>
+          <a:lstStyle/>
+          <a:p>
+            <a:endParaRPr lang="en-ZA"/>
+          </a:p>
+        </p:txBody>
       </p:sp>
       <p:sp>
         <p:nvSpPr>
@@ -7352,7 +7421,7 @@
           <a:bodyPr wrap="square" lIns="0" tIns="0" rIns="0" bIns="0" rtlCol="0" anchor="ctr"/>
           <a:lstStyle/>
           <a:p>
-            <a:pPr indent="0" marL="0">
+            <a:pPr marL="0" indent="0">
               <a:buNone/>
             </a:pPr>
             <a:r>
@@ -7391,7 +7460,7 @@
           <a:bodyPr wrap="square" lIns="0" tIns="0" rIns="0" bIns="0" rtlCol="0" anchor="t"/>
           <a:lstStyle/>
           <a:p>
-            <a:pPr indent="0" marL="0">
+            <a:pPr marL="0" indent="0">
               <a:buNone/>
             </a:pPr>
             <a:r>
@@ -7425,6 +7494,7 @@
         <a:solidFill>
           <a:srgbClr val="F7F4EF"/>
         </a:solidFill>
+        <a:effectLst/>
       </p:bgPr>
     </p:bg>
     <p:spTree>
@@ -7462,7 +7532,7 @@
           <a:bodyPr wrap="square" lIns="0" tIns="0" rIns="0" bIns="0" rtlCol="0" anchor="ctr"/>
           <a:lstStyle/>
           <a:p>
-            <a:pPr indent="0" marL="0">
+            <a:pPr marL="0" indent="0">
               <a:buNone/>
             </a:pPr>
             <a:r>
@@ -7476,9 +7546,6 @@
               </a:rPr>
               <a:t>Step 4   </a:t>
             </a:r>
-            <a:pPr indent="0" marL="0">
-              <a:buNone/>
-            </a:pPr>
             <a:r>
               <a:rPr lang="en-US" sz="3200" dirty="0">
                 <a:solidFill>
@@ -7496,14 +7563,14 @@
       </p:sp>
       <p:pic>
         <p:nvPicPr>
-          <p:cNvPr id="3" name="Image 0" descr="The app sends traces to the Container Apps environment, which forwards them to Application Insights, where you can query tokens and cost or open one question as a timeline">    </p:cNvPr>
+          <p:cNvPr id="3" name="Image 0" descr="The app sends traces to the Container Apps environment, which forwards them to Application Insights, where you can query tokens and cost or open one question as a timeline"/>
           <p:cNvPicPr>
             <a:picLocks noChangeAspect="1"/>
           </p:cNvPicPr>
           <p:nvPr/>
         </p:nvPicPr>
         <p:blipFill>
-          <a:blip r:embed="rId1"/>
+          <a:blip r:embed="rId3"/>
           <a:stretch>
             <a:fillRect/>
           </a:stretch>
@@ -7542,13 +7609,20 @@
             <a:prstDash val="solid"/>
           </a:ln>
           <a:effectLst>
-            <a:outerShdw sx="100000" sy="100000" kx="0" ky="0" algn="bl" rotWithShape="0" blurRad="101600" dist="25400" dir="5400000">
+            <a:outerShdw blurRad="101600" dist="25400" dir="5400000" algn="bl" rotWithShape="0">
               <a:srgbClr val="000000">
                 <a:alpha val="12000"/>
               </a:srgbClr>
             </a:outerShdw>
           </a:effectLst>
         </p:spPr>
+        <p:txBody>
+          <a:bodyPr/>
+          <a:lstStyle/>
+          <a:p>
+            <a:endParaRPr lang="en-ZA"/>
+          </a:p>
+        </p:txBody>
       </p:sp>
       <p:sp>
         <p:nvSpPr>
@@ -7574,6 +7648,13 @@
             <a:prstDash val="solid"/>
           </a:ln>
         </p:spPr>
+        <p:txBody>
+          <a:bodyPr/>
+          <a:lstStyle/>
+          <a:p>
+            <a:endParaRPr lang="en-ZA"/>
+          </a:p>
+        </p:txBody>
       </p:sp>
       <p:sp>
         <p:nvSpPr>
@@ -7596,11 +7677,11 @@
           <a:bodyPr wrap="square" lIns="0" tIns="0" rIns="0" bIns="0" rtlCol="0" anchor="ctr"/>
           <a:lstStyle/>
           <a:p>
-            <a:pPr indent="0" marL="0">
-              <a:buNone/>
-            </a:pPr>
-            <a:r>
-              <a:rPr lang="en-US" sz="1300" spc="300" kern="0" dirty="0">
+            <a:pPr marL="0" indent="0">
+              <a:buNone/>
+            </a:pPr>
+            <a:r>
+              <a:rPr lang="en-US" sz="1300" kern="0" spc="300" dirty="0">
                 <a:solidFill>
                   <a:srgbClr val="107C10"/>
                 </a:solidFill>
@@ -7635,7 +7716,7 @@
           <a:bodyPr wrap="square" lIns="0" tIns="0" rIns="0" bIns="0" rtlCol="0" anchor="t"/>
           <a:lstStyle/>
           <a:p>
-            <a:pPr indent="0" marL="0">
+            <a:pPr marL="0" indent="0">
               <a:buNone/>
             </a:pPr>
             <a:r>
@@ -7674,11 +7755,11 @@
           <a:bodyPr wrap="square" lIns="0" tIns="0" rIns="0" bIns="0" rtlCol="0" anchor="ctr"/>
           <a:lstStyle/>
           <a:p>
-            <a:pPr indent="0" marL="0">
-              <a:buNone/>
-            </a:pPr>
-            <a:r>
-              <a:rPr lang="en-US" sz="1300" spc="300" kern="0" dirty="0">
+            <a:pPr marL="0" indent="0">
+              <a:buNone/>
+            </a:pPr>
+            <a:r>
+              <a:rPr lang="en-US" sz="1300" kern="0" spc="300" dirty="0">
                 <a:solidFill>
                   <a:srgbClr val="107C10"/>
                 </a:solidFill>
@@ -7713,7 +7794,7 @@
           <a:bodyPr wrap="square" lIns="0" tIns="0" rIns="0" bIns="0" rtlCol="0" anchor="t"/>
           <a:lstStyle/>
           <a:p>
-            <a:pPr indent="0" marL="0">
+            <a:pPr marL="0" indent="0">
               <a:buNone/>
             </a:pPr>
             <a:r>
@@ -7730,7 +7811,7 @@
             <a:endParaRPr lang="en-US" sz="1400" dirty="0"/>
           </a:p>
           <a:p>
-            <a:pPr indent="0" marL="0">
+            <a:pPr marL="0" indent="0">
               <a:buNone/>
             </a:pPr>
             <a:r>
@@ -7764,6 +7845,7 @@
         <a:solidFill>
           <a:srgbClr val="F7F4EF"/>
         </a:solidFill>
+        <a:effectLst/>
       </p:bgPr>
     </p:bg>
     <p:spTree>
@@ -7801,7 +7883,7 @@
           <a:bodyPr wrap="square" lIns="0" tIns="0" rIns="0" bIns="0" rtlCol="0" anchor="ctr"/>
           <a:lstStyle/>
           <a:p>
-            <a:pPr indent="0" marL="0">
+            <a:pPr marL="0" indent="0">
               <a:buNone/>
             </a:pPr>
             <a:r>
@@ -7815,9 +7897,6 @@
               </a:rPr>
               <a:t>Step 4   </a:t>
             </a:r>
-            <a:pPr indent="0" marL="0">
-              <a:buNone/>
-            </a:pPr>
             <a:r>
               <a:rPr lang="en-US" sz="3200" dirty="0">
                 <a:solidFill>
@@ -7854,7 +7933,7 @@
           <a:bodyPr wrap="square" lIns="0" tIns="0" rIns="0" bIns="0" rtlCol="0" anchor="ctr"/>
           <a:lstStyle/>
           <a:p>
-            <a:pPr indent="0" marL="0">
+            <a:pPr marL="0" indent="0">
               <a:buNone/>
             </a:pPr>
             <a:r>
@@ -7874,14 +7953,14 @@
       </p:sp>
       <p:pic>
         <p:nvPicPr>
-          <p:cNvPr id="4" name="Image 0" descr="A 3.5-second request with a 1.5-second model call, a 1-millisecond tool call and a 1.9-second model call, using 549 input and 52 output tokens for $0.000081">    </p:cNvPr>
+          <p:cNvPr id="4" name="Image 0" descr="A 3.5-second request with a 1.5-second model call, a 1-millisecond tool call and a 1.9-second model call, using 549 input and 52 output tokens for $0.000081"/>
           <p:cNvPicPr>
             <a:picLocks noChangeAspect="1"/>
           </p:cNvPicPr>
           <p:nvPr/>
         </p:nvPicPr>
         <p:blipFill>
-          <a:blip r:embed="rId1"/>
+          <a:blip r:embed="rId3"/>
           <a:stretch>
             <a:fillRect/>
           </a:stretch>
@@ -7917,7 +7996,7 @@
           <a:bodyPr wrap="square" lIns="0" tIns="0" rIns="0" bIns="0" rtlCol="0" anchor="ctr"/>
           <a:lstStyle/>
           <a:p>
-            <a:pPr indent="0" marL="0">
+            <a:pPr marL="0" indent="0">
               <a:buNone/>
             </a:pPr>
             <a:r>
@@ -8236,4 +8315,325 @@
     </a:ext>
   </a:extLst>
 </a:theme>
+</file>
+
+<file path=ppt/theme/theme2.xml><?xml version="1.0" encoding="utf-8"?>
+<a:theme xmlns:a="http://schemas.openxmlformats.org/drawingml/2006/main" name="Office Theme">
+  <a:themeElements>
+    <a:clrScheme name="Office">
+      <a:dk1>
+        <a:sysClr val="windowText" lastClr="000000"/>
+      </a:dk1>
+      <a:lt1>
+        <a:sysClr val="window" lastClr="FFFFFF"/>
+      </a:lt1>
+      <a:dk2>
+        <a:srgbClr val="0E2841"/>
+      </a:dk2>
+      <a:lt2>
+        <a:srgbClr val="E8E8E8"/>
+      </a:lt2>
+      <a:accent1>
+        <a:srgbClr val="156082"/>
+      </a:accent1>
+      <a:accent2>
+        <a:srgbClr val="E97132"/>
+      </a:accent2>
+      <a:accent3>
+        <a:srgbClr val="196B24"/>
+      </a:accent3>
+      <a:accent4>
+        <a:srgbClr val="0F9ED5"/>
+      </a:accent4>
+      <a:accent5>
+        <a:srgbClr val="A02B93"/>
+      </a:accent5>
+      <a:accent6>
+        <a:srgbClr val="4EA72E"/>
+      </a:accent6>
+      <a:hlink>
+        <a:srgbClr val="467886"/>
+      </a:hlink>
+      <a:folHlink>
+        <a:srgbClr val="96607D"/>
+      </a:folHlink>
+    </a:clrScheme>
+    <a:fontScheme name="Office">
+      <a:majorFont>
+        <a:latin typeface="Aptos Display" panose="02110004020202020204"/>
+        <a:ea typeface=""/>
+        <a:cs typeface=""/>
+        <a:font script="Jpan" typeface="游ゴシック Light"/>
+        <a:font script="Hang" typeface="맑은 고딕"/>
+        <a:font script="Hans" typeface="等线 Light"/>
+        <a:font script="Hant" typeface="新細明體"/>
+        <a:font script="Arab" typeface="Times New Roman"/>
+        <a:font script="Hebr" typeface="Times New Roman"/>
+        <a:font script="Thai" typeface="Angsana New"/>
+        <a:font script="Ethi" typeface="Nyala"/>
+        <a:font script="Beng" typeface="Vrinda"/>
+        <a:font script="Gujr" typeface="Shruti"/>
+        <a:font script="Khmr" typeface="MoolBoran"/>
+        <a:font script="Knda" typeface="Tunga"/>
+        <a:font script="Guru" typeface="Raavi"/>
+        <a:font script="Cans" typeface="Euphemia"/>
+        <a:font script="Cher" typeface="Plantagenet Cherokee"/>
+        <a:font script="Yiii" typeface="Microsoft Yi Baiti"/>
+        <a:font script="Tibt" typeface="Microsoft Himalaya"/>
+        <a:font script="Thaa" typeface="MV Boli"/>
+        <a:font script="Deva" typeface="Mangal"/>
+        <a:font script="Telu" typeface="Gautami"/>
+        <a:font script="Taml" typeface="Latha"/>
+        <a:font script="Syrc" typeface="Estrangelo Edessa"/>
+        <a:font script="Orya" typeface="Kalinga"/>
+        <a:font script="Mlym" typeface="Kartika"/>
+        <a:font script="Laoo" typeface="DokChampa"/>
+        <a:font script="Sinh" typeface="Iskoola Pota"/>
+        <a:font script="Mong" typeface="Mongolian Baiti"/>
+        <a:font script="Viet" typeface="Times New Roman"/>
+        <a:font script="Uigh" typeface="Microsoft Uighur"/>
+        <a:font script="Geor" typeface="Sylfaen"/>
+        <a:font script="Armn" typeface="Arial"/>
+        <a:font script="Bugi" typeface="Leelawadee UI"/>
+        <a:font script="Bopo" typeface="Microsoft JhengHei"/>
+        <a:font script="Java" typeface="Javanese Text"/>
+        <a:font script="Lisu" typeface="Segoe UI"/>
+        <a:font script="Mymr" typeface="Myanmar Text"/>
+        <a:font script="Nkoo" typeface="Ebrima"/>
+        <a:font script="Olck" typeface="Nirmala UI"/>
+        <a:font script="Osma" typeface="Ebrima"/>
+        <a:font script="Phag" typeface="Phagspa"/>
+        <a:font script="Syrn" typeface="Estrangelo Edessa"/>
+        <a:font script="Syrj" typeface="Estrangelo Edessa"/>
+        <a:font script="Syre" typeface="Estrangelo Edessa"/>
+        <a:font script="Sora" typeface="Nirmala UI"/>
+        <a:font script="Tale" typeface="Microsoft Tai Le"/>
+        <a:font script="Talu" typeface="Microsoft New Tai Lue"/>
+        <a:font script="Tfng" typeface="Ebrima"/>
+      </a:majorFont>
+      <a:minorFont>
+        <a:latin typeface="Aptos" panose="02110004020202020204"/>
+        <a:ea typeface=""/>
+        <a:cs typeface=""/>
+        <a:font script="Jpan" typeface="游ゴシック"/>
+        <a:font script="Hang" typeface="맑은 고딕"/>
+        <a:font script="Hans" typeface="等线"/>
+        <a:font script="Hant" typeface="新細明體"/>
+        <a:font script="Arab" typeface="Arial"/>
+        <a:font script="Hebr" typeface="Arial"/>
+        <a:font script="Thai" typeface="Cordia New"/>
+        <a:font script="Ethi" typeface="Nyala"/>
+        <a:font script="Beng" typeface="Vrinda"/>
+        <a:font script="Gujr" typeface="Shruti"/>
+        <a:font script="Khmr" typeface="DaunPenh"/>
+        <a:font script="Knda" typeface="Tunga"/>
+        <a:font script="Guru" typeface="Raavi"/>
+        <a:font script="Cans" typeface="Euphemia"/>
+        <a:font script="Cher" typeface="Plantagenet Cherokee"/>
+        <a:font script="Yiii" typeface="Microsoft Yi Baiti"/>
+        <a:font script="Tibt" typeface="Microsoft Himalaya"/>
+        <a:font script="Thaa" typeface="MV Boli"/>
+        <a:font script="Deva" typeface="Mangal"/>
+        <a:font script="Telu" typeface="Gautami"/>
+        <a:font script="Taml" typeface="Latha"/>
+        <a:font script="Syrc" typeface="Estrangelo Edessa"/>
+        <a:font script="Orya" typeface="Kalinga"/>
+        <a:font script="Mlym" typeface="Kartika"/>
+        <a:font script="Laoo" typeface="DokChampa"/>
+        <a:font script="Sinh" typeface="Iskoola Pota"/>
+        <a:font script="Mong" typeface="Mongolian Baiti"/>
+        <a:font script="Viet" typeface="Arial"/>
+        <a:font script="Uigh" typeface="Microsoft Uighur"/>
+        <a:font script="Geor" typeface="Sylfaen"/>
+        <a:font script="Armn" typeface="Arial"/>
+        <a:font script="Bugi" typeface="Leelawadee UI"/>
+        <a:font script="Bopo" typeface="Microsoft JhengHei"/>
+        <a:font script="Java" typeface="Javanese Text"/>
+        <a:font script="Lisu" typeface="Segoe UI"/>
+        <a:font script="Mymr" typeface="Myanmar Text"/>
+        <a:font script="Nkoo" typeface="Ebrima"/>
+        <a:font script="Olck" typeface="Nirmala UI"/>
+        <a:font script="Osma" typeface="Ebrima"/>
+        <a:font script="Phag" typeface="Phagspa"/>
+        <a:font script="Syrn" typeface="Estrangelo Edessa"/>
+        <a:font script="Syrj" typeface="Estrangelo Edessa"/>
+        <a:font script="Syre" typeface="Estrangelo Edessa"/>
+        <a:font script="Sora" typeface="Nirmala UI"/>
+        <a:font script="Tale" typeface="Microsoft Tai Le"/>
+        <a:font script="Talu" typeface="Microsoft New Tai Lue"/>
+        <a:font script="Tfng" typeface="Ebrima"/>
+      </a:minorFont>
+    </a:fontScheme>
+    <a:fmtScheme name="Office">
+      <a:fillStyleLst>
+        <a:solidFill>
+          <a:schemeClr val="phClr"/>
+        </a:solidFill>
+        <a:gradFill rotWithShape="1">
+          <a:gsLst>
+            <a:gs pos="0">
+              <a:schemeClr val="phClr">
+                <a:lumMod val="110000"/>
+                <a:satMod val="105000"/>
+                <a:tint val="67000"/>
+              </a:schemeClr>
+            </a:gs>
+            <a:gs pos="50000">
+              <a:schemeClr val="phClr">
+                <a:lumMod val="105000"/>
+                <a:satMod val="103000"/>
+                <a:tint val="73000"/>
+              </a:schemeClr>
+            </a:gs>
+            <a:gs pos="100000">
+              <a:schemeClr val="phClr">
+                <a:lumMod val="105000"/>
+                <a:satMod val="109000"/>
+                <a:tint val="81000"/>
+              </a:schemeClr>
+            </a:gs>
+          </a:gsLst>
+          <a:lin ang="5400000" scaled="0"/>
+        </a:gradFill>
+        <a:gradFill rotWithShape="1">
+          <a:gsLst>
+            <a:gs pos="0">
+              <a:schemeClr val="phClr">
+                <a:satMod val="103000"/>
+                <a:lumMod val="102000"/>
+                <a:tint val="94000"/>
+              </a:schemeClr>
+            </a:gs>
+            <a:gs pos="50000">
+              <a:schemeClr val="phClr">
+                <a:satMod val="110000"/>
+                <a:lumMod val="100000"/>
+                <a:shade val="100000"/>
+              </a:schemeClr>
+            </a:gs>
+            <a:gs pos="100000">
+              <a:schemeClr val="phClr">
+                <a:lumMod val="99000"/>
+                <a:satMod val="120000"/>
+                <a:shade val="78000"/>
+              </a:schemeClr>
+            </a:gs>
+          </a:gsLst>
+          <a:lin ang="5400000" scaled="0"/>
+        </a:gradFill>
+      </a:fillStyleLst>
+      <a:lnStyleLst>
+        <a:ln w="12700" cap="flat" cmpd="sng" algn="ctr">
+          <a:solidFill>
+            <a:schemeClr val="phClr"/>
+          </a:solidFill>
+          <a:prstDash val="solid"/>
+          <a:miter lim="800000"/>
+        </a:ln>
+        <a:ln w="19050" cap="flat" cmpd="sng" algn="ctr">
+          <a:solidFill>
+            <a:schemeClr val="phClr"/>
+          </a:solidFill>
+          <a:prstDash val="solid"/>
+          <a:miter lim="800000"/>
+        </a:ln>
+        <a:ln w="25400" cap="flat" cmpd="sng" algn="ctr">
+          <a:solidFill>
+            <a:schemeClr val="phClr"/>
+          </a:solidFill>
+          <a:prstDash val="solid"/>
+          <a:miter lim="800000"/>
+        </a:ln>
+      </a:lnStyleLst>
+      <a:effectStyleLst>
+        <a:effectStyle>
+          <a:effectLst/>
+        </a:effectStyle>
+        <a:effectStyle>
+          <a:effectLst/>
+        </a:effectStyle>
+        <a:effectStyle>
+          <a:effectLst>
+            <a:outerShdw blurRad="57150" dist="19050" dir="5400000" algn="ctr" rotWithShape="0">
+              <a:srgbClr val="000000">
+                <a:alpha val="63000"/>
+              </a:srgbClr>
+            </a:outerShdw>
+          </a:effectLst>
+        </a:effectStyle>
+      </a:effectStyleLst>
+      <a:bgFillStyleLst>
+        <a:solidFill>
+          <a:schemeClr val="phClr"/>
+        </a:solidFill>
+        <a:solidFill>
+          <a:schemeClr val="phClr">
+            <a:tint val="95000"/>
+            <a:satMod val="170000"/>
+          </a:schemeClr>
+        </a:solidFill>
+        <a:gradFill rotWithShape="1">
+          <a:gsLst>
+            <a:gs pos="0">
+              <a:schemeClr val="phClr">
+                <a:tint val="93000"/>
+                <a:satMod val="150000"/>
+                <a:shade val="98000"/>
+                <a:lumMod val="102000"/>
+              </a:schemeClr>
+            </a:gs>
+            <a:gs pos="50000">
+              <a:schemeClr val="phClr">
+                <a:tint val="98000"/>
+                <a:satMod val="130000"/>
+                <a:shade val="90000"/>
+                <a:lumMod val="103000"/>
+              </a:schemeClr>
+            </a:gs>
+            <a:gs pos="100000">
+              <a:schemeClr val="phClr">
+                <a:shade val="63000"/>
+                <a:satMod val="120000"/>
+              </a:schemeClr>
+            </a:gs>
+          </a:gsLst>
+          <a:lin ang="5400000" scaled="0"/>
+        </a:gradFill>
+      </a:bgFillStyleLst>
+    </a:fmtScheme>
+  </a:themeElements>
+  <a:objectDefaults>
+    <a:lnDef>
+      <a:spPr/>
+      <a:bodyPr/>
+      <a:lstStyle/>
+      <a:style>
+        <a:lnRef idx="2">
+          <a:schemeClr val="accent1"/>
+        </a:lnRef>
+        <a:fillRef idx="0">
+          <a:schemeClr val="accent1"/>
+        </a:fillRef>
+        <a:effectRef idx="1">
+          <a:schemeClr val="accent1"/>
+        </a:effectRef>
+        <a:fontRef idx="minor">
+          <a:schemeClr val="tx1"/>
+        </a:fontRef>
+      </a:style>
+    </a:lnDef>
+  </a:objectDefaults>
+  <a:extraClrSchemeLst/>
+  <a:extLst>
+    <a:ext uri="{05A4C25C-085E-4340-85A3-A5531E510DB2}">
+      <thm15:themeFamily xmlns:thm15="http://schemas.microsoft.com/office/thememl/2012/main" name="Office Theme" id="{2E142A2C-CD16-42D6-873A-C26D2A0506FA}" vid="{1BDDFF52-6CD6-40A5-AB3C-68EB2F1E4D0A}"/>
+    </a:ext>
+  </a:extLst>
+</a:theme>
+</file>
+
+<file path=docMetadata/LabelInfo.xml><?xml version="1.0" encoding="utf-8"?>
+<clbl:labelList xmlns:clbl="http://schemas.microsoft.com/office/2020/mipLabelMetadata">
+  <clbl:label id="{f42aa342-8706-4288-bd11-ebb85995028c}" enabled="1" method="Standard" siteId="{72f988bf-86f1-41af-91ab-2d7cd011db47}" contentBits="0" removed="0"/>
+</clbl:labelList>
 </file>
</xml_diff>

<commit_message>
Add a step 3 bonus built with the GitHub Copilot SDK
The new step-3-copilot-sdk folder is step 3 with one change: the assistant
runs on the GitHub Copilot SDK for Java instead of Spring AI. Copilot's agent
starts in empty mode with only the list_products tool, calls gpt-6-luna in
Microsoft Foundry with the app's managed identity, and deletes each session
after answering.

Also adds a slide on the Copilot SDK after step 3, and updates the README,
the workshop and presenter guides, and the Copilot instructions.

Tested with mvnw verify (6 tests), and deployed with azd up to
rg-trail-step3-copilot, where the example questions answer from the real
stock.

Co-authored-by: Copilot <223556219+Copilot@users.noreply.github.com>
</commit_message>
<xml_diff>
--- a/docs/trail-store-workshop.pptx
+++ b/docs/trail-store-workshop.pptx
@@ -15,6 +15,7 @@
     <p:sldId id="260" r:id="rId6"/>
     <p:sldId id="261" r:id="rId7"/>
     <p:sldId id="262" r:id="rId8"/>
+    <p:sldId id="268" r:id="rId19"/>
     <p:sldId id="263" r:id="rId9"/>
     <p:sldId id="264" r:id="rId10"/>
     <p:sldId id="265" r:id="rId11"/>
@@ -596,6 +597,93 @@
 </p:notes>
 </file>
 
+<file path=ppt/notesSlides/notesSlide13.xml><?xml version="1.0" encoding="utf-8"?>
+<p:notes xmlns:a="http://schemas.openxmlformats.org/drawingml/2006/main" xmlns:r="http://schemas.openxmlformats.org/officeDocument/2006/relationships" xmlns:p="http://schemas.openxmlformats.org/presentationml/2006/main">
+  <p:cSld>
+    <p:spTree>
+      <p:nvGrpSpPr>
+        <p:cNvPr id="1" name=""/>
+        <p:cNvGrpSpPr/>
+        <p:nvPr/>
+      </p:nvGrpSpPr>
+      <p:grpSpPr>
+        <a:xfrm>
+          <a:off x="0" y="0"/>
+          <a:ext cx="0" cy="0"/>
+          <a:chOff x="0" y="0"/>
+          <a:chExt cx="0" cy="0"/>
+        </a:xfrm>
+      </p:grpSpPr>
+      <p:sp>
+        <p:nvSpPr>
+          <p:cNvPr id="2" name="Slide Image Placeholder 1"/>
+          <p:cNvSpPr>
+            <a:spLocks noGrp="1" noRot="1" noChangeAspect="1"/>
+          </p:cNvSpPr>
+          <p:nvPr>
+            <p:ph type="sldImg"/>
+          </p:nvPr>
+        </p:nvSpPr>
+        <p:spPr/>
+      </p:sp>
+      <p:sp>
+        <p:nvSpPr>
+          <p:cNvPr id="3" name="Notes Placeholder 2"/>
+          <p:cNvSpPr>
+            <a:spLocks noGrp="1"/>
+          </p:cNvSpPr>
+          <p:nvPr>
+            <p:ph type="body" idx="1"/>
+          </p:nvPr>
+        </p:nvSpPr>
+        <p:spPr/>
+        <p:txBody>
+          <a:bodyPr/>
+          <a:lstStyle/>
+          <a:p>
+            <a:r>
+              <a:rPr lang="en-US" dirty="0"/>
+              <a:t>Two minutes, and nothing for the room to do. In step 3, Spring AI sends one question to the model, and the model can ask for one Java method. The GitHub Copilot SDK goes further: it runs Copilot's agent inside your own app. You give it a goal, and it plans and calls your Java tools, step by step, until the job is done. You still write the tools as Java methods, with @CopilotTool instead of @Tool. The Maven dependency is com.github:copilot-sdk-java. It works with a GitHub Copilot subscription, or with your own model in Microsoft Foundry, where the app signs in with its managed identity, as in step 3. The bonus folder, step-3-copilot-sdk, builds this same assistant with the SDK: show Assistant.java and its live app if you have time. Copilot's agent can run commands and edit files, so the app switches all of that off and allows only the one tool. Be clear that the SDK's Java releases are still labeled preview, and @CopilotTool is still marked experimental.</a:t>
+            </a:r>
+          </a:p>
+        </p:txBody>
+      </p:sp>
+      <p:sp>
+        <p:nvSpPr>
+          <p:cNvPr id="4" name="Slide Number Placeholder 3"/>
+          <p:cNvSpPr>
+            <a:spLocks noGrp="1"/>
+          </p:cNvSpPr>
+          <p:nvPr>
+            <p:ph type="sldNum" sz="quarter" idx="10"/>
+          </p:nvPr>
+        </p:nvSpPr>
+        <p:spPr/>
+        <p:txBody>
+          <a:bodyPr/>
+          <a:lstStyle/>
+          <a:p>
+            <a:fld id="{F7021451-1387-4CA6-816F-3879F97B5CBC}" type="slidenum">
+              <a:rPr lang="en-US"/>
+              <a:t>8</a:t>
+            </a:fld>
+            <a:endParaRPr lang="en-US"/>
+          </a:p>
+        </p:txBody>
+      </p:sp>
+    </p:spTree>
+    <p:extLst>
+      <p:ext uri="{BB962C8B-B14F-4D97-AF65-F5344CB8AC3E}">
+        <p14:creationId xmlns:p14="http://schemas.microsoft.com/office/powerpoint/2010/main" val="2713590247"/>
+      </p:ext>
+    </p:extLst>
+  </p:cSld>
+  <p:clrMapOvr>
+    <a:masterClrMapping/>
+  </p:clrMapOvr>
+</p:notes>
+</file>
+
 <file path=ppt/notesSlides/notesSlide2.xml><?xml version="1.0" encoding="utf-8"?>
 <p:notes xmlns:a="http://schemas.openxmlformats.org/drawingml/2006/main" xmlns:r="http://schemas.openxmlformats.org/officeDocument/2006/relationships" xmlns:p="http://schemas.openxmlformats.org/presentationml/2006/main">
   <p:cSld>
@@ -990,7 +1078,7 @@
           <a:p>
             <a:r>
               <a:rPr lang="en-US" dirty="0"/>
-              <a:t>Follow the numbers: two calls to the model, and one call to our own Java code in between. The model can't see our catalog, so we give it a tool: one method with @Tool. There are no API keys: they're switched off in Foundry, and the app signs in with its managed identity. Time: 12 minutes for step 3, including the next slide.</a:t>
+              <a:t>Follow the numbers: two calls to the model, and one call to our own Java code in between. The model can't see our catalog, so we give it a tool: one method with @Tool. There are no API keys: they're switched off in Foundry, and the app signs in with its managed identity. Time: 12 minutes for step 3, including the next two slides.</a:t>
             </a:r>
           </a:p>
         </p:txBody>
@@ -3493,7 +3581,7 @@
                 <a:ea typeface="Segoe UI" pitchFamily="34" charset="-122"/>
                 <a:cs typeface="Segoe UI" pitchFamily="34" charset="-120"/>
               </a:rPr>
-              <a:t>The managed identity has the Foundry User role. Keys are off: </a:t>
+              <a:t xml:space="preserve">The managed identity has the Foundry User role. Keys are off: </a:t>
             </a:r>
             <a:r>
               <a:rPr lang="en-US" sz="1500" dirty="0">
@@ -3720,7 +3808,7 @@
                 <a:ea typeface="Segoe UI" pitchFamily="34" charset="-122"/>
                 <a:cs typeface="Segoe UI" pitchFamily="34" charset="-120"/>
               </a:rPr>
-              <a:t>Two: it asks for </a:t>
+              <a:t xml:space="preserve">Two: it asks for </a:t>
             </a:r>
             <a:r>
               <a:rPr lang="en-US" sz="1500" dirty="0">
@@ -4018,7 +4106,7 @@
                 <a:ea typeface="Consolas" pitchFamily="34" charset="-122"/>
                 <a:cs typeface="Consolas" pitchFamily="34" charset="-120"/>
               </a:rPr>
-              <a:t>    # when you're done</a:t>
+              <a:t xml:space="preserve">    # when you're done</a:t>
             </a:r>
             <a:endParaRPr lang="en-US" sz="1600" dirty="0"/>
           </a:p>
@@ -4138,6 +4226,853 @@
               <a:t>github.com/roryp/spring-ai-webstore</a:t>
             </a:r>
             <a:endParaRPr lang="en-US" sz="1500" dirty="0"/>
+          </a:p>
+        </p:txBody>
+      </p:sp>
+    </p:spTree>
+  </p:cSld>
+  <p:clrMapOvr>
+    <a:masterClrMapping/>
+  </p:clrMapOvr>
+</p:sld>
+</file>
+
+<file path=ppt/slides/slide13.xml><?xml version="1.0" encoding="utf-8"?>
+<p:sld xmlns:a="http://schemas.openxmlformats.org/drawingml/2006/main" xmlns:r="http://schemas.openxmlformats.org/officeDocument/2006/relationships" xmlns:p="http://schemas.openxmlformats.org/presentationml/2006/main">
+  <p:cSld name="Copilot SDK">
+    <p:bg>
+      <p:bgPr>
+        <a:solidFill>
+          <a:srgbClr val="F7F4EF"/>
+        </a:solidFill>
+        <a:effectLst/>
+      </p:bgPr>
+    </p:bg>
+    <p:spTree>
+      <p:nvGrpSpPr>
+        <p:cNvPr id="1" name=""/>
+        <p:cNvGrpSpPr/>
+        <p:nvPr/>
+      </p:nvGrpSpPr>
+      <p:grpSpPr>
+        <a:xfrm>
+          <a:off x="0" y="0"/>
+          <a:ext cx="0" cy="0"/>
+          <a:chOff x="0" y="0"/>
+          <a:chExt cx="0" cy="0"/>
+        </a:xfrm>
+      </p:grpSpPr>
+      <p:sp>
+        <p:nvSpPr>
+          <p:cNvPr id="2" name="Title"/>
+          <p:cNvSpPr/>
+          <p:nvPr/>
+        </p:nvSpPr>
+        <p:spPr>
+          <a:xfrm>
+            <a:off x="548640" y="320040"/>
+            <a:ext cx="11064240" cy="566928"/>
+          </a:xfrm>
+          <a:prstGeom prst="rect">
+            <a:avLst/>
+          </a:prstGeom>
+          <a:noFill/>
+          <a:ln/>
+        </p:spPr>
+        <p:txBody>
+          <a:bodyPr wrap="square" lIns="0" tIns="0" rIns="0" bIns="0" rtlCol="0" anchor="ctr"/>
+          <a:lstStyle/>
+          <a:p>
+            <a:pPr marL="0" indent="0">
+              <a:buNone/>
+            </a:pPr>
+            <a:r>
+              <a:rPr lang="en-US" sz="3200" dirty="0">
+                <a:solidFill>
+                  <a:srgbClr val="5C2D91"/>
+                </a:solidFill>
+                <a:latin typeface="Segoe UI Semibold" pitchFamily="34" charset="0"/>
+                <a:ea typeface="Segoe UI Semibold" pitchFamily="34" charset="-122"/>
+                <a:cs typeface="Segoe UI Semibold" pitchFamily="34" charset="-120"/>
+              </a:rPr>
+              <a:t xml:space="preserve">Step 3   </a:t>
+            </a:r>
+            <a:r>
+              <a:rPr lang="en-US" sz="3200" dirty="0">
+                <a:solidFill>
+                  <a:srgbClr val="242424"/>
+                </a:solidFill>
+                <a:latin typeface="Segoe UI Semibold" pitchFamily="34" charset="0"/>
+                <a:ea typeface="Segoe UI Semibold" pitchFamily="34" charset="-122"/>
+                <a:cs typeface="Segoe UI Semibold" pitchFamily="34" charset="-120"/>
+              </a:rPr>
+              <a:t>Going further: the GitHub Copilot SDK</a:t>
+            </a:r>
+            <a:endParaRPr lang="en-US" sz="3200" dirty="0"/>
+          </a:p>
+        </p:txBody>
+      </p:sp>
+      <p:sp>
+        <p:nvSpPr>
+          <p:cNvPr id="3" name="Saw card"/>
+          <p:cNvSpPr/>
+          <p:nvPr/>
+        </p:nvSpPr>
+        <p:spPr>
+          <a:xfrm>
+            <a:off x="548640" y="1325880"/>
+            <a:ext cx="5134356" cy="2468880"/>
+          </a:xfrm>
+          <a:prstGeom prst="rect">
+            <a:avLst/>
+          </a:prstGeom>
+          <a:solidFill>
+            <a:srgbClr val="FFFFFF"/>
+          </a:solidFill>
+          <a:ln w="9525">
+            <a:solidFill>
+              <a:srgbClr val="DEDEDE"/>
+            </a:solidFill>
+            <a:prstDash val="solid"/>
+          </a:ln>
+          <a:effectLst>
+            <a:outerShdw blurRad="101600" dist="25400" dir="5400000" algn="bl" rotWithShape="0">
+              <a:srgbClr val="000000">
+                <a:alpha val="12000"/>
+              </a:srgbClr>
+            </a:outerShdw>
+          </a:effectLst>
+        </p:spPr>
+        <p:txBody>
+          <a:bodyPr/>
+          <a:lstStyle/>
+          <a:p>
+            <a:endParaRPr lang="en-US"/>
+          </a:p>
+        </p:txBody>
+      </p:sp>
+      <p:sp>
+        <p:nvSpPr>
+          <p:cNvPr id="4" name="Saw card bar"/>
+          <p:cNvSpPr/>
+          <p:nvPr/>
+        </p:nvSpPr>
+        <p:spPr>
+          <a:xfrm>
+            <a:off x="548640" y="1325880"/>
+            <a:ext cx="82296" cy="2468880"/>
+          </a:xfrm>
+          <a:prstGeom prst="rect">
+            <a:avLst/>
+          </a:prstGeom>
+          <a:solidFill>
+            <a:srgbClr val="5C2D91"/>
+          </a:solidFill>
+          <a:ln w="12700">
+            <a:solidFill>
+              <a:srgbClr val="5C2D91"/>
+            </a:solidFill>
+            <a:prstDash val="solid"/>
+          </a:ln>
+        </p:spPr>
+        <p:txBody>
+          <a:bodyPr/>
+          <a:lstStyle/>
+          <a:p>
+            <a:endParaRPr lang="en-US"/>
+          </a:p>
+        </p:txBody>
+      </p:sp>
+      <p:sp>
+        <p:nvSpPr>
+          <p:cNvPr id="5" name="Saw label"/>
+          <p:cNvSpPr/>
+          <p:nvPr/>
+        </p:nvSpPr>
+        <p:spPr>
+          <a:xfrm>
+            <a:off x="914400" y="1645920"/>
+            <a:ext cx="4494276" cy="228600"/>
+          </a:xfrm>
+          <a:prstGeom prst="rect">
+            <a:avLst/>
+          </a:prstGeom>
+          <a:noFill/>
+          <a:ln/>
+        </p:spPr>
+        <p:txBody>
+          <a:bodyPr wrap="square" lIns="0" tIns="0" rIns="0" bIns="0" rtlCol="0" anchor="t"/>
+          <a:lstStyle/>
+          <a:p>
+            <a:pPr marL="0" indent="0">
+              <a:buNone/>
+            </a:pPr>
+            <a:r>
+              <a:rPr lang="en-US" sz="1300" kern="0" spc="300" dirty="0">
+                <a:solidFill>
+                  <a:srgbClr val="5C2D91"/>
+                </a:solidFill>
+                <a:latin typeface="Segoe UI Semibold" pitchFamily="34" charset="0"/>
+                <a:ea typeface="Segoe UI Semibold" pitchFamily="34" charset="-122"/>
+                <a:cs typeface="Segoe UI Semibold" pitchFamily="34" charset="-120"/>
+              </a:rPr>
+              <a:t>WHAT YOU JUST SAW</a:t>
+            </a:r>
+            <a:endParaRPr lang="en-US" sz="1300" dirty="0"/>
+          </a:p>
+        </p:txBody>
+      </p:sp>
+      <p:sp>
+        <p:nvSpPr>
+          <p:cNvPr id="6" name="Saw heading"/>
+          <p:cNvSpPr/>
+          <p:nvPr/>
+        </p:nvSpPr>
+        <p:spPr>
+          <a:xfrm>
+            <a:off x="914400" y="1965960"/>
+            <a:ext cx="4494276" cy="411480"/>
+          </a:xfrm>
+          <a:prstGeom prst="rect">
+            <a:avLst/>
+          </a:prstGeom>
+          <a:noFill/>
+          <a:ln/>
+        </p:spPr>
+        <p:txBody>
+          <a:bodyPr wrap="square" lIns="0" tIns="0" rIns="0" bIns="0" rtlCol="0" anchor="t"/>
+          <a:lstStyle/>
+          <a:p>
+            <a:pPr marL="0" indent="0">
+              <a:buNone/>
+            </a:pPr>
+            <a:r>
+              <a:rPr lang="en-US" sz="2400" dirty="0">
+                <a:solidFill>
+                  <a:srgbClr val="242424"/>
+                </a:solidFill>
+                <a:latin typeface="Segoe UI Semibold" pitchFamily="34" charset="0"/>
+                <a:ea typeface="Segoe UI Semibold" pitchFamily="34" charset="-122"/>
+                <a:cs typeface="Segoe UI Semibold" pitchFamily="34" charset="-120"/>
+              </a:rPr>
+              <a:t>One question, one tool</a:t>
+            </a:r>
+            <a:endParaRPr lang="en-US" sz="2400" dirty="0"/>
+          </a:p>
+        </p:txBody>
+      </p:sp>
+      <p:sp>
+        <p:nvSpPr>
+          <p:cNvPr id="7" name="Saw body"/>
+          <p:cNvSpPr/>
+          <p:nvPr/>
+        </p:nvSpPr>
+        <p:spPr>
+          <a:xfrm>
+            <a:off x="914400" y="2468880"/>
+            <a:ext cx="4494276" cy="594360"/>
+          </a:xfrm>
+          <a:prstGeom prst="rect">
+            <a:avLst/>
+          </a:prstGeom>
+          <a:noFill/>
+          <a:ln/>
+        </p:spPr>
+        <p:txBody>
+          <a:bodyPr wrap="square" lIns="0" tIns="0" rIns="0" bIns="0" rtlCol="0" anchor="t"/>
+          <a:lstStyle/>
+          <a:p>
+            <a:pPr marL="0" indent="0">
+              <a:buNone/>
+            </a:pPr>
+            <a:r>
+              <a:rPr lang="en-US" sz="1600" dirty="0">
+                <a:solidFill>
+                  <a:srgbClr val="242424"/>
+                </a:solidFill>
+                <a:latin typeface="Segoe UI" pitchFamily="34" charset="0"/>
+                <a:ea typeface="Segoe UI" pitchFamily="34" charset="-122"/>
+                <a:cs typeface="Segoe UI" pitchFamily="34" charset="-120"/>
+              </a:rPr>
+              <a:t>In this app, the model asks to run your Java method, then answers your question.</a:t>
+            </a:r>
+            <a:endParaRPr lang="en-US" sz="1600" dirty="0"/>
+          </a:p>
+        </p:txBody>
+      </p:sp>
+      <p:sp>
+        <p:nvSpPr>
+          <p:cNvPr id="8" name="Saw code"/>
+          <p:cNvSpPr/>
+          <p:nvPr/>
+        </p:nvSpPr>
+        <p:spPr>
+          <a:xfrm>
+            <a:off x="914400" y="3200400"/>
+            <a:ext cx="4494276" cy="274320"/>
+          </a:xfrm>
+          <a:prstGeom prst="rect">
+            <a:avLst/>
+          </a:prstGeom>
+          <a:noFill/>
+          <a:ln/>
+        </p:spPr>
+        <p:txBody>
+          <a:bodyPr wrap="square" lIns="0" tIns="0" rIns="0" bIns="0" rtlCol="0" anchor="t"/>
+          <a:lstStyle/>
+          <a:p>
+            <a:pPr marL="0" indent="0">
+              <a:buNone/>
+            </a:pPr>
+            <a:r>
+              <a:rPr lang="en-US" sz="1600" dirty="0">
+                <a:solidFill>
+                  <a:srgbClr val="5C2D91"/>
+                </a:solidFill>
+                <a:latin typeface="Consolas" pitchFamily="34" charset="0"/>
+                <a:ea typeface="Consolas" pitchFamily="34" charset="-122"/>
+                <a:cs typeface="Consolas" pitchFamily="34" charset="-120"/>
+              </a:rPr>
+              <a:t>@Tool</a:t>
+            </a:r>
+            <a:r>
+              <a:rPr lang="en-US" sz="1600" dirty="0">
+                <a:solidFill>
+                  <a:srgbClr val="242424"/>
+                </a:solidFill>
+                <a:latin typeface="Consolas" pitchFamily="34" charset="0"/>
+                <a:ea typeface="Consolas" pitchFamily="34" charset="-122"/>
+                <a:cs typeface="Consolas" pitchFamily="34" charset="-120"/>
+              </a:rPr>
+              <a:t xml:space="preserve"> listProducts()</a:t>
+            </a:r>
+            <a:endParaRPr lang="en-US" sz="1600" dirty="0"/>
+          </a:p>
+        </p:txBody>
+      </p:sp>
+      <p:cxnSp>
+        <p:nvCxnSpPr>
+          <p:cNvPr id="9" name="Arrow"/>
+          <p:cNvCxnSpPr/>
+          <p:nvPr/>
+        </p:nvCxnSpPr>
+        <p:spPr>
+          <a:xfrm>
+            <a:off x="5957316" y="2560320"/>
+            <a:ext cx="274320" cy="0"/>
+          </a:xfrm>
+          <a:prstGeom prst="straightConnector1">
+            <a:avLst/>
+          </a:prstGeom>
+          <a:ln w="28575">
+            <a:solidFill>
+              <a:srgbClr val="5C2D91"/>
+            </a:solidFill>
+            <a:tailEnd type="triangle" w="med" len="med"/>
+          </a:ln>
+        </p:spPr>
+      </p:cxnSp>
+      <p:sp>
+        <p:nvSpPr>
+          <p:cNvPr id="10" name="SDK card"/>
+          <p:cNvSpPr/>
+          <p:nvPr/>
+        </p:nvSpPr>
+        <p:spPr>
+          <a:xfrm>
+            <a:off x="6505956" y="1325880"/>
+            <a:ext cx="5134356" cy="2468880"/>
+          </a:xfrm>
+          <a:prstGeom prst="rect">
+            <a:avLst/>
+          </a:prstGeom>
+          <a:solidFill>
+            <a:srgbClr val="FFFFFF"/>
+          </a:solidFill>
+          <a:ln w="9525">
+            <a:solidFill>
+              <a:srgbClr val="DEDEDE"/>
+            </a:solidFill>
+            <a:prstDash val="solid"/>
+          </a:ln>
+          <a:effectLst>
+            <a:outerShdw blurRad="101600" dist="25400" dir="5400000" algn="bl" rotWithShape="0">
+              <a:srgbClr val="000000">
+                <a:alpha val="12000"/>
+              </a:srgbClr>
+            </a:outerShdw>
+          </a:effectLst>
+        </p:spPr>
+        <p:txBody>
+          <a:bodyPr/>
+          <a:lstStyle/>
+          <a:p>
+            <a:endParaRPr lang="en-US"/>
+          </a:p>
+        </p:txBody>
+      </p:sp>
+      <p:sp>
+        <p:nvSpPr>
+          <p:cNvPr id="11" name="SDK card bar"/>
+          <p:cNvSpPr/>
+          <p:nvPr/>
+        </p:nvSpPr>
+        <p:spPr>
+          <a:xfrm>
+            <a:off x="6505956" y="1325880"/>
+            <a:ext cx="82296" cy="2468880"/>
+          </a:xfrm>
+          <a:prstGeom prst="rect">
+            <a:avLst/>
+          </a:prstGeom>
+          <a:solidFill>
+            <a:srgbClr val="5C2D91"/>
+          </a:solidFill>
+          <a:ln w="12700">
+            <a:solidFill>
+              <a:srgbClr val="5C2D91"/>
+            </a:solidFill>
+            <a:prstDash val="solid"/>
+          </a:ln>
+        </p:spPr>
+        <p:txBody>
+          <a:bodyPr/>
+          <a:lstStyle/>
+          <a:p>
+            <a:endParaRPr lang="en-US"/>
+          </a:p>
+        </p:txBody>
+      </p:sp>
+      <p:sp>
+        <p:nvSpPr>
+          <p:cNvPr id="12" name="SDK label"/>
+          <p:cNvSpPr/>
+          <p:nvPr/>
+        </p:nvSpPr>
+        <p:spPr>
+          <a:xfrm>
+            <a:off x="6871716" y="1645920"/>
+            <a:ext cx="4494276" cy="228600"/>
+          </a:xfrm>
+          <a:prstGeom prst="rect">
+            <a:avLst/>
+          </a:prstGeom>
+          <a:noFill/>
+          <a:ln/>
+        </p:spPr>
+        <p:txBody>
+          <a:bodyPr wrap="square" lIns="0" tIns="0" rIns="0" bIns="0" rtlCol="0" anchor="t"/>
+          <a:lstStyle/>
+          <a:p>
+            <a:pPr marL="0" indent="0">
+              <a:buNone/>
+            </a:pPr>
+            <a:r>
+              <a:rPr lang="en-US" sz="1300" kern="0" spc="300" dirty="0">
+                <a:solidFill>
+                  <a:srgbClr val="5C2D91"/>
+                </a:solidFill>
+                <a:latin typeface="Segoe UI Semibold" pitchFamily="34" charset="0"/>
+                <a:ea typeface="Segoe UI Semibold" pitchFamily="34" charset="-122"/>
+                <a:cs typeface="Segoe UI Semibold" pitchFamily="34" charset="-120"/>
+              </a:rPr>
+              <a:t>WITH THE COPILOT SDK</a:t>
+            </a:r>
+            <a:endParaRPr lang="en-US" sz="1300" dirty="0"/>
+          </a:p>
+        </p:txBody>
+      </p:sp>
+      <p:sp>
+        <p:nvSpPr>
+          <p:cNvPr id="13" name="SDK heading"/>
+          <p:cNvSpPr/>
+          <p:nvPr/>
+        </p:nvSpPr>
+        <p:spPr>
+          <a:xfrm>
+            <a:off x="6871716" y="1965960"/>
+            <a:ext cx="4494276" cy="411480"/>
+          </a:xfrm>
+          <a:prstGeom prst="rect">
+            <a:avLst/>
+          </a:prstGeom>
+          <a:noFill/>
+          <a:ln/>
+        </p:spPr>
+        <p:txBody>
+          <a:bodyPr wrap="square" lIns="0" tIns="0" rIns="0" bIns="0" rtlCol="0" anchor="t"/>
+          <a:lstStyle/>
+          <a:p>
+            <a:pPr marL="0" indent="0">
+              <a:buNone/>
+            </a:pPr>
+            <a:r>
+              <a:rPr lang="en-US" sz="2400" dirty="0">
+                <a:solidFill>
+                  <a:srgbClr val="242424"/>
+                </a:solidFill>
+                <a:latin typeface="Segoe UI Semibold" pitchFamily="34" charset="0"/>
+                <a:ea typeface="Segoe UI Semibold" pitchFamily="34" charset="-122"/>
+                <a:cs typeface="Segoe UI Semibold" pitchFamily="34" charset="-120"/>
+              </a:rPr>
+              <a:t>One goal, many steps</a:t>
+            </a:r>
+            <a:endParaRPr lang="en-US" sz="2400" dirty="0"/>
+          </a:p>
+        </p:txBody>
+      </p:sp>
+      <p:sp>
+        <p:nvSpPr>
+          <p:cNvPr id="14" name="SDK body"/>
+          <p:cNvSpPr/>
+          <p:nvPr/>
+        </p:nvSpPr>
+        <p:spPr>
+          <a:xfrm>
+            <a:off x="6871716" y="2468880"/>
+            <a:ext cx="4494276" cy="594360"/>
+          </a:xfrm>
+          <a:prstGeom prst="rect">
+            <a:avLst/>
+          </a:prstGeom>
+          <a:noFill/>
+          <a:ln/>
+        </p:spPr>
+        <p:txBody>
+          <a:bodyPr wrap="square" lIns="0" tIns="0" rIns="0" bIns="0" rtlCol="0" anchor="t"/>
+          <a:lstStyle/>
+          <a:p>
+            <a:pPr marL="0" indent="0">
+              <a:buNone/>
+            </a:pPr>
+            <a:r>
+              <a:rPr lang="en-US" sz="1600" dirty="0">
+                <a:solidFill>
+                  <a:srgbClr val="242424"/>
+                </a:solidFill>
+                <a:latin typeface="Segoe UI" pitchFamily="34" charset="0"/>
+                <a:ea typeface="Segoe UI" pitchFamily="34" charset="-122"/>
+                <a:cs typeface="Segoe UI" pitchFamily="34" charset="-120"/>
+              </a:rPr>
+              <a:t>Copilot's agent runs in your app. It plans and calls your Java tools until the job is done.</a:t>
+            </a:r>
+            <a:endParaRPr lang="en-US" sz="1600" dirty="0"/>
+          </a:p>
+        </p:txBody>
+      </p:sp>
+      <p:sp>
+        <p:nvSpPr>
+          <p:cNvPr id="15" name="SDK code"/>
+          <p:cNvSpPr/>
+          <p:nvPr/>
+        </p:nvSpPr>
+        <p:spPr>
+          <a:xfrm>
+            <a:off x="6871716" y="3200400"/>
+            <a:ext cx="4494276" cy="274320"/>
+          </a:xfrm>
+          <a:prstGeom prst="rect">
+            <a:avLst/>
+          </a:prstGeom>
+          <a:noFill/>
+          <a:ln/>
+        </p:spPr>
+        <p:txBody>
+          <a:bodyPr wrap="square" lIns="0" tIns="0" rIns="0" bIns="0" rtlCol="0" anchor="t"/>
+          <a:lstStyle/>
+          <a:p>
+            <a:pPr marL="0" indent="0">
+              <a:buNone/>
+            </a:pPr>
+            <a:r>
+              <a:rPr lang="en-US" sz="1600" dirty="0">
+                <a:solidFill>
+                  <a:srgbClr val="5C2D91"/>
+                </a:solidFill>
+                <a:latin typeface="Consolas" pitchFamily="34" charset="0"/>
+                <a:ea typeface="Consolas" pitchFamily="34" charset="-122"/>
+                <a:cs typeface="Consolas" pitchFamily="34" charset="-120"/>
+              </a:rPr>
+              <a:t>@CopilotTool</a:t>
+            </a:r>
+            <a:r>
+              <a:rPr lang="en-US" sz="1600" dirty="0">
+                <a:solidFill>
+                  <a:srgbClr val="242424"/>
+                </a:solidFill>
+                <a:latin typeface="Consolas" pitchFamily="34" charset="0"/>
+                <a:ea typeface="Consolas" pitchFamily="34" charset="-122"/>
+                <a:cs typeface="Consolas" pitchFamily="34" charset="-120"/>
+              </a:rPr>
+              <a:t xml:space="preserve"> listProducts()</a:t>
+            </a:r>
+            <a:endParaRPr lang="en-US" sz="1600" dirty="0"/>
+          </a:p>
+        </p:txBody>
+      </p:sp>
+      <p:sp>
+        <p:nvSpPr>
+          <p:cNvPr id="16" name="Java card"/>
+          <p:cNvSpPr/>
+          <p:nvPr/>
+        </p:nvSpPr>
+        <p:spPr>
+          <a:xfrm>
+            <a:off x="548640" y="4114800"/>
+            <a:ext cx="11091672" cy="1554480"/>
+          </a:xfrm>
+          <a:prstGeom prst="rect">
+            <a:avLst/>
+          </a:prstGeom>
+          <a:solidFill>
+            <a:srgbClr val="FFFFFF"/>
+          </a:solidFill>
+          <a:ln w="9525">
+            <a:solidFill>
+              <a:srgbClr val="DEDEDE"/>
+            </a:solidFill>
+            <a:prstDash val="solid"/>
+          </a:ln>
+          <a:effectLst>
+            <a:outerShdw blurRad="101600" dist="25400" dir="5400000" algn="bl" rotWithShape="0">
+              <a:srgbClr val="000000">
+                <a:alpha val="12000"/>
+              </a:srgbClr>
+            </a:outerShdw>
+          </a:effectLst>
+        </p:spPr>
+        <p:txBody>
+          <a:bodyPr/>
+          <a:lstStyle/>
+          <a:p>
+            <a:endParaRPr lang="en-US"/>
+          </a:p>
+        </p:txBody>
+      </p:sp>
+      <p:sp>
+        <p:nvSpPr>
+          <p:cNvPr id="17" name="Java card bar"/>
+          <p:cNvSpPr/>
+          <p:nvPr/>
+        </p:nvSpPr>
+        <p:spPr>
+          <a:xfrm>
+            <a:off x="548640" y="4114800"/>
+            <a:ext cx="82296" cy="1554480"/>
+          </a:xfrm>
+          <a:prstGeom prst="rect">
+            <a:avLst/>
+          </a:prstGeom>
+          <a:solidFill>
+            <a:srgbClr val="5C2D91"/>
+          </a:solidFill>
+          <a:ln w="12700">
+            <a:solidFill>
+              <a:srgbClr val="5C2D91"/>
+            </a:solidFill>
+            <a:prstDash val="solid"/>
+          </a:ln>
+        </p:spPr>
+        <p:txBody>
+          <a:bodyPr/>
+          <a:lstStyle/>
+          <a:p>
+            <a:endParaRPr lang="en-US"/>
+          </a:p>
+        </p:txBody>
+      </p:sp>
+      <p:sp>
+        <p:nvSpPr>
+          <p:cNvPr id="18" name="Maven label"/>
+          <p:cNvSpPr/>
+          <p:nvPr/>
+        </p:nvSpPr>
+        <p:spPr>
+          <a:xfrm>
+            <a:off x="914400" y="4434840"/>
+            <a:ext cx="4494276" cy="228600"/>
+          </a:xfrm>
+          <a:prstGeom prst="rect">
+            <a:avLst/>
+          </a:prstGeom>
+          <a:noFill/>
+          <a:ln/>
+        </p:spPr>
+        <p:txBody>
+          <a:bodyPr wrap="square" lIns="0" tIns="0" rIns="0" bIns="0" rtlCol="0" anchor="t"/>
+          <a:lstStyle/>
+          <a:p>
+            <a:pPr marL="0" indent="0">
+              <a:buNone/>
+            </a:pPr>
+            <a:r>
+              <a:rPr lang="en-US" sz="1300" kern="0" spc="300" dirty="0">
+                <a:solidFill>
+                  <a:srgbClr val="5C2D91"/>
+                </a:solidFill>
+                <a:latin typeface="Segoe UI Semibold" pitchFamily="34" charset="0"/>
+                <a:ea typeface="Segoe UI Semibold" pitchFamily="34" charset="-122"/>
+                <a:cs typeface="Segoe UI Semibold" pitchFamily="34" charset="-120"/>
+              </a:rPr>
+              <a:t>MAVEN DEPENDENCY</a:t>
+            </a:r>
+            <a:endParaRPr lang="en-US" sz="1300" dirty="0"/>
+          </a:p>
+        </p:txBody>
+      </p:sp>
+      <p:sp>
+        <p:nvSpPr>
+          <p:cNvPr id="19" name="Maven artifact"/>
+          <p:cNvSpPr/>
+          <p:nvPr/>
+        </p:nvSpPr>
+        <p:spPr>
+          <a:xfrm>
+            <a:off x="914400" y="4754880"/>
+            <a:ext cx="4494276" cy="274320"/>
+          </a:xfrm>
+          <a:prstGeom prst="rect">
+            <a:avLst/>
+          </a:prstGeom>
+          <a:noFill/>
+          <a:ln/>
+        </p:spPr>
+        <p:txBody>
+          <a:bodyPr wrap="square" lIns="0" tIns="0" rIns="0" bIns="0" rtlCol="0" anchor="t"/>
+          <a:lstStyle/>
+          <a:p>
+            <a:pPr marL="0" indent="0">
+              <a:buNone/>
+            </a:pPr>
+            <a:r>
+              <a:rPr lang="en-US" sz="1600" dirty="0">
+                <a:solidFill>
+                  <a:srgbClr val="242424"/>
+                </a:solidFill>
+                <a:latin typeface="Consolas" pitchFamily="34" charset="0"/>
+                <a:ea typeface="Consolas" pitchFamily="34" charset="-122"/>
+                <a:cs typeface="Consolas" pitchFamily="34" charset="-120"/>
+              </a:rPr>
+              <a:t>com.github:copilot-sdk-java</a:t>
+            </a:r>
+            <a:endParaRPr lang="en-US" sz="1600" dirty="0"/>
+          </a:p>
+        </p:txBody>
+      </p:sp>
+      <p:sp>
+        <p:nvSpPr>
+          <p:cNvPr id="20" name="Works with label"/>
+          <p:cNvSpPr/>
+          <p:nvPr/>
+        </p:nvSpPr>
+        <p:spPr>
+          <a:xfrm>
+            <a:off x="6871716" y="4434840"/>
+            <a:ext cx="4494276" cy="228600"/>
+          </a:xfrm>
+          <a:prstGeom prst="rect">
+            <a:avLst/>
+          </a:prstGeom>
+          <a:noFill/>
+          <a:ln/>
+        </p:spPr>
+        <p:txBody>
+          <a:bodyPr wrap="square" lIns="0" tIns="0" rIns="0" bIns="0" rtlCol="0" anchor="t"/>
+          <a:lstStyle/>
+          <a:p>
+            <a:pPr marL="0" indent="0">
+              <a:buNone/>
+            </a:pPr>
+            <a:r>
+              <a:rPr lang="en-US" sz="1300" kern="0" spc="300" dirty="0">
+                <a:solidFill>
+                  <a:srgbClr val="5C2D91"/>
+                </a:solidFill>
+                <a:latin typeface="Segoe UI Semibold" pitchFamily="34" charset="0"/>
+                <a:ea typeface="Segoe UI Semibold" pitchFamily="34" charset="-122"/>
+                <a:cs typeface="Segoe UI Semibold" pitchFamily="34" charset="-120"/>
+              </a:rPr>
+              <a:t>WORKS WITH</a:t>
+            </a:r>
+            <a:endParaRPr lang="en-US" sz="1300" dirty="0"/>
+          </a:p>
+        </p:txBody>
+      </p:sp>
+      <p:sp>
+        <p:nvSpPr>
+          <p:cNvPr id="21" name="Works with text"/>
+          <p:cNvSpPr/>
+          <p:nvPr/>
+        </p:nvSpPr>
+        <p:spPr>
+          <a:xfrm>
+            <a:off x="6871716" y="4754880"/>
+            <a:ext cx="4494276" cy="594360"/>
+          </a:xfrm>
+          <a:prstGeom prst="rect">
+            <a:avLst/>
+          </a:prstGeom>
+          <a:noFill/>
+          <a:ln/>
+        </p:spPr>
+        <p:txBody>
+          <a:bodyPr wrap="square" lIns="0" tIns="0" rIns="0" bIns="0" rtlCol="0" anchor="t"/>
+          <a:lstStyle/>
+          <a:p>
+            <a:pPr marL="0" indent="0">
+              <a:buNone/>
+            </a:pPr>
+            <a:r>
+              <a:rPr lang="en-US" sz="1600" dirty="0">
+                <a:solidFill>
+                  <a:srgbClr val="242424"/>
+                </a:solidFill>
+                <a:latin typeface="Segoe UI" pitchFamily="34" charset="0"/>
+                <a:ea typeface="Segoe UI" pitchFamily="34" charset="-122"/>
+                <a:cs typeface="Segoe UI" pitchFamily="34" charset="-120"/>
+              </a:rPr>
+              <a:t>A GitHub Copilot subscription, or your own Foundry model with managed identity. No keys.</a:t>
+            </a:r>
+            <a:endParaRPr lang="en-US" sz="1600" dirty="0"/>
+          </a:p>
+        </p:txBody>
+      </p:sp>
+      <p:sp>
+        <p:nvSpPr>
+          <p:cNvPr id="22" name="Footnote"/>
+          <p:cNvSpPr/>
+          <p:nvPr/>
+        </p:nvSpPr>
+        <p:spPr>
+          <a:xfrm>
+            <a:off x="548640" y="5943600"/>
+            <a:ext cx="11091672" cy="274320"/>
+          </a:xfrm>
+          <a:prstGeom prst="rect">
+            <a:avLst/>
+          </a:prstGeom>
+          <a:noFill/>
+          <a:ln/>
+        </p:spPr>
+        <p:txBody>
+          <a:bodyPr wrap="square" lIns="0" tIns="0" rIns="0" bIns="0" rtlCol="0" anchor="t"/>
+          <a:lstStyle/>
+          <a:p>
+            <a:pPr marL="0" indent="0">
+              <a:buNone/>
+            </a:pPr>
+            <a:r>
+              <a:rPr lang="en-US" sz="1200" dirty="0">
+                <a:solidFill>
+                  <a:srgbClr val="5C5C5C"/>
+                </a:solidFill>
+                <a:latin typeface="Segoe UI" pitchFamily="34" charset="0"/>
+                <a:ea typeface="Segoe UI" pitchFamily="34" charset="-122"/>
+                <a:cs typeface="Segoe UI" pitchFamily="34" charset="-120"/>
+              </a:rPr>
+              <a:t>See it working in the step-3-copilot-sdk folder. The SDK's Java releases are still labeled preview. Learn more at github.com/github/copilot-sdk</a:t>
+            </a:r>
+            <a:endParaRPr lang="en-US" sz="1200" dirty="0"/>
           </a:p>
         </p:txBody>
       </p:sp>
@@ -5292,7 +6227,7 @@
                 <a:ea typeface="Segoe UI" pitchFamily="34" charset="-122"/>
                 <a:cs typeface="Segoe UI" pitchFamily="34" charset="-120"/>
               </a:rPr>
-              <a:t> </a:t>
+              <a:t xml:space="preserve"> </a:t>
             </a:r>
             <a:endParaRPr lang="en-US" sz="1500" dirty="0"/>
           </a:p>
@@ -5948,7 +6883,7 @@
                 <a:ea typeface="Segoe UI Semibold" pitchFamily="34" charset="-122"/>
                 <a:cs typeface="Segoe UI Semibold" pitchFamily="34" charset="-120"/>
               </a:rPr>
-              <a:t>Step 1   </a:t>
+              <a:t xml:space="preserve">Step 1   </a:t>
             </a:r>
             <a:r>
               <a:rPr lang="en-US" sz="3200" dirty="0">
@@ -6299,7 +7234,7 @@
                 <a:ea typeface="Segoe UI Semibold" pitchFamily="34" charset="-122"/>
                 <a:cs typeface="Segoe UI Semibold" pitchFamily="34" charset="-120"/>
               </a:rPr>
-              <a:t>Step 2   </a:t>
+              <a:t xml:space="preserve">Step 2   </a:t>
             </a:r>
             <a:r>
               <a:rPr lang="en-US" sz="3200" dirty="0">
@@ -6650,7 +7585,7 @@
                 <a:ea typeface="Segoe UI Semibold" pitchFamily="34" charset="-122"/>
                 <a:cs typeface="Segoe UI Semibold" pitchFamily="34" charset="-120"/>
               </a:rPr>
-              <a:t>Step 3   </a:t>
+              <a:t xml:space="preserve">Step 3   </a:t>
             </a:r>
             <a:r>
               <a:rPr lang="en-US" sz="3200" dirty="0">
@@ -7544,7 +8479,7 @@
                 <a:ea typeface="Segoe UI Semibold" pitchFamily="34" charset="-122"/>
                 <a:cs typeface="Segoe UI Semibold" pitchFamily="34" charset="-120"/>
               </a:rPr>
-              <a:t>Step 4   </a:t>
+              <a:t xml:space="preserve">Step 4   </a:t>
             </a:r>
             <a:r>
               <a:rPr lang="en-US" sz="3200" dirty="0">
@@ -7895,7 +8830,7 @@
                 <a:ea typeface="Segoe UI Semibold" pitchFamily="34" charset="-122"/>
                 <a:cs typeface="Segoe UI Semibold" pitchFamily="34" charset="-120"/>
               </a:rPr>
-              <a:t>Step 4   </a:t>
+              <a:t xml:space="preserve">Step 4   </a:t>
             </a:r>
             <a:r>
               <a:rPr lang="en-US" sz="3200" dirty="0">

</xml_diff>

<commit_message>
Show both Copilot SDK dependencies on the SDK slide
The app needs copilot-sdk-java and copilot-sdk-java-runtime, so the slide
now lists both. "No keys" now applies only to Foundry with managed identity,
because a GitHub Copilot subscription needs a GitHub token.

Co-authored-by: Copilot <223556219+Copilot@users.noreply.github.com>
</commit_message>
<xml_diff>
--- a/docs/trail-store-workshop.pptx
+++ b/docs/trail-store-workshop.pptx
@@ -643,7 +643,7 @@
           <a:p>
             <a:r>
               <a:rPr lang="en-US" dirty="0"/>
-              <a:t>Two minutes, and nothing for the room to do. In step 3, Spring AI sends one question to the model, and the model can ask for one Java method. The GitHub Copilot SDK goes further: it runs Copilot's agent inside your own app. You give it a goal, and it plans and calls your Java tools, step by step, until the job is done. You still write the tools as Java methods, with @CopilotTool instead of @Tool. The Maven dependency is com.github:copilot-sdk-java. It works with a GitHub Copilot subscription, or with your own model in Microsoft Foundry, where the app signs in with its managed identity, as in step 3. The bonus folder, step-3-copilot-sdk, builds this same assistant with the SDK: show Assistant.java and its live app if you have time. Copilot's agent can run commands and edit files, so the app switches all of that off and allows only the one tool. Be clear that the SDK's Java releases are still labeled preview, and @CopilotTool is still marked experimental.</a:t>
+              <a:t>Two minutes, and nothing for the room to do. In step 3, Spring AI sends one question to the model, and the model can ask for one Java method. The GitHub Copilot SDK goes further: it runs Copilot's agent inside your own app. You give it a goal, and it plans and calls your Java tools, step by step, until the job is done. You still write the tools as Java methods, with @CopilotTool instead of @Tool. You add two Maven dependencies: copilot-sdk-java, and copilot-sdk-java-runtime, which brings Copilot's agent runtime. It works with your own model in Microsoft Foundry, where the app signs in with its managed identity and needs no keys, as in step 3. It also works with a GitHub Copilot subscription, which needs a GitHub token instead. The bonus folder, step-3-copilot-sdk, builds this same assistant with the SDK: show Assistant.java and its live app if you have time. Copilot's agent can run commands and edit files, so the app switches all of that off and allows only the one tool. Be clear that the SDK's Java releases are still labeled preview, and @CopilotTool is still marked experimental.</a:t>
             </a:r>
           </a:p>
         </p:txBody>
@@ -4914,7 +4914,7 @@
                 <a:ea typeface="Segoe UI Semibold" pitchFamily="34" charset="-122"/>
                 <a:cs typeface="Segoe UI Semibold" pitchFamily="34" charset="-120"/>
               </a:rPr>
-              <a:t>MAVEN DEPENDENCY</a:t>
+              <a:t>MAVEN DEPENDENCIES</a:t>
             </a:r>
             <a:endParaRPr lang="en-US" sz="1300" dirty="0"/>
           </a:p>
@@ -4929,7 +4929,7 @@
         <p:spPr>
           <a:xfrm>
             <a:off x="914400" y="4754880"/>
-            <a:ext cx="4494276" cy="274320"/>
+            <a:ext cx="4494276" cy="594360"/>
           </a:xfrm>
           <a:prstGeom prst="rect">
             <a:avLst/>
@@ -4955,6 +4955,22 @@
               </a:rPr>
               <a:t>com.github:copilot-sdk-java</a:t>
             </a:r>
+          </a:p>
+          <a:p>
+            <a:pPr marL="0" indent="0">
+              <a:buNone/>
+            </a:pPr>
+            <a:r>
+              <a:rPr lang="en-US" sz="1600" dirty="0">
+                <a:solidFill>
+                  <a:srgbClr val="242424"/>
+                </a:solidFill>
+                <a:latin typeface="Consolas" pitchFamily="34" charset="0"/>
+                <a:ea typeface="Consolas" pitchFamily="34" charset="-122"/>
+                <a:cs typeface="Consolas" pitchFamily="34" charset="-120"/>
+              </a:rPr>
+              <a:t>com.github:copilot-sdk-java-runtime</a:t>
+            </a:r>
             <a:endParaRPr lang="en-US" sz="1600" dirty="0"/>
           </a:p>
         </p:txBody>
@@ -5031,7 +5047,7 @@
                 <a:ea typeface="Segoe UI" pitchFamily="34" charset="-122"/>
                 <a:cs typeface="Segoe UI" pitchFamily="34" charset="-120"/>
               </a:rPr>
-              <a:t>A GitHub Copilot subscription, or your own Foundry model with managed identity. No keys.</a:t>
+              <a:t>Your own Foundry model with managed identity: no keys. Or a GitHub Copilot subscription.</a:t>
             </a:r>
             <a:endParaRPr lang="en-US" sz="1600" dirty="0"/>
           </a:p>

</xml_diff>

<commit_message>
Add a slide on how the Copilot SDK answers a question
Slide 9 shows the step 3 bonus as a sequence diagram, like slide 6 does
for Spring AI: the same question, two model calls and one tool call. The
app hands the question to Copilot's agent, which runs in the app's
container, and the SDK runs listProducts() when the model asks for
list_products. The notes on the diagram say what's locked down, and that
each question's session is deleted afterwards.

The diagram is new in docs/diagrams, next to its Excalidraw source, and
the step-3-copilot-sdk README now shows it and follows its numbers. The
notes on slides 6 and 8, the presenter guide and the workshop guide now
count the new slide.

Co-authored-by: Copilot <223556219+Copilot@users.noreply.github.com>
</commit_message>
<xml_diff>
--- a/docs/trail-store-workshop.pptx
+++ b/docs/trail-store-workshop.pptx
@@ -16,6 +16,7 @@
     <p:sldId id="261" r:id="rId7"/>
     <p:sldId id="262" r:id="rId8"/>
     <p:sldId id="268" r:id="rId19"/>
+    <p:sldId id="269" r:id="rId20"/>
     <p:sldId id="263" r:id="rId9"/>
     <p:sldId id="264" r:id="rId10"/>
     <p:sldId id="265" r:id="rId11"/>
@@ -643,7 +644,7 @@
           <a:p>
             <a:r>
               <a:rPr lang="en-US" dirty="0"/>
-              <a:t>Two minutes, and nothing for the room to do. In step 3, Spring AI sends one question to the model, and the model can ask for one Java method. The GitHub Copilot SDK goes further: it runs Copilot's agent inside your own app. You give it a goal, and it plans and calls your Java tools, step by step, until the job is done. You still write the tools as Java methods, with @CopilotTool instead of @Tool. You add two Maven dependencies: copilot-sdk-java, and copilot-sdk-java-runtime, which brings Copilot's agent runtime. It works with your own model in Microsoft Foundry, where the app signs in with its managed identity and needs no keys, as in step 3. It also works with a GitHub Copilot subscription, which needs a GitHub token instead. The bonus folder, step-3-copilot-sdk, builds this same assistant with the SDK: show Assistant.java and its live app if you have time. Copilot's agent can run commands and edit files, so the app switches all of that off and allows only the one tool. Be clear that the SDK's Java releases are still labeled preview, and @CopilotTool is still marked experimental.</a:t>
+              <a:t>Two minutes for this slide and the next, and nothing for the room to do. In step 3, Spring AI sends one question to the model, and the model can ask for one Java method. The GitHub Copilot SDK goes further: it runs Copilot's agent inside your own app. You give it a goal, and it plans and calls your Java tools, step by step, until the job is done. You still write the tools as Java methods, with @CopilotTool instead of @Tool. You add two Maven dependencies: copilot-sdk-java, and copilot-sdk-java-runtime, which brings Copilot's agent runtime. It works with your own model in Microsoft Foundry, where the app signs in with its managed identity and needs no keys, as in step 3. It also works with a GitHub Copilot subscription, which needs a GitHub token instead. The bonus folder, step-3-copilot-sdk, builds this same assistant with the SDK: show Assistant.java and its live app if you have time. Copilot's agent can run commands and edit files, so the app switches all of that off and allows only the one tool. Be clear that the SDK's Java releases are still labeled preview, and @CopilotTool is still marked experimental.</a:t>
             </a:r>
           </a:p>
         </p:txBody>
@@ -675,6 +676,93 @@
     <p:extLst>
       <p:ext uri="{BB962C8B-B14F-4D97-AF65-F5344CB8AC3E}">
         <p14:creationId xmlns:p14="http://schemas.microsoft.com/office/powerpoint/2010/main" val="2713590247"/>
+      </p:ext>
+    </p:extLst>
+  </p:cSld>
+  <p:clrMapOvr>
+    <a:masterClrMapping/>
+  </p:clrMapOvr>
+</p:notes>
+</file>
+
+<file path=ppt/notesSlides/notesSlide14.xml><?xml version="1.0" encoding="utf-8"?>
+<p:notes xmlns:a="http://schemas.openxmlformats.org/drawingml/2006/main" xmlns:r="http://schemas.openxmlformats.org/officeDocument/2006/relationships" xmlns:p="http://schemas.openxmlformats.org/presentationml/2006/main">
+  <p:cSld>
+    <p:spTree>
+      <p:nvGrpSpPr>
+        <p:cNvPr id="1" name=""/>
+        <p:cNvGrpSpPr/>
+        <p:nvPr/>
+      </p:nvGrpSpPr>
+      <p:grpSpPr>
+        <a:xfrm>
+          <a:off x="0" y="0"/>
+          <a:ext cx="0" cy="0"/>
+          <a:chOff x="0" y="0"/>
+          <a:chExt cx="0" cy="0"/>
+        </a:xfrm>
+      </p:grpSpPr>
+      <p:sp>
+        <p:nvSpPr>
+          <p:cNvPr id="2" name="Slide Image Placeholder 1"/>
+          <p:cNvSpPr>
+            <a:spLocks noGrp="1" noRot="1" noChangeAspect="1"/>
+          </p:cNvSpPr>
+          <p:nvPr>
+            <p:ph type="sldImg"/>
+          </p:nvPr>
+        </p:nvSpPr>
+        <p:spPr/>
+      </p:sp>
+      <p:sp>
+        <p:nvSpPr>
+          <p:cNvPr id="3" name="Notes Placeholder 2"/>
+          <p:cNvSpPr>
+            <a:spLocks noGrp="1"/>
+          </p:cNvSpPr>
+          <p:nvPr>
+            <p:ph type="body" idx="1"/>
+          </p:nvPr>
+        </p:nvSpPr>
+        <p:spPr/>
+        <p:txBody>
+          <a:bodyPr/>
+          <a:lstStyle/>
+          <a:p>
+            <a:r>
+              <a:rPr lang="en-US" dirty="0"/>
+              <a:t>Follow the numbers. It's the same question as before, with the same two model calls and one tool call. What's new is Copilot's agent, which runs next to the app, in the same container. The app opens a session and hands the agent the question. From there, the agent does what Spring AI did: it calls the model, and when the model asks for list_products, the SDK runs our Java method. Then the agent calls the model again and hands back the answer, and the app deletes the session, so no questions stay on disk. The agent may call that one tool and nothing else: Copilot's tools for files and commands are switched off.</a:t>
+            </a:r>
+          </a:p>
+        </p:txBody>
+      </p:sp>
+      <p:sp>
+        <p:nvSpPr>
+          <p:cNvPr id="4" name="Slide Number Placeholder 3"/>
+          <p:cNvSpPr>
+            <a:spLocks noGrp="1"/>
+          </p:cNvSpPr>
+          <p:nvPr>
+            <p:ph type="sldNum" sz="quarter" idx="10"/>
+          </p:nvPr>
+        </p:nvSpPr>
+        <p:spPr/>
+        <p:txBody>
+          <a:bodyPr/>
+          <a:lstStyle/>
+          <a:p>
+            <a:fld id="{F7021451-1387-4CA6-816F-3879F97B5CBC}" type="slidenum">
+              <a:rPr lang="en-US"/>
+              <a:t>9</a:t>
+            </a:fld>
+            <a:endParaRPr lang="en-US"/>
+          </a:p>
+        </p:txBody>
+      </p:sp>
+    </p:spTree>
+    <p:extLst>
+      <p:ext uri="{BB962C8B-B14F-4D97-AF65-F5344CB8AC3E}">
+        <p14:creationId xmlns:p14="http://schemas.microsoft.com/office/powerpoint/2010/main" val="1024086991"/>
       </p:ext>
     </p:extLst>
   </p:cSld>
@@ -1078,7 +1166,7 @@
           <a:p>
             <a:r>
               <a:rPr lang="en-US" dirty="0"/>
-              <a:t>Follow the numbers: two calls to the model, and one call to our own Java code in between. The model can't see our catalog, so we give it a tool: one method with @Tool. There are no API keys: they're switched off in Foundry, and the app signs in with its managed identity. Time: 12 minutes for step 3, including the next two slides.</a:t>
+              <a:t>Follow the numbers: two calls to the model, and one call to our own Java code in between. The model can't see our catalog, so we give it a tool: one method with @Tool. There are no API keys: they're switched off in Foundry, and the app signs in with its managed identity. Time: 12 minutes for step 3, including the next three slides.</a:t>
             </a:r>
           </a:p>
         </p:txBody>
@@ -5092,6 +5180,113 @@
           </a:p>
         </p:txBody>
       </p:sp>
+    </p:spTree>
+  </p:cSld>
+  <p:clrMapOvr>
+    <a:masterClrMapping/>
+  </p:clrMapOvr>
+</p:sld>
+</file>
+
+<file path=ppt/slides/slide14.xml><?xml version="1.0" encoding="utf-8"?>
+<p:sld xmlns:a="http://schemas.openxmlformats.org/drawingml/2006/main" xmlns:r="http://schemas.openxmlformats.org/officeDocument/2006/relationships" xmlns:p="http://schemas.openxmlformats.org/presentationml/2006/main">
+  <p:cSld name="Copilot SDK question">
+    <p:bg>
+      <p:bgPr>
+        <a:solidFill>
+          <a:srgbClr val="F7F4EF"/>
+        </a:solidFill>
+        <a:effectLst/>
+      </p:bgPr>
+    </p:bg>
+    <p:spTree>
+      <p:nvGrpSpPr>
+        <p:cNvPr id="1" name=""/>
+        <p:cNvGrpSpPr/>
+        <p:nvPr/>
+      </p:nvGrpSpPr>
+      <p:grpSpPr>
+        <a:xfrm>
+          <a:off x="0" y="0"/>
+          <a:ext cx="0" cy="0"/>
+          <a:chOff x="0" y="0"/>
+          <a:chExt cx="0" cy="0"/>
+        </a:xfrm>
+      </p:grpSpPr>
+      <p:sp>
+        <p:nvSpPr>
+          <p:cNvPr id="2" name="Text 0"/>
+          <p:cNvSpPr/>
+          <p:nvPr/>
+        </p:nvSpPr>
+        <p:spPr>
+          <a:xfrm>
+            <a:off x="548640" y="320040"/>
+            <a:ext cx="11064240" cy="566928"/>
+          </a:xfrm>
+          <a:prstGeom prst="rect">
+            <a:avLst/>
+          </a:prstGeom>
+          <a:noFill/>
+          <a:ln/>
+        </p:spPr>
+        <p:txBody>
+          <a:bodyPr wrap="square" lIns="0" tIns="0" rIns="0" bIns="0" rtlCol="0" anchor="ctr"/>
+          <a:lstStyle/>
+          <a:p>
+            <a:pPr marL="0" indent="0">
+              <a:buNone/>
+            </a:pPr>
+            <a:r>
+              <a:rPr lang="en-US" sz="3200" dirty="0">
+                <a:solidFill>
+                  <a:srgbClr val="5C2D91"/>
+                </a:solidFill>
+                <a:latin typeface="Segoe UI Semibold" pitchFamily="34" charset="0"/>
+                <a:ea typeface="Segoe UI Semibold" pitchFamily="34" charset="-122"/>
+                <a:cs typeface="Segoe UI Semibold" pitchFamily="34" charset="-120"/>
+              </a:rPr>
+              <a:t xml:space="preserve">Step 3   </a:t>
+            </a:r>
+            <a:r>
+              <a:rPr lang="en-US" sz="3200" dirty="0">
+                <a:solidFill>
+                  <a:srgbClr val="242424"/>
+                </a:solidFill>
+                <a:latin typeface="Segoe UI Semibold" pitchFamily="34" charset="0"/>
+                <a:ea typeface="Segoe UI Semibold" pitchFamily="34" charset="-122"/>
+                <a:cs typeface="Segoe UI Semibold" pitchFamily="34" charset="-120"/>
+              </a:rPr>
+              <a:t>How the Copilot SDK answers a question</a:t>
+            </a:r>
+            <a:endParaRPr lang="en-US" sz="3200" dirty="0"/>
+          </a:p>
+        </p:txBody>
+      </p:sp>
+      <p:pic>
+        <p:nvPicPr>
+          <p:cNvPr id="3" name="Image 0" descr="Ten numbered messages between you, the app, Copilot's agent, the listProducts tool and the model: the app hands the question to Copilot's agent, which calls the model twice and has the SDK run the Java tool once, then hands the answer back"/>
+          <p:cNvPicPr>
+            <a:picLocks noChangeAspect="1"/>
+          </p:cNvPicPr>
+          <p:nvPr/>
+        </p:nvPicPr>
+        <p:blipFill>
+          <a:blip r:embed="rId3"/>
+          <a:stretch>
+            <a:fillRect/>
+          </a:stretch>
+        </p:blipFill>
+        <p:spPr>
+          <a:xfrm>
+            <a:off x="598322" y="1051560"/>
+            <a:ext cx="10995355" cy="5349240"/>
+          </a:xfrm>
+          <a:prstGeom prst="rect">
+            <a:avLst/>
+          </a:prstGeom>
+        </p:spPr>
+      </p:pic>
     </p:spTree>
   </p:cSld>
   <p:clrMapOvr>

</xml_diff>

<commit_message>
Add cost per step slide to workshop deck
Darken the token cost label in the README chart for contrast.

Co-authored-by: Copilot <223556219+Copilot@users.noreply.github.com>
</commit_message>
<xml_diff>
--- a/docs/trail-store-workshop.pptx
+++ b/docs/trail-store-workshop.pptx
@@ -20,6 +20,7 @@
     <p:sldId id="263" r:id="rId9"/>
     <p:sldId id="264" r:id="rId10"/>
     <p:sldId id="265" r:id="rId11"/>
+    <p:sldId id="270" r:id="rId21"/>
     <p:sldId id="266" r:id="rId12"/>
     <p:sldId id="267" r:id="rId13"/>
   </p:sldIdLst>
@@ -765,6 +766,52 @@
         <p14:creationId xmlns:p14="http://schemas.microsoft.com/office/powerpoint/2010/main" val="1024086991"/>
       </p:ext>
     </p:extLst>
+  </p:cSld>
+  <p:clrMapOvr>
+    <a:masterClrMapping/>
+  </p:clrMapOvr>
+</p:notes>
+</file>
+
+<file path=ppt/notesSlides/notesSlide15.xml><?xml version="1.0" encoding="utf-8"?>
+<p:notes xmlns:a="http://schemas.openxmlformats.org/drawingml/2006/main" xmlns:p="http://schemas.openxmlformats.org/presentationml/2006/main" xmlns:r="http://schemas.openxmlformats.org/officeDocument/2006/relationships">
+  <p:cSld>
+    <p:spTree>
+      <p:nvGrpSpPr>
+        <p:cNvPr id="1" name=""/>
+        <p:cNvGrpSpPr/>
+        <p:nvPr/>
+      </p:nvGrpSpPr>
+      <p:grpSpPr>
+        <a:xfrm>
+          <a:off x="0" y="0"/>
+          <a:ext cx="0" cy="0"/>
+          <a:chOff x="0" y="0"/>
+          <a:chExt cx="0" cy="0"/>
+        </a:xfrm>
+      </p:grpSpPr>
+      <p:sp>
+        <p:nvSpPr>
+          <p:cNvPr id="3" name="Notes Placeholder 2"/>
+          <p:cNvSpPr>
+            <a:spLocks noGrp="1"/>
+          </p:cNvSpPr>
+          <p:nvPr>
+            <p:ph type="body" idx="1"/>
+          </p:nvPr>
+        </p:nvSpPr>
+        <p:spPr/>
+        <p:txBody>
+          <a:bodyPr/>
+          <a:lstStyle/>
+          <a:p>
+            <a:r>
+              <a:t>Here's the whole journey in one picture. Step 1 is free. Once you deploy, the container registry is most of the bill: about $5 a month for each step. Adding AI costs about $1.25 more: a bigger app, plus 71 cents of tokens for 9,000 questions. Step 4's Log Analytics stays in the free 5 GB.</a:t>
+            </a:r>
+          </a:p>
+        </p:txBody>
+      </p:sp>
+    </p:spTree>
   </p:cSld>
   <p:clrMapOvr>
     <a:masterClrMapping/>
@@ -2107,6 +2154,542 @@
 
 <file path=ppt/slides/slide10.xml><?xml version="1.0" encoding="utf-8"?>
 <p:sld xmlns:a="http://schemas.openxmlformats.org/drawingml/2006/main" xmlns:r="http://schemas.openxmlformats.org/officeDocument/2006/relationships" xmlns:p="http://schemas.openxmlformats.org/presentationml/2006/main">
+  <p:cSld name="Slide 8">
+    <p:bg>
+      <p:bgPr>
+        <a:solidFill>
+          <a:srgbClr val="F7F4EF"/>
+        </a:solidFill>
+        <a:effectLst/>
+      </p:bgPr>
+    </p:bg>
+    <p:spTree>
+      <p:nvGrpSpPr>
+        <p:cNvPr id="1" name=""/>
+        <p:cNvGrpSpPr/>
+        <p:nvPr/>
+      </p:nvGrpSpPr>
+      <p:grpSpPr>
+        <a:xfrm>
+          <a:off x="0" y="0"/>
+          <a:ext cx="0" cy="0"/>
+          <a:chOff x="0" y="0"/>
+          <a:chExt cx="0" cy="0"/>
+        </a:xfrm>
+      </p:grpSpPr>
+      <p:sp>
+        <p:nvSpPr>
+          <p:cNvPr id="2" name="Text 0"/>
+          <p:cNvSpPr/>
+          <p:nvPr/>
+        </p:nvSpPr>
+        <p:spPr>
+          <a:xfrm>
+            <a:off x="548640" y="320040"/>
+            <a:ext cx="11064240" cy="566928"/>
+          </a:xfrm>
+          <a:prstGeom prst="rect">
+            <a:avLst/>
+          </a:prstGeom>
+          <a:noFill/>
+          <a:ln/>
+        </p:spPr>
+        <p:txBody>
+          <a:bodyPr wrap="square" lIns="0" tIns="0" rIns="0" bIns="0" rtlCol="0" anchor="ctr"/>
+          <a:lstStyle/>
+          <a:p>
+            <a:pPr marL="0" indent="0">
+              <a:buNone/>
+            </a:pPr>
+            <a:r>
+              <a:rPr lang="en-US" sz="3200" dirty="0">
+                <a:solidFill>
+                  <a:srgbClr val="107C10"/>
+                </a:solidFill>
+                <a:latin typeface="Segoe UI Semibold" pitchFamily="34" charset="0"/>
+                <a:ea typeface="Segoe UI Semibold" pitchFamily="34" charset="-122"/>
+                <a:cs typeface="Segoe UI Semibold" pitchFamily="34" charset="-120"/>
+              </a:rPr>
+              <a:t xml:space="preserve">Step 4   </a:t>
+            </a:r>
+            <a:r>
+              <a:rPr lang="en-US" sz="3200" dirty="0">
+                <a:solidFill>
+                  <a:srgbClr val="242424"/>
+                </a:solidFill>
+                <a:latin typeface="Segoe UI Semibold" pitchFamily="34" charset="0"/>
+                <a:ea typeface="Segoe UI Semibold" pitchFamily="34" charset="-122"/>
+                <a:cs typeface="Segoe UI Semibold" pitchFamily="34" charset="-120"/>
+              </a:rPr>
+              <a:t>How traces get to Application Insights</a:t>
+            </a:r>
+            <a:endParaRPr lang="en-US" sz="3200" dirty="0"/>
+          </a:p>
+        </p:txBody>
+      </p:sp>
+      <p:pic>
+        <p:nvPicPr>
+          <p:cNvPr id="3" name="Image 0" descr="The app sends traces to the Container Apps environment, which forwards them to Application Insights, where you can query tokens and cost or open one question as a timeline"/>
+          <p:cNvPicPr>
+            <a:picLocks noChangeAspect="1"/>
+          </p:cNvPicPr>
+          <p:nvPr/>
+        </p:nvPicPr>
+        <p:blipFill>
+          <a:blip r:embed="rId3"/>
+          <a:stretch>
+            <a:fillRect/>
+          </a:stretch>
+        </p:blipFill>
+        <p:spPr>
+          <a:xfrm>
+            <a:off x="365760" y="1401693"/>
+            <a:ext cx="11457432" cy="3505974"/>
+          </a:xfrm>
+          <a:prstGeom prst="rect">
+            <a:avLst/>
+          </a:prstGeom>
+        </p:spPr>
+      </p:pic>
+      <p:sp>
+        <p:nvSpPr>
+          <p:cNvPr id="4" name="Shape 1"/>
+          <p:cNvSpPr/>
+          <p:nvPr/>
+        </p:nvSpPr>
+        <p:spPr>
+          <a:xfrm>
+            <a:off x="548640" y="5440680"/>
+            <a:ext cx="11091672" cy="960120"/>
+          </a:xfrm>
+          <a:prstGeom prst="rect">
+            <a:avLst/>
+          </a:prstGeom>
+          <a:solidFill>
+            <a:srgbClr val="FFFFFF"/>
+          </a:solidFill>
+          <a:ln w="9525">
+            <a:solidFill>
+              <a:srgbClr val="DEDEDE"/>
+            </a:solidFill>
+            <a:prstDash val="solid"/>
+          </a:ln>
+          <a:effectLst>
+            <a:outerShdw blurRad="101600" dist="25400" dir="5400000" algn="bl" rotWithShape="0">
+              <a:srgbClr val="000000">
+                <a:alpha val="12000"/>
+              </a:srgbClr>
+            </a:outerShdw>
+          </a:effectLst>
+        </p:spPr>
+        <p:txBody>
+          <a:bodyPr/>
+          <a:lstStyle/>
+          <a:p>
+            <a:endParaRPr lang="en-ZA"/>
+          </a:p>
+        </p:txBody>
+      </p:sp>
+      <p:sp>
+        <p:nvSpPr>
+          <p:cNvPr id="5" name="Shape 2"/>
+          <p:cNvSpPr/>
+          <p:nvPr/>
+        </p:nvSpPr>
+        <p:spPr>
+          <a:xfrm>
+            <a:off x="548640" y="5440680"/>
+            <a:ext cx="82296" cy="960120"/>
+          </a:xfrm>
+          <a:prstGeom prst="rect">
+            <a:avLst/>
+          </a:prstGeom>
+          <a:solidFill>
+            <a:srgbClr val="107C10"/>
+          </a:solidFill>
+          <a:ln w="12700">
+            <a:solidFill>
+              <a:srgbClr val="107C10"/>
+            </a:solidFill>
+            <a:prstDash val="solid"/>
+          </a:ln>
+        </p:spPr>
+        <p:txBody>
+          <a:bodyPr/>
+          <a:lstStyle/>
+          <a:p>
+            <a:endParaRPr lang="en-ZA"/>
+          </a:p>
+        </p:txBody>
+      </p:sp>
+      <p:sp>
+        <p:nvSpPr>
+          <p:cNvPr id="6" name="Text 3"/>
+          <p:cNvSpPr/>
+          <p:nvPr/>
+        </p:nvSpPr>
+        <p:spPr>
+          <a:xfrm>
+            <a:off x="868680" y="5568696"/>
+            <a:ext cx="3566160" cy="274320"/>
+          </a:xfrm>
+          <a:prstGeom prst="rect">
+            <a:avLst/>
+          </a:prstGeom>
+          <a:noFill/>
+          <a:ln/>
+        </p:spPr>
+        <p:txBody>
+          <a:bodyPr wrap="square" lIns="0" tIns="0" rIns="0" bIns="0" rtlCol="0" anchor="ctr"/>
+          <a:lstStyle/>
+          <a:p>
+            <a:pPr marL="0" indent="0">
+              <a:buNone/>
+            </a:pPr>
+            <a:r>
+              <a:rPr lang="en-US" sz="1300" kern="0" spc="300" dirty="0">
+                <a:solidFill>
+                  <a:srgbClr val="107C10"/>
+                </a:solidFill>
+                <a:latin typeface="Segoe UI Semibold" pitchFamily="34" charset="0"/>
+                <a:ea typeface="Segoe UI Semibold" pitchFamily="34" charset="-122"/>
+                <a:cs typeface="Segoe UI Semibold" pitchFamily="34" charset="-120"/>
+              </a:rPr>
+              <a:t>READ</a:t>
+            </a:r>
+            <a:endParaRPr lang="en-US" sz="1300" dirty="0"/>
+          </a:p>
+        </p:txBody>
+      </p:sp>
+      <p:sp>
+        <p:nvSpPr>
+          <p:cNvPr id="7" name="Text 4"/>
+          <p:cNvSpPr/>
+          <p:nvPr/>
+        </p:nvSpPr>
+        <p:spPr>
+          <a:xfrm>
+            <a:off x="868680" y="5843016"/>
+            <a:ext cx="3566160" cy="457200"/>
+          </a:xfrm>
+          <a:prstGeom prst="rect">
+            <a:avLst/>
+          </a:prstGeom>
+          <a:noFill/>
+          <a:ln/>
+        </p:spPr>
+        <p:txBody>
+          <a:bodyPr wrap="square" lIns="0" tIns="0" rIns="0" bIns="0" rtlCol="0" anchor="t"/>
+          <a:lstStyle/>
+          <a:p>
+            <a:pPr marL="0" indent="0">
+              <a:buNone/>
+            </a:pPr>
+            <a:r>
+              <a:rPr lang="en-US" sz="1300" dirty="0">
+                <a:solidFill>
+                  <a:srgbClr val="242424"/>
+                </a:solidFill>
+                <a:latin typeface="Consolas" pitchFamily="34" charset="0"/>
+                <a:ea typeface="Consolas" pitchFamily="34" charset="-122"/>
+                <a:cs typeface="Consolas" pitchFamily="34" charset="-120"/>
+              </a:rPr>
+              <a:t>pom.xml   application.properties   infra/app.bicep</a:t>
+            </a:r>
+            <a:endParaRPr lang="en-US" sz="1300" dirty="0"/>
+          </a:p>
+        </p:txBody>
+      </p:sp>
+      <p:sp>
+        <p:nvSpPr>
+          <p:cNvPr id="8" name="Text 5"/>
+          <p:cNvSpPr/>
+          <p:nvPr/>
+        </p:nvSpPr>
+        <p:spPr>
+          <a:xfrm>
+            <a:off x="4709160" y="5568696"/>
+            <a:ext cx="6675120" cy="274320"/>
+          </a:xfrm>
+          <a:prstGeom prst="rect">
+            <a:avLst/>
+          </a:prstGeom>
+          <a:noFill/>
+          <a:ln/>
+        </p:spPr>
+        <p:txBody>
+          <a:bodyPr wrap="square" lIns="0" tIns="0" rIns="0" bIns="0" rtlCol="0" anchor="ctr"/>
+          <a:lstStyle/>
+          <a:p>
+            <a:pPr marL="0" indent="0">
+              <a:buNone/>
+            </a:pPr>
+            <a:r>
+              <a:rPr lang="en-US" sz="1300" kern="0" spc="300" dirty="0">
+                <a:solidFill>
+                  <a:srgbClr val="107C10"/>
+                </a:solidFill>
+                <a:latin typeface="Segoe UI Semibold" pitchFamily="34" charset="0"/>
+                <a:ea typeface="Segoe UI Semibold" pitchFamily="34" charset="-122"/>
+                <a:cs typeface="Segoe UI Semibold" pitchFamily="34" charset="-120"/>
+              </a:rPr>
+              <a:t>FIND</a:t>
+            </a:r>
+            <a:endParaRPr lang="en-US" sz="1300" dirty="0"/>
+          </a:p>
+        </p:txBody>
+      </p:sp>
+      <p:sp>
+        <p:nvSpPr>
+          <p:cNvPr id="9" name="Text 6"/>
+          <p:cNvSpPr/>
+          <p:nvPr/>
+        </p:nvSpPr>
+        <p:spPr>
+          <a:xfrm>
+            <a:off x="4709160" y="5843016"/>
+            <a:ext cx="6720840" cy="457200"/>
+          </a:xfrm>
+          <a:prstGeom prst="rect">
+            <a:avLst/>
+          </a:prstGeom>
+          <a:noFill/>
+          <a:ln/>
+        </p:spPr>
+        <p:txBody>
+          <a:bodyPr wrap="square" lIns="0" tIns="0" rIns="0" bIns="0" rtlCol="0" anchor="t"/>
+          <a:lstStyle/>
+          <a:p>
+            <a:pPr marL="0" indent="0">
+              <a:buNone/>
+            </a:pPr>
+            <a:r>
+              <a:rPr lang="en-US" sz="1400" dirty="0">
+                <a:solidFill>
+                  <a:srgbClr val="242424"/>
+                </a:solidFill>
+                <a:latin typeface="Segoe UI" pitchFamily="34" charset="0"/>
+                <a:ea typeface="Segoe UI" pitchFamily="34" charset="-122"/>
+                <a:cs typeface="Segoe UI" pitchFamily="34" charset="-120"/>
+              </a:rPr>
+              <a:t>How many model calls does one product question make, and why?</a:t>
+            </a:r>
+            <a:endParaRPr lang="en-US" sz="1400" dirty="0"/>
+          </a:p>
+          <a:p>
+            <a:pPr marL="0" indent="0">
+              <a:buNone/>
+            </a:pPr>
+            <a:r>
+              <a:rPr lang="en-US" sz="1400" dirty="0">
+                <a:solidFill>
+                  <a:srgbClr val="242424"/>
+                </a:solidFill>
+                <a:latin typeface="Segoe UI" pitchFamily="34" charset="0"/>
+                <a:ea typeface="Segoe UI" pitchFamily="34" charset="-122"/>
+                <a:cs typeface="Segoe UI" pitchFamily="34" charset="-120"/>
+              </a:rPr>
+              <a:t>About how much does one question cost?</a:t>
+            </a:r>
+            <a:endParaRPr lang="en-US" sz="1400" dirty="0"/>
+          </a:p>
+        </p:txBody>
+      </p:sp>
+    </p:spTree>
+  </p:cSld>
+  <p:clrMapOvr>
+    <a:masterClrMapping/>
+  </p:clrMapOvr>
+</p:sld>
+</file>
+
+<file path=ppt/slides/slide11.xml><?xml version="1.0" encoding="utf-8"?>
+<p:sld xmlns:a="http://schemas.openxmlformats.org/drawingml/2006/main" xmlns:r="http://schemas.openxmlformats.org/officeDocument/2006/relationships" xmlns:p="http://schemas.openxmlformats.org/presentationml/2006/main">
+  <p:cSld name="Slide 9">
+    <p:bg>
+      <p:bgPr>
+        <a:solidFill>
+          <a:srgbClr val="F7F4EF"/>
+        </a:solidFill>
+        <a:effectLst/>
+      </p:bgPr>
+    </p:bg>
+    <p:spTree>
+      <p:nvGrpSpPr>
+        <p:cNvPr id="1" name=""/>
+        <p:cNvGrpSpPr/>
+        <p:nvPr/>
+      </p:nvGrpSpPr>
+      <p:grpSpPr>
+        <a:xfrm>
+          <a:off x="0" y="0"/>
+          <a:ext cx="0" cy="0"/>
+          <a:chOff x="0" y="0"/>
+          <a:chExt cx="0" cy="0"/>
+        </a:xfrm>
+      </p:grpSpPr>
+      <p:sp>
+        <p:nvSpPr>
+          <p:cNvPr id="2" name="Text 0"/>
+          <p:cNvSpPr/>
+          <p:nvPr/>
+        </p:nvSpPr>
+        <p:spPr>
+          <a:xfrm>
+            <a:off x="548640" y="320040"/>
+            <a:ext cx="11064240" cy="566928"/>
+          </a:xfrm>
+          <a:prstGeom prst="rect">
+            <a:avLst/>
+          </a:prstGeom>
+          <a:noFill/>
+          <a:ln/>
+        </p:spPr>
+        <p:txBody>
+          <a:bodyPr wrap="square" lIns="0" tIns="0" rIns="0" bIns="0" rtlCol="0" anchor="ctr"/>
+          <a:lstStyle/>
+          <a:p>
+            <a:pPr marL="0" indent="0">
+              <a:buNone/>
+            </a:pPr>
+            <a:r>
+              <a:rPr lang="en-US" sz="3200" dirty="0">
+                <a:solidFill>
+                  <a:srgbClr val="107C10"/>
+                </a:solidFill>
+                <a:latin typeface="Segoe UI Semibold" pitchFamily="34" charset="0"/>
+                <a:ea typeface="Segoe UI Semibold" pitchFamily="34" charset="-122"/>
+                <a:cs typeface="Segoe UI Semibold" pitchFamily="34" charset="-120"/>
+              </a:rPr>
+              <a:t xml:space="preserve">Step 4   </a:t>
+            </a:r>
+            <a:r>
+              <a:rPr lang="en-US" sz="3200" dirty="0">
+                <a:solidFill>
+                  <a:srgbClr val="242424"/>
+                </a:solidFill>
+                <a:latin typeface="Segoe UI Semibold" pitchFamily="34" charset="0"/>
+                <a:ea typeface="Segoe UI Semibold" pitchFamily="34" charset="-122"/>
+                <a:cs typeface="Segoe UI Semibold" pitchFamily="34" charset="-120"/>
+              </a:rPr>
+              <a:t>One question, as a trace</a:t>
+            </a:r>
+            <a:endParaRPr lang="en-US" sz="3200" dirty="0"/>
+          </a:p>
+        </p:txBody>
+      </p:sp>
+      <p:sp>
+        <p:nvSpPr>
+          <p:cNvPr id="3" name="Text 1"/>
+          <p:cNvSpPr/>
+          <p:nvPr/>
+        </p:nvSpPr>
+        <p:spPr>
+          <a:xfrm>
+            <a:off x="548640" y="914400"/>
+            <a:ext cx="11064240" cy="365760"/>
+          </a:xfrm>
+          <a:prstGeom prst="rect">
+            <a:avLst/>
+          </a:prstGeom>
+          <a:noFill/>
+          <a:ln/>
+        </p:spPr>
+        <p:txBody>
+          <a:bodyPr wrap="square" lIns="0" tIns="0" rIns="0" bIns="0" rtlCol="0" anchor="ctr"/>
+          <a:lstStyle/>
+          <a:p>
+            <a:pPr marL="0" indent="0">
+              <a:buNone/>
+            </a:pPr>
+            <a:r>
+              <a:rPr lang="en-US" sz="1600" dirty="0">
+                <a:solidFill>
+                  <a:srgbClr val="5C5C5C"/>
+                </a:solidFill>
+                <a:latin typeface="Segoe UI" pitchFamily="34" charset="0"/>
+                <a:ea typeface="Segoe UI" pitchFamily="34" charset="-122"/>
+                <a:cs typeface="Segoe UI" pitchFamily="34" charset="-120"/>
+              </a:rPr>
+              <a:t>“Is the Summit Waterproof Jacket in stock?” Real data from step 4.</a:t>
+            </a:r>
+            <a:endParaRPr lang="en-US" sz="1600" dirty="0"/>
+          </a:p>
+        </p:txBody>
+      </p:sp>
+      <p:pic>
+        <p:nvPicPr>
+          <p:cNvPr id="4" name="Image 0" descr="A 3.5-second request with a 1.5-second model call, a 1-millisecond tool call and a 1.9-second model call, using 549 input and 52 output tokens for $0.000081"/>
+          <p:cNvPicPr>
+            <a:picLocks noChangeAspect="1"/>
+          </p:cNvPicPr>
+          <p:nvPr/>
+        </p:nvPicPr>
+        <p:blipFill>
+          <a:blip r:embed="rId3"/>
+          <a:stretch>
+            <a:fillRect/>
+          </a:stretch>
+        </p:blipFill>
+        <p:spPr>
+          <a:xfrm>
+            <a:off x="195682" y="1464535"/>
+            <a:ext cx="11731752" cy="3883210"/>
+          </a:xfrm>
+          <a:prstGeom prst="rect">
+            <a:avLst/>
+          </a:prstGeom>
+        </p:spPr>
+      </p:pic>
+      <p:sp>
+        <p:nvSpPr>
+          <p:cNvPr id="5" name="Text 2"/>
+          <p:cNvSpPr/>
+          <p:nvPr/>
+        </p:nvSpPr>
+        <p:spPr>
+          <a:xfrm>
+            <a:off x="548640" y="5577840"/>
+            <a:ext cx="11064240" cy="457200"/>
+          </a:xfrm>
+          <a:prstGeom prst="rect">
+            <a:avLst/>
+          </a:prstGeom>
+          <a:noFill/>
+          <a:ln/>
+        </p:spPr>
+        <p:txBody>
+          <a:bodyPr wrap="square" lIns="0" tIns="0" rIns="0" bIns="0" rtlCol="0" anchor="ctr"/>
+          <a:lstStyle/>
+          <a:p>
+            <a:pPr marL="0" indent="0">
+              <a:buNone/>
+            </a:pPr>
+            <a:r>
+              <a:rPr lang="en-US" sz="1800" dirty="0">
+                <a:solidFill>
+                  <a:srgbClr val="242424"/>
+                </a:solidFill>
+                <a:latin typeface="Segoe UI" pitchFamily="34" charset="0"/>
+                <a:ea typeface="Segoe UI" pitchFamily="34" charset="-122"/>
+                <a:cs typeface="Segoe UI" pitchFamily="34" charset="-120"/>
+              </a:rPr>
+              <a:t>Your Java method takes 1 ms. The model is where the time, and the cost, goes.</a:t>
+            </a:r>
+            <a:endParaRPr lang="en-US" sz="1800" dirty="0"/>
+          </a:p>
+        </p:txBody>
+      </p:sp>
+    </p:spTree>
+  </p:cSld>
+  <p:clrMapOvr>
+    <a:masterClrMapping/>
+  </p:clrMapOvr>
+</p:sld>
+</file>
+
+<file path=ppt/slides/slide12.xml><?xml version="1.0" encoding="utf-8"?>
+<p:sld xmlns:a="http://schemas.openxmlformats.org/drawingml/2006/main" xmlns:r="http://schemas.openxmlformats.org/officeDocument/2006/relationships" xmlns:p="http://schemas.openxmlformats.org/presentationml/2006/main">
   <p:cSld name="Slide 10">
     <p:bg>
       <p:bgPr>
@@ -2985,7 +3568,135 @@
 </p:sld>
 </file>
 
-<file path=ppt/slides/slide11.xml><?xml version="1.0" encoding="utf-8"?>
+<file path=ppt/slides/slide13.xml><?xml version="1.0" encoding="utf-8"?>
+<p:sld xmlns:a="http://schemas.openxmlformats.org/drawingml/2006/main" xmlns:p="http://schemas.openxmlformats.org/presentationml/2006/main" xmlns:r="http://schemas.openxmlformats.org/officeDocument/2006/relationships">
+  <p:cSld>
+    <p:bg>
+      <p:bgPr>
+        <a:solidFill>
+          <a:srgbClr val="F7F4EF"/>
+        </a:solidFill>
+        <a:effectLst/>
+      </p:bgPr>
+    </p:bg>
+    <p:spTree>
+      <p:nvGrpSpPr>
+        <p:cNvPr id="1" name=""/>
+        <p:cNvGrpSpPr/>
+        <p:nvPr/>
+      </p:nvGrpSpPr>
+      <p:grpSpPr/>
+      <p:sp>
+        <p:nvSpPr>
+          <p:cNvPr id="2" name="Text 0"/>
+          <p:cNvSpPr/>
+          <p:nvPr/>
+        </p:nvSpPr>
+        <p:spPr>
+          <a:xfrm>
+            <a:off x="548640" y="320040"/>
+            <a:ext cx="11064240" cy="566928"/>
+          </a:xfrm>
+          <a:prstGeom prst="rect">
+            <a:avLst/>
+          </a:prstGeom>
+          <a:noFill/>
+          <a:ln/>
+        </p:spPr>
+        <p:txBody>
+          <a:bodyPr wrap="square" lIns="0" tIns="0" rIns="0" bIns="0" rtlCol="0" anchor="ctr"/>
+          <a:lstStyle/>
+          <a:p>
+            <a:pPr marL="0" indent="0">
+              <a:buNone/>
+            </a:pPr>
+            <a:r>
+              <a:rPr lang="en-US" sz="3200" dirty="0">
+                <a:solidFill>
+                  <a:srgbClr val="242424"/>
+                </a:solidFill>
+                <a:latin typeface="Segoe UI Semibold" pitchFamily="34" charset="0"/>
+                <a:ea typeface="Segoe UI Semibold" pitchFamily="34" charset="-122"/>
+                <a:cs typeface="Segoe UI Semibold" pitchFamily="34" charset="-120"/>
+              </a:rPr>
+              <a:t>What each step costs</a:t>
+            </a:r>
+            <a:endParaRPr lang="en-US" sz="3200" dirty="0"/>
+          </a:p>
+        </p:txBody>
+      </p:sp>
+      <p:sp>
+        <p:nvSpPr>
+          <p:cNvPr id="3" name="Text 1"/>
+          <p:cNvSpPr/>
+          <p:nvPr/>
+        </p:nvSpPr>
+        <p:spPr>
+          <a:xfrm>
+            <a:off x="548640" y="914400"/>
+            <a:ext cx="11064240" cy="365760"/>
+          </a:xfrm>
+          <a:prstGeom prst="rect">
+            <a:avLst/>
+          </a:prstGeom>
+          <a:noFill/>
+          <a:ln/>
+        </p:spPr>
+        <p:txBody>
+          <a:bodyPr wrap="square" lIns="0" tIns="0" rIns="0" bIns="0" rtlCol="0" anchor="ctr"/>
+          <a:lstStyle/>
+          <a:p>
+            <a:pPr marL="0" indent="0">
+              <a:buNone/>
+            </a:pPr>
+            <a:r>
+              <a:rPr lang="en-US" sz="1600" dirty="0">
+                <a:solidFill>
+                  <a:srgbClr val="5C5C5C"/>
+                </a:solidFill>
+                <a:latin typeface="Segoe UI" pitchFamily="34" charset="0"/>
+                <a:ea typeface="Segoe UI" pitchFamily="34" charset="-122"/>
+                <a:cs typeface="Segoe UI" pitchFamily="34" charset="-120"/>
+              </a:rPr>
+              <a:t>One month with 10 busy hours and 9,000 questions</a:t>
+            </a:r>
+            <a:endParaRPr lang="en-US" sz="1600" dirty="0"/>
+          </a:p>
+        </p:txBody>
+      </p:sp>
+      <p:pic>
+        <p:nvPicPr>
+          <p:cNvPr id="4" name="Image 0" descr="Monthly cost of each step: step 1 $0, step 2 $5.54, steps 3 and 4 $6.79 each. The container registry is $5 of each deployed step, and tokens add $0.71."/>
+          <p:cNvPicPr>
+            <a:picLocks noChangeAspect="1"/>
+          </p:cNvPicPr>
+          <p:nvPr/>
+        </p:nvPicPr>
+        <p:blipFill>
+          <a:blip r:embed="rId2"/>
+          <a:stretch>
+            <a:fillRect/>
+          </a:stretch>
+        </p:blipFill>
+        <p:spPr>
+          <a:xfrm>
+            <a:off x="548640" y="1417320"/>
+            <a:ext cx="11064240" cy="4846320"/>
+          </a:xfrm>
+          <a:prstGeom prst="rect">
+            <a:avLst/>
+          </a:prstGeom>
+        </p:spPr>
+      </p:pic>
+    </p:spTree>
+  </p:cSld>
+  <p:clrMapOvr>
+    <a:masterClrMapping/>
+  </p:clrMapOvr>
+</p:sld>
+</file>
+
+<file path=ppt/slides/slide14.xml><?xml version="1.0" encoding="utf-8"?>
 <p:sld xmlns:a="http://schemas.openxmlformats.org/drawingml/2006/main" xmlns:r="http://schemas.openxmlformats.org/officeDocument/2006/relationships" xmlns:p="http://schemas.openxmlformats.org/presentationml/2006/main">
   <p:cSld name="Slide 11">
     <p:bg>
@@ -3932,7 +4643,7 @@
 </p:sld>
 </file>
 
-<file path=ppt/slides/slide12.xml><?xml version="1.0" encoding="utf-8"?>
+<file path=ppt/slides/slide15.xml><?xml version="1.0" encoding="utf-8"?>
 <p:sld xmlns:a="http://schemas.openxmlformats.org/drawingml/2006/main" xmlns:r="http://schemas.openxmlformats.org/officeDocument/2006/relationships" xmlns:p="http://schemas.openxmlformats.org/presentationml/2006/main">
   <p:cSld name="Slide 12">
     <p:bg>
@@ -4317,976 +5028,6 @@
           </a:p>
         </p:txBody>
       </p:sp>
-    </p:spTree>
-  </p:cSld>
-  <p:clrMapOvr>
-    <a:masterClrMapping/>
-  </p:clrMapOvr>
-</p:sld>
-</file>
-
-<file path=ppt/slides/slide13.xml><?xml version="1.0" encoding="utf-8"?>
-<p:sld xmlns:a="http://schemas.openxmlformats.org/drawingml/2006/main" xmlns:r="http://schemas.openxmlformats.org/officeDocument/2006/relationships" xmlns:p="http://schemas.openxmlformats.org/presentationml/2006/main">
-  <p:cSld name="Copilot SDK">
-    <p:bg>
-      <p:bgPr>
-        <a:solidFill>
-          <a:srgbClr val="F7F4EF"/>
-        </a:solidFill>
-        <a:effectLst/>
-      </p:bgPr>
-    </p:bg>
-    <p:spTree>
-      <p:nvGrpSpPr>
-        <p:cNvPr id="1" name=""/>
-        <p:cNvGrpSpPr/>
-        <p:nvPr/>
-      </p:nvGrpSpPr>
-      <p:grpSpPr>
-        <a:xfrm>
-          <a:off x="0" y="0"/>
-          <a:ext cx="0" cy="0"/>
-          <a:chOff x="0" y="0"/>
-          <a:chExt cx="0" cy="0"/>
-        </a:xfrm>
-      </p:grpSpPr>
-      <p:sp>
-        <p:nvSpPr>
-          <p:cNvPr id="2" name="Title"/>
-          <p:cNvSpPr/>
-          <p:nvPr/>
-        </p:nvSpPr>
-        <p:spPr>
-          <a:xfrm>
-            <a:off x="548640" y="320040"/>
-            <a:ext cx="11064240" cy="566928"/>
-          </a:xfrm>
-          <a:prstGeom prst="rect">
-            <a:avLst/>
-          </a:prstGeom>
-          <a:noFill/>
-          <a:ln/>
-        </p:spPr>
-        <p:txBody>
-          <a:bodyPr wrap="square" lIns="0" tIns="0" rIns="0" bIns="0" rtlCol="0" anchor="ctr"/>
-          <a:lstStyle/>
-          <a:p>
-            <a:pPr marL="0" indent="0">
-              <a:buNone/>
-            </a:pPr>
-            <a:r>
-              <a:rPr lang="en-US" sz="3200" dirty="0">
-                <a:solidFill>
-                  <a:srgbClr val="5C2D91"/>
-                </a:solidFill>
-                <a:latin typeface="Segoe UI Semibold" pitchFamily="34" charset="0"/>
-                <a:ea typeface="Segoe UI Semibold" pitchFamily="34" charset="-122"/>
-                <a:cs typeface="Segoe UI Semibold" pitchFamily="34" charset="-120"/>
-              </a:rPr>
-              <a:t xml:space="preserve">Step 3   </a:t>
-            </a:r>
-            <a:r>
-              <a:rPr lang="en-US" sz="3200" dirty="0">
-                <a:solidFill>
-                  <a:srgbClr val="242424"/>
-                </a:solidFill>
-                <a:latin typeface="Segoe UI Semibold" pitchFamily="34" charset="0"/>
-                <a:ea typeface="Segoe UI Semibold" pitchFamily="34" charset="-122"/>
-                <a:cs typeface="Segoe UI Semibold" pitchFamily="34" charset="-120"/>
-              </a:rPr>
-              <a:t>Going further: the GitHub Copilot SDK</a:t>
-            </a:r>
-            <a:endParaRPr lang="en-US" sz="3200" dirty="0"/>
-          </a:p>
-        </p:txBody>
-      </p:sp>
-      <p:sp>
-        <p:nvSpPr>
-          <p:cNvPr id="3" name="Saw card"/>
-          <p:cNvSpPr/>
-          <p:nvPr/>
-        </p:nvSpPr>
-        <p:spPr>
-          <a:xfrm>
-            <a:off x="548640" y="1325880"/>
-            <a:ext cx="5134356" cy="2468880"/>
-          </a:xfrm>
-          <a:prstGeom prst="rect">
-            <a:avLst/>
-          </a:prstGeom>
-          <a:solidFill>
-            <a:srgbClr val="FFFFFF"/>
-          </a:solidFill>
-          <a:ln w="9525">
-            <a:solidFill>
-              <a:srgbClr val="DEDEDE"/>
-            </a:solidFill>
-            <a:prstDash val="solid"/>
-          </a:ln>
-          <a:effectLst>
-            <a:outerShdw blurRad="101600" dist="25400" dir="5400000" algn="bl" rotWithShape="0">
-              <a:srgbClr val="000000">
-                <a:alpha val="12000"/>
-              </a:srgbClr>
-            </a:outerShdw>
-          </a:effectLst>
-        </p:spPr>
-        <p:txBody>
-          <a:bodyPr/>
-          <a:lstStyle/>
-          <a:p>
-            <a:endParaRPr lang="en-US"/>
-          </a:p>
-        </p:txBody>
-      </p:sp>
-      <p:sp>
-        <p:nvSpPr>
-          <p:cNvPr id="4" name="Saw card bar"/>
-          <p:cNvSpPr/>
-          <p:nvPr/>
-        </p:nvSpPr>
-        <p:spPr>
-          <a:xfrm>
-            <a:off x="548640" y="1325880"/>
-            <a:ext cx="82296" cy="2468880"/>
-          </a:xfrm>
-          <a:prstGeom prst="rect">
-            <a:avLst/>
-          </a:prstGeom>
-          <a:solidFill>
-            <a:srgbClr val="5C2D91"/>
-          </a:solidFill>
-          <a:ln w="12700">
-            <a:solidFill>
-              <a:srgbClr val="5C2D91"/>
-            </a:solidFill>
-            <a:prstDash val="solid"/>
-          </a:ln>
-        </p:spPr>
-        <p:txBody>
-          <a:bodyPr/>
-          <a:lstStyle/>
-          <a:p>
-            <a:endParaRPr lang="en-US"/>
-          </a:p>
-        </p:txBody>
-      </p:sp>
-      <p:sp>
-        <p:nvSpPr>
-          <p:cNvPr id="5" name="Saw label"/>
-          <p:cNvSpPr/>
-          <p:nvPr/>
-        </p:nvSpPr>
-        <p:spPr>
-          <a:xfrm>
-            <a:off x="914400" y="1645920"/>
-            <a:ext cx="4494276" cy="228600"/>
-          </a:xfrm>
-          <a:prstGeom prst="rect">
-            <a:avLst/>
-          </a:prstGeom>
-          <a:noFill/>
-          <a:ln/>
-        </p:spPr>
-        <p:txBody>
-          <a:bodyPr wrap="square" lIns="0" tIns="0" rIns="0" bIns="0" rtlCol="0" anchor="t"/>
-          <a:lstStyle/>
-          <a:p>
-            <a:pPr marL="0" indent="0">
-              <a:buNone/>
-            </a:pPr>
-            <a:r>
-              <a:rPr lang="en-US" sz="1300" kern="0" spc="300" dirty="0">
-                <a:solidFill>
-                  <a:srgbClr val="5C2D91"/>
-                </a:solidFill>
-                <a:latin typeface="Segoe UI Semibold" pitchFamily="34" charset="0"/>
-                <a:ea typeface="Segoe UI Semibold" pitchFamily="34" charset="-122"/>
-                <a:cs typeface="Segoe UI Semibold" pitchFamily="34" charset="-120"/>
-              </a:rPr>
-              <a:t>WHAT YOU JUST SAW</a:t>
-            </a:r>
-            <a:endParaRPr lang="en-US" sz="1300" dirty="0"/>
-          </a:p>
-        </p:txBody>
-      </p:sp>
-      <p:sp>
-        <p:nvSpPr>
-          <p:cNvPr id="6" name="Saw heading"/>
-          <p:cNvSpPr/>
-          <p:nvPr/>
-        </p:nvSpPr>
-        <p:spPr>
-          <a:xfrm>
-            <a:off x="914400" y="1965960"/>
-            <a:ext cx="4494276" cy="411480"/>
-          </a:xfrm>
-          <a:prstGeom prst="rect">
-            <a:avLst/>
-          </a:prstGeom>
-          <a:noFill/>
-          <a:ln/>
-        </p:spPr>
-        <p:txBody>
-          <a:bodyPr wrap="square" lIns="0" tIns="0" rIns="0" bIns="0" rtlCol="0" anchor="t"/>
-          <a:lstStyle/>
-          <a:p>
-            <a:pPr marL="0" indent="0">
-              <a:buNone/>
-            </a:pPr>
-            <a:r>
-              <a:rPr lang="en-US" sz="2400" dirty="0">
-                <a:solidFill>
-                  <a:srgbClr val="242424"/>
-                </a:solidFill>
-                <a:latin typeface="Segoe UI Semibold" pitchFamily="34" charset="0"/>
-                <a:ea typeface="Segoe UI Semibold" pitchFamily="34" charset="-122"/>
-                <a:cs typeface="Segoe UI Semibold" pitchFamily="34" charset="-120"/>
-              </a:rPr>
-              <a:t>One question, one tool</a:t>
-            </a:r>
-            <a:endParaRPr lang="en-US" sz="2400" dirty="0"/>
-          </a:p>
-        </p:txBody>
-      </p:sp>
-      <p:sp>
-        <p:nvSpPr>
-          <p:cNvPr id="7" name="Saw body"/>
-          <p:cNvSpPr/>
-          <p:nvPr/>
-        </p:nvSpPr>
-        <p:spPr>
-          <a:xfrm>
-            <a:off x="914400" y="2468880"/>
-            <a:ext cx="4494276" cy="594360"/>
-          </a:xfrm>
-          <a:prstGeom prst="rect">
-            <a:avLst/>
-          </a:prstGeom>
-          <a:noFill/>
-          <a:ln/>
-        </p:spPr>
-        <p:txBody>
-          <a:bodyPr wrap="square" lIns="0" tIns="0" rIns="0" bIns="0" rtlCol="0" anchor="t"/>
-          <a:lstStyle/>
-          <a:p>
-            <a:pPr marL="0" indent="0">
-              <a:buNone/>
-            </a:pPr>
-            <a:r>
-              <a:rPr lang="en-US" sz="1600" dirty="0">
-                <a:solidFill>
-                  <a:srgbClr val="242424"/>
-                </a:solidFill>
-                <a:latin typeface="Segoe UI" pitchFamily="34" charset="0"/>
-                <a:ea typeface="Segoe UI" pitchFamily="34" charset="-122"/>
-                <a:cs typeface="Segoe UI" pitchFamily="34" charset="-120"/>
-              </a:rPr>
-              <a:t>In this app, the model asks to run your Java method, then answers your question.</a:t>
-            </a:r>
-            <a:endParaRPr lang="en-US" sz="1600" dirty="0"/>
-          </a:p>
-        </p:txBody>
-      </p:sp>
-      <p:sp>
-        <p:nvSpPr>
-          <p:cNvPr id="8" name="Saw code"/>
-          <p:cNvSpPr/>
-          <p:nvPr/>
-        </p:nvSpPr>
-        <p:spPr>
-          <a:xfrm>
-            <a:off x="914400" y="3200400"/>
-            <a:ext cx="4494276" cy="274320"/>
-          </a:xfrm>
-          <a:prstGeom prst="rect">
-            <a:avLst/>
-          </a:prstGeom>
-          <a:noFill/>
-          <a:ln/>
-        </p:spPr>
-        <p:txBody>
-          <a:bodyPr wrap="square" lIns="0" tIns="0" rIns="0" bIns="0" rtlCol="0" anchor="t"/>
-          <a:lstStyle/>
-          <a:p>
-            <a:pPr marL="0" indent="0">
-              <a:buNone/>
-            </a:pPr>
-            <a:r>
-              <a:rPr lang="en-US" sz="1600" dirty="0">
-                <a:solidFill>
-                  <a:srgbClr val="5C2D91"/>
-                </a:solidFill>
-                <a:latin typeface="Consolas" pitchFamily="34" charset="0"/>
-                <a:ea typeface="Consolas" pitchFamily="34" charset="-122"/>
-                <a:cs typeface="Consolas" pitchFamily="34" charset="-120"/>
-              </a:rPr>
-              <a:t>@Tool</a:t>
-            </a:r>
-            <a:r>
-              <a:rPr lang="en-US" sz="1600" dirty="0">
-                <a:solidFill>
-                  <a:srgbClr val="242424"/>
-                </a:solidFill>
-                <a:latin typeface="Consolas" pitchFamily="34" charset="0"/>
-                <a:ea typeface="Consolas" pitchFamily="34" charset="-122"/>
-                <a:cs typeface="Consolas" pitchFamily="34" charset="-120"/>
-              </a:rPr>
-              <a:t xml:space="preserve"> listProducts()</a:t>
-            </a:r>
-            <a:endParaRPr lang="en-US" sz="1600" dirty="0"/>
-          </a:p>
-        </p:txBody>
-      </p:sp>
-      <p:cxnSp>
-        <p:nvCxnSpPr>
-          <p:cNvPr id="9" name="Arrow"/>
-          <p:cNvCxnSpPr/>
-          <p:nvPr/>
-        </p:nvCxnSpPr>
-        <p:spPr>
-          <a:xfrm>
-            <a:off x="5957316" y="2560320"/>
-            <a:ext cx="274320" cy="0"/>
-          </a:xfrm>
-          <a:prstGeom prst="straightConnector1">
-            <a:avLst/>
-          </a:prstGeom>
-          <a:ln w="28575">
-            <a:solidFill>
-              <a:srgbClr val="5C2D91"/>
-            </a:solidFill>
-            <a:tailEnd type="triangle" w="med" len="med"/>
-          </a:ln>
-        </p:spPr>
-      </p:cxnSp>
-      <p:sp>
-        <p:nvSpPr>
-          <p:cNvPr id="10" name="SDK card"/>
-          <p:cNvSpPr/>
-          <p:nvPr/>
-        </p:nvSpPr>
-        <p:spPr>
-          <a:xfrm>
-            <a:off x="6505956" y="1325880"/>
-            <a:ext cx="5134356" cy="2468880"/>
-          </a:xfrm>
-          <a:prstGeom prst="rect">
-            <a:avLst/>
-          </a:prstGeom>
-          <a:solidFill>
-            <a:srgbClr val="FFFFFF"/>
-          </a:solidFill>
-          <a:ln w="9525">
-            <a:solidFill>
-              <a:srgbClr val="DEDEDE"/>
-            </a:solidFill>
-            <a:prstDash val="solid"/>
-          </a:ln>
-          <a:effectLst>
-            <a:outerShdw blurRad="101600" dist="25400" dir="5400000" algn="bl" rotWithShape="0">
-              <a:srgbClr val="000000">
-                <a:alpha val="12000"/>
-              </a:srgbClr>
-            </a:outerShdw>
-          </a:effectLst>
-        </p:spPr>
-        <p:txBody>
-          <a:bodyPr/>
-          <a:lstStyle/>
-          <a:p>
-            <a:endParaRPr lang="en-US"/>
-          </a:p>
-        </p:txBody>
-      </p:sp>
-      <p:sp>
-        <p:nvSpPr>
-          <p:cNvPr id="11" name="SDK card bar"/>
-          <p:cNvSpPr/>
-          <p:nvPr/>
-        </p:nvSpPr>
-        <p:spPr>
-          <a:xfrm>
-            <a:off x="6505956" y="1325880"/>
-            <a:ext cx="82296" cy="2468880"/>
-          </a:xfrm>
-          <a:prstGeom prst="rect">
-            <a:avLst/>
-          </a:prstGeom>
-          <a:solidFill>
-            <a:srgbClr val="5C2D91"/>
-          </a:solidFill>
-          <a:ln w="12700">
-            <a:solidFill>
-              <a:srgbClr val="5C2D91"/>
-            </a:solidFill>
-            <a:prstDash val="solid"/>
-          </a:ln>
-        </p:spPr>
-        <p:txBody>
-          <a:bodyPr/>
-          <a:lstStyle/>
-          <a:p>
-            <a:endParaRPr lang="en-US"/>
-          </a:p>
-        </p:txBody>
-      </p:sp>
-      <p:sp>
-        <p:nvSpPr>
-          <p:cNvPr id="12" name="SDK label"/>
-          <p:cNvSpPr/>
-          <p:nvPr/>
-        </p:nvSpPr>
-        <p:spPr>
-          <a:xfrm>
-            <a:off x="6871716" y="1645920"/>
-            <a:ext cx="4494276" cy="228600"/>
-          </a:xfrm>
-          <a:prstGeom prst="rect">
-            <a:avLst/>
-          </a:prstGeom>
-          <a:noFill/>
-          <a:ln/>
-        </p:spPr>
-        <p:txBody>
-          <a:bodyPr wrap="square" lIns="0" tIns="0" rIns="0" bIns="0" rtlCol="0" anchor="t"/>
-          <a:lstStyle/>
-          <a:p>
-            <a:pPr marL="0" indent="0">
-              <a:buNone/>
-            </a:pPr>
-            <a:r>
-              <a:rPr lang="en-US" sz="1300" kern="0" spc="300" dirty="0">
-                <a:solidFill>
-                  <a:srgbClr val="5C2D91"/>
-                </a:solidFill>
-                <a:latin typeface="Segoe UI Semibold" pitchFamily="34" charset="0"/>
-                <a:ea typeface="Segoe UI Semibold" pitchFamily="34" charset="-122"/>
-                <a:cs typeface="Segoe UI Semibold" pitchFamily="34" charset="-120"/>
-              </a:rPr>
-              <a:t>WITH THE COPILOT SDK</a:t>
-            </a:r>
-            <a:endParaRPr lang="en-US" sz="1300" dirty="0"/>
-          </a:p>
-        </p:txBody>
-      </p:sp>
-      <p:sp>
-        <p:nvSpPr>
-          <p:cNvPr id="13" name="SDK heading"/>
-          <p:cNvSpPr/>
-          <p:nvPr/>
-        </p:nvSpPr>
-        <p:spPr>
-          <a:xfrm>
-            <a:off x="6871716" y="1965960"/>
-            <a:ext cx="4494276" cy="411480"/>
-          </a:xfrm>
-          <a:prstGeom prst="rect">
-            <a:avLst/>
-          </a:prstGeom>
-          <a:noFill/>
-          <a:ln/>
-        </p:spPr>
-        <p:txBody>
-          <a:bodyPr wrap="square" lIns="0" tIns="0" rIns="0" bIns="0" rtlCol="0" anchor="t"/>
-          <a:lstStyle/>
-          <a:p>
-            <a:pPr marL="0" indent="0">
-              <a:buNone/>
-            </a:pPr>
-            <a:r>
-              <a:rPr lang="en-US" sz="2400" dirty="0">
-                <a:solidFill>
-                  <a:srgbClr val="242424"/>
-                </a:solidFill>
-                <a:latin typeface="Segoe UI Semibold" pitchFamily="34" charset="0"/>
-                <a:ea typeface="Segoe UI Semibold" pitchFamily="34" charset="-122"/>
-                <a:cs typeface="Segoe UI Semibold" pitchFamily="34" charset="-120"/>
-              </a:rPr>
-              <a:t>One goal, many steps</a:t>
-            </a:r>
-            <a:endParaRPr lang="en-US" sz="2400" dirty="0"/>
-          </a:p>
-        </p:txBody>
-      </p:sp>
-      <p:sp>
-        <p:nvSpPr>
-          <p:cNvPr id="14" name="SDK body"/>
-          <p:cNvSpPr/>
-          <p:nvPr/>
-        </p:nvSpPr>
-        <p:spPr>
-          <a:xfrm>
-            <a:off x="6871716" y="2468880"/>
-            <a:ext cx="4494276" cy="594360"/>
-          </a:xfrm>
-          <a:prstGeom prst="rect">
-            <a:avLst/>
-          </a:prstGeom>
-          <a:noFill/>
-          <a:ln/>
-        </p:spPr>
-        <p:txBody>
-          <a:bodyPr wrap="square" lIns="0" tIns="0" rIns="0" bIns="0" rtlCol="0" anchor="t"/>
-          <a:lstStyle/>
-          <a:p>
-            <a:pPr marL="0" indent="0">
-              <a:buNone/>
-            </a:pPr>
-            <a:r>
-              <a:rPr lang="en-US" sz="1600" dirty="0">
-                <a:solidFill>
-                  <a:srgbClr val="242424"/>
-                </a:solidFill>
-                <a:latin typeface="Segoe UI" pitchFamily="34" charset="0"/>
-                <a:ea typeface="Segoe UI" pitchFamily="34" charset="-122"/>
-                <a:cs typeface="Segoe UI" pitchFamily="34" charset="-120"/>
-              </a:rPr>
-              <a:t>Copilot's agent runs in your app. It plans and calls your Java tools until the job is done.</a:t>
-            </a:r>
-            <a:endParaRPr lang="en-US" sz="1600" dirty="0"/>
-          </a:p>
-        </p:txBody>
-      </p:sp>
-      <p:sp>
-        <p:nvSpPr>
-          <p:cNvPr id="15" name="SDK code"/>
-          <p:cNvSpPr/>
-          <p:nvPr/>
-        </p:nvSpPr>
-        <p:spPr>
-          <a:xfrm>
-            <a:off x="6871716" y="3200400"/>
-            <a:ext cx="4494276" cy="274320"/>
-          </a:xfrm>
-          <a:prstGeom prst="rect">
-            <a:avLst/>
-          </a:prstGeom>
-          <a:noFill/>
-          <a:ln/>
-        </p:spPr>
-        <p:txBody>
-          <a:bodyPr wrap="square" lIns="0" tIns="0" rIns="0" bIns="0" rtlCol="0" anchor="t"/>
-          <a:lstStyle/>
-          <a:p>
-            <a:pPr marL="0" indent="0">
-              <a:buNone/>
-            </a:pPr>
-            <a:r>
-              <a:rPr lang="en-US" sz="1600" dirty="0">
-                <a:solidFill>
-                  <a:srgbClr val="5C2D91"/>
-                </a:solidFill>
-                <a:latin typeface="Consolas" pitchFamily="34" charset="0"/>
-                <a:ea typeface="Consolas" pitchFamily="34" charset="-122"/>
-                <a:cs typeface="Consolas" pitchFamily="34" charset="-120"/>
-              </a:rPr>
-              <a:t>@CopilotTool</a:t>
-            </a:r>
-            <a:r>
-              <a:rPr lang="en-US" sz="1600" dirty="0">
-                <a:solidFill>
-                  <a:srgbClr val="242424"/>
-                </a:solidFill>
-                <a:latin typeface="Consolas" pitchFamily="34" charset="0"/>
-                <a:ea typeface="Consolas" pitchFamily="34" charset="-122"/>
-                <a:cs typeface="Consolas" pitchFamily="34" charset="-120"/>
-              </a:rPr>
-              <a:t xml:space="preserve"> listProducts()</a:t>
-            </a:r>
-            <a:endParaRPr lang="en-US" sz="1600" dirty="0"/>
-          </a:p>
-        </p:txBody>
-      </p:sp>
-      <p:sp>
-        <p:nvSpPr>
-          <p:cNvPr id="16" name="Java card"/>
-          <p:cNvSpPr/>
-          <p:nvPr/>
-        </p:nvSpPr>
-        <p:spPr>
-          <a:xfrm>
-            <a:off x="548640" y="4114800"/>
-            <a:ext cx="11091672" cy="1554480"/>
-          </a:xfrm>
-          <a:prstGeom prst="rect">
-            <a:avLst/>
-          </a:prstGeom>
-          <a:solidFill>
-            <a:srgbClr val="FFFFFF"/>
-          </a:solidFill>
-          <a:ln w="9525">
-            <a:solidFill>
-              <a:srgbClr val="DEDEDE"/>
-            </a:solidFill>
-            <a:prstDash val="solid"/>
-          </a:ln>
-          <a:effectLst>
-            <a:outerShdw blurRad="101600" dist="25400" dir="5400000" algn="bl" rotWithShape="0">
-              <a:srgbClr val="000000">
-                <a:alpha val="12000"/>
-              </a:srgbClr>
-            </a:outerShdw>
-          </a:effectLst>
-        </p:spPr>
-        <p:txBody>
-          <a:bodyPr/>
-          <a:lstStyle/>
-          <a:p>
-            <a:endParaRPr lang="en-US"/>
-          </a:p>
-        </p:txBody>
-      </p:sp>
-      <p:sp>
-        <p:nvSpPr>
-          <p:cNvPr id="17" name="Java card bar"/>
-          <p:cNvSpPr/>
-          <p:nvPr/>
-        </p:nvSpPr>
-        <p:spPr>
-          <a:xfrm>
-            <a:off x="548640" y="4114800"/>
-            <a:ext cx="82296" cy="1554480"/>
-          </a:xfrm>
-          <a:prstGeom prst="rect">
-            <a:avLst/>
-          </a:prstGeom>
-          <a:solidFill>
-            <a:srgbClr val="5C2D91"/>
-          </a:solidFill>
-          <a:ln w="12700">
-            <a:solidFill>
-              <a:srgbClr val="5C2D91"/>
-            </a:solidFill>
-            <a:prstDash val="solid"/>
-          </a:ln>
-        </p:spPr>
-        <p:txBody>
-          <a:bodyPr/>
-          <a:lstStyle/>
-          <a:p>
-            <a:endParaRPr lang="en-US"/>
-          </a:p>
-        </p:txBody>
-      </p:sp>
-      <p:sp>
-        <p:nvSpPr>
-          <p:cNvPr id="18" name="Maven label"/>
-          <p:cNvSpPr/>
-          <p:nvPr/>
-        </p:nvSpPr>
-        <p:spPr>
-          <a:xfrm>
-            <a:off x="914400" y="4434840"/>
-            <a:ext cx="4494276" cy="228600"/>
-          </a:xfrm>
-          <a:prstGeom prst="rect">
-            <a:avLst/>
-          </a:prstGeom>
-          <a:noFill/>
-          <a:ln/>
-        </p:spPr>
-        <p:txBody>
-          <a:bodyPr wrap="square" lIns="0" tIns="0" rIns="0" bIns="0" rtlCol="0" anchor="t"/>
-          <a:lstStyle/>
-          <a:p>
-            <a:pPr marL="0" indent="0">
-              <a:buNone/>
-            </a:pPr>
-            <a:r>
-              <a:rPr lang="en-US" sz="1300" kern="0" spc="300" dirty="0">
-                <a:solidFill>
-                  <a:srgbClr val="5C2D91"/>
-                </a:solidFill>
-                <a:latin typeface="Segoe UI Semibold" pitchFamily="34" charset="0"/>
-                <a:ea typeface="Segoe UI Semibold" pitchFamily="34" charset="-122"/>
-                <a:cs typeface="Segoe UI Semibold" pitchFamily="34" charset="-120"/>
-              </a:rPr>
-              <a:t>MAVEN DEPENDENCIES</a:t>
-            </a:r>
-            <a:endParaRPr lang="en-US" sz="1300" dirty="0"/>
-          </a:p>
-        </p:txBody>
-      </p:sp>
-      <p:sp>
-        <p:nvSpPr>
-          <p:cNvPr id="19" name="Maven artifact"/>
-          <p:cNvSpPr/>
-          <p:nvPr/>
-        </p:nvSpPr>
-        <p:spPr>
-          <a:xfrm>
-            <a:off x="914400" y="4754880"/>
-            <a:ext cx="4494276" cy="594360"/>
-          </a:xfrm>
-          <a:prstGeom prst="rect">
-            <a:avLst/>
-          </a:prstGeom>
-          <a:noFill/>
-          <a:ln/>
-        </p:spPr>
-        <p:txBody>
-          <a:bodyPr wrap="square" lIns="0" tIns="0" rIns="0" bIns="0" rtlCol="0" anchor="t"/>
-          <a:lstStyle/>
-          <a:p>
-            <a:pPr marL="0" indent="0">
-              <a:buNone/>
-            </a:pPr>
-            <a:r>
-              <a:rPr lang="en-US" sz="1600" dirty="0">
-                <a:solidFill>
-                  <a:srgbClr val="242424"/>
-                </a:solidFill>
-                <a:latin typeface="Consolas" pitchFamily="34" charset="0"/>
-                <a:ea typeface="Consolas" pitchFamily="34" charset="-122"/>
-                <a:cs typeface="Consolas" pitchFamily="34" charset="-120"/>
-              </a:rPr>
-              <a:t>com.github:copilot-sdk-java</a:t>
-            </a:r>
-          </a:p>
-          <a:p>
-            <a:pPr marL="0" indent="0">
-              <a:buNone/>
-            </a:pPr>
-            <a:r>
-              <a:rPr lang="en-US" sz="1600" dirty="0">
-                <a:solidFill>
-                  <a:srgbClr val="242424"/>
-                </a:solidFill>
-                <a:latin typeface="Consolas" pitchFamily="34" charset="0"/>
-                <a:ea typeface="Consolas" pitchFamily="34" charset="-122"/>
-                <a:cs typeface="Consolas" pitchFamily="34" charset="-120"/>
-              </a:rPr>
-              <a:t>com.github:copilot-sdk-java-runtime</a:t>
-            </a:r>
-            <a:endParaRPr lang="en-US" sz="1600" dirty="0"/>
-          </a:p>
-        </p:txBody>
-      </p:sp>
-      <p:sp>
-        <p:nvSpPr>
-          <p:cNvPr id="20" name="Works with label"/>
-          <p:cNvSpPr/>
-          <p:nvPr/>
-        </p:nvSpPr>
-        <p:spPr>
-          <a:xfrm>
-            <a:off x="6871716" y="4434840"/>
-            <a:ext cx="4494276" cy="228600"/>
-          </a:xfrm>
-          <a:prstGeom prst="rect">
-            <a:avLst/>
-          </a:prstGeom>
-          <a:noFill/>
-          <a:ln/>
-        </p:spPr>
-        <p:txBody>
-          <a:bodyPr wrap="square" lIns="0" tIns="0" rIns="0" bIns="0" rtlCol="0" anchor="t"/>
-          <a:lstStyle/>
-          <a:p>
-            <a:pPr marL="0" indent="0">
-              <a:buNone/>
-            </a:pPr>
-            <a:r>
-              <a:rPr lang="en-US" sz="1300" kern="0" spc="300" dirty="0">
-                <a:solidFill>
-                  <a:srgbClr val="5C2D91"/>
-                </a:solidFill>
-                <a:latin typeface="Segoe UI Semibold" pitchFamily="34" charset="0"/>
-                <a:ea typeface="Segoe UI Semibold" pitchFamily="34" charset="-122"/>
-                <a:cs typeface="Segoe UI Semibold" pitchFamily="34" charset="-120"/>
-              </a:rPr>
-              <a:t>WORKS WITH</a:t>
-            </a:r>
-            <a:endParaRPr lang="en-US" sz="1300" dirty="0"/>
-          </a:p>
-        </p:txBody>
-      </p:sp>
-      <p:sp>
-        <p:nvSpPr>
-          <p:cNvPr id="21" name="Works with text"/>
-          <p:cNvSpPr/>
-          <p:nvPr/>
-        </p:nvSpPr>
-        <p:spPr>
-          <a:xfrm>
-            <a:off x="6871716" y="4754880"/>
-            <a:ext cx="4494276" cy="594360"/>
-          </a:xfrm>
-          <a:prstGeom prst="rect">
-            <a:avLst/>
-          </a:prstGeom>
-          <a:noFill/>
-          <a:ln/>
-        </p:spPr>
-        <p:txBody>
-          <a:bodyPr wrap="square" lIns="0" tIns="0" rIns="0" bIns="0" rtlCol="0" anchor="t"/>
-          <a:lstStyle/>
-          <a:p>
-            <a:pPr marL="0" indent="0">
-              <a:buNone/>
-            </a:pPr>
-            <a:r>
-              <a:rPr lang="en-US" sz="1600" dirty="0">
-                <a:solidFill>
-                  <a:srgbClr val="242424"/>
-                </a:solidFill>
-                <a:latin typeface="Segoe UI" pitchFamily="34" charset="0"/>
-                <a:ea typeface="Segoe UI" pitchFamily="34" charset="-122"/>
-                <a:cs typeface="Segoe UI" pitchFamily="34" charset="-120"/>
-              </a:rPr>
-              <a:t>Your own Foundry model with managed identity: no keys. Or a GitHub Copilot subscription.</a:t>
-            </a:r>
-            <a:endParaRPr lang="en-US" sz="1600" dirty="0"/>
-          </a:p>
-        </p:txBody>
-      </p:sp>
-      <p:sp>
-        <p:nvSpPr>
-          <p:cNvPr id="22" name="Footnote"/>
-          <p:cNvSpPr/>
-          <p:nvPr/>
-        </p:nvSpPr>
-        <p:spPr>
-          <a:xfrm>
-            <a:off x="548640" y="5943600"/>
-            <a:ext cx="11091672" cy="274320"/>
-          </a:xfrm>
-          <a:prstGeom prst="rect">
-            <a:avLst/>
-          </a:prstGeom>
-          <a:noFill/>
-          <a:ln/>
-        </p:spPr>
-        <p:txBody>
-          <a:bodyPr wrap="square" lIns="0" tIns="0" rIns="0" bIns="0" rtlCol="0" anchor="t"/>
-          <a:lstStyle/>
-          <a:p>
-            <a:pPr marL="0" indent="0">
-              <a:buNone/>
-            </a:pPr>
-            <a:r>
-              <a:rPr lang="en-US" sz="1200" dirty="0">
-                <a:solidFill>
-                  <a:srgbClr val="5C5C5C"/>
-                </a:solidFill>
-                <a:latin typeface="Segoe UI" pitchFamily="34" charset="0"/>
-                <a:ea typeface="Segoe UI" pitchFamily="34" charset="-122"/>
-                <a:cs typeface="Segoe UI" pitchFamily="34" charset="-120"/>
-              </a:rPr>
-              <a:t>See it working in the step-3-copilot-sdk folder. The SDK's Java releases are still labeled preview. Learn more at github.com/github/copilot-sdk</a:t>
-            </a:r>
-            <a:endParaRPr lang="en-US" sz="1200" dirty="0"/>
-          </a:p>
-        </p:txBody>
-      </p:sp>
-    </p:spTree>
-  </p:cSld>
-  <p:clrMapOvr>
-    <a:masterClrMapping/>
-  </p:clrMapOvr>
-</p:sld>
-</file>
-
-<file path=ppt/slides/slide14.xml><?xml version="1.0" encoding="utf-8"?>
-<p:sld xmlns:a="http://schemas.openxmlformats.org/drawingml/2006/main" xmlns:r="http://schemas.openxmlformats.org/officeDocument/2006/relationships" xmlns:p="http://schemas.openxmlformats.org/presentationml/2006/main">
-  <p:cSld name="Copilot SDK question">
-    <p:bg>
-      <p:bgPr>
-        <a:solidFill>
-          <a:srgbClr val="F7F4EF"/>
-        </a:solidFill>
-        <a:effectLst/>
-      </p:bgPr>
-    </p:bg>
-    <p:spTree>
-      <p:nvGrpSpPr>
-        <p:cNvPr id="1" name=""/>
-        <p:cNvGrpSpPr/>
-        <p:nvPr/>
-      </p:nvGrpSpPr>
-      <p:grpSpPr>
-        <a:xfrm>
-          <a:off x="0" y="0"/>
-          <a:ext cx="0" cy="0"/>
-          <a:chOff x="0" y="0"/>
-          <a:chExt cx="0" cy="0"/>
-        </a:xfrm>
-      </p:grpSpPr>
-      <p:sp>
-        <p:nvSpPr>
-          <p:cNvPr id="2" name="Text 0"/>
-          <p:cNvSpPr/>
-          <p:nvPr/>
-        </p:nvSpPr>
-        <p:spPr>
-          <a:xfrm>
-            <a:off x="548640" y="320040"/>
-            <a:ext cx="11064240" cy="566928"/>
-          </a:xfrm>
-          <a:prstGeom prst="rect">
-            <a:avLst/>
-          </a:prstGeom>
-          <a:noFill/>
-          <a:ln/>
-        </p:spPr>
-        <p:txBody>
-          <a:bodyPr wrap="square" lIns="0" tIns="0" rIns="0" bIns="0" rtlCol="0" anchor="ctr"/>
-          <a:lstStyle/>
-          <a:p>
-            <a:pPr marL="0" indent="0">
-              <a:buNone/>
-            </a:pPr>
-            <a:r>
-              <a:rPr lang="en-US" sz="3200" dirty="0">
-                <a:solidFill>
-                  <a:srgbClr val="5C2D91"/>
-                </a:solidFill>
-                <a:latin typeface="Segoe UI Semibold" pitchFamily="34" charset="0"/>
-                <a:ea typeface="Segoe UI Semibold" pitchFamily="34" charset="-122"/>
-                <a:cs typeface="Segoe UI Semibold" pitchFamily="34" charset="-120"/>
-              </a:rPr>
-              <a:t xml:space="preserve">Step 3   </a:t>
-            </a:r>
-            <a:r>
-              <a:rPr lang="en-US" sz="3200" dirty="0">
-                <a:solidFill>
-                  <a:srgbClr val="242424"/>
-                </a:solidFill>
-                <a:latin typeface="Segoe UI Semibold" pitchFamily="34" charset="0"/>
-                <a:ea typeface="Segoe UI Semibold" pitchFamily="34" charset="-122"/>
-                <a:cs typeface="Segoe UI Semibold" pitchFamily="34" charset="-120"/>
-              </a:rPr>
-              <a:t>How the Copilot SDK answers a question</a:t>
-            </a:r>
-            <a:endParaRPr lang="en-US" sz="3200" dirty="0"/>
-          </a:p>
-        </p:txBody>
-      </p:sp>
-      <p:pic>
-        <p:nvPicPr>
-          <p:cNvPr id="3" name="Image 0" descr="Ten numbered messages between you, the app, Copilot's agent, the listProducts tool and the model: the app hands the question to Copilot's agent, which calls the model twice and has the SDK run the Java tool once, then hands the answer back"/>
-          <p:cNvPicPr>
-            <a:picLocks noChangeAspect="1"/>
-          </p:cNvPicPr>
-          <p:nvPr/>
-        </p:nvPicPr>
-        <p:blipFill>
-          <a:blip r:embed="rId3"/>
-          <a:stretch>
-            <a:fillRect/>
-          </a:stretch>
-        </p:blipFill>
-        <p:spPr>
-          <a:xfrm>
-            <a:off x="598322" y="1051560"/>
-            <a:ext cx="10995355" cy="5349240"/>
-          </a:xfrm>
-          <a:prstGeom prst="rect">
-            <a:avLst/>
-          </a:prstGeom>
-        </p:spPr>
-      </p:pic>
     </p:spTree>
   </p:cSld>
   <p:clrMapOvr>
@@ -8634,7 +8375,7 @@
 
 <file path=ppt/slides/slide8.xml><?xml version="1.0" encoding="utf-8"?>
 <p:sld xmlns:a="http://schemas.openxmlformats.org/drawingml/2006/main" xmlns:r="http://schemas.openxmlformats.org/officeDocument/2006/relationships" xmlns:p="http://schemas.openxmlformats.org/presentationml/2006/main">
-  <p:cSld name="Slide 8">
+  <p:cSld name="Copilot SDK">
     <p:bg>
       <p:bgPr>
         <a:solidFill>
@@ -8659,7 +8400,7 @@
       </p:grpSpPr>
       <p:sp>
         <p:nvSpPr>
-          <p:cNvPr id="2" name="Text 0"/>
+          <p:cNvPr id="2" name="Title"/>
           <p:cNvSpPr/>
           <p:nvPr/>
         </p:nvSpPr>
@@ -8684,13 +8425,13 @@
             <a:r>
               <a:rPr lang="en-US" sz="3200" dirty="0">
                 <a:solidFill>
-                  <a:srgbClr val="107C10"/>
+                  <a:srgbClr val="5C2D91"/>
                 </a:solidFill>
                 <a:latin typeface="Segoe UI Semibold" pitchFamily="34" charset="0"/>
                 <a:ea typeface="Segoe UI Semibold" pitchFamily="34" charset="-122"/>
                 <a:cs typeface="Segoe UI Semibold" pitchFamily="34" charset="-120"/>
               </a:rPr>
-              <a:t xml:space="preserve">Step 4   </a:t>
+              <a:t xml:space="preserve">Step 3   </a:t>
             </a:r>
             <a:r>
               <a:rPr lang="en-US" sz="3200" dirty="0">
@@ -8701,46 +8442,22 @@
                 <a:ea typeface="Segoe UI Semibold" pitchFamily="34" charset="-122"/>
                 <a:cs typeface="Segoe UI Semibold" pitchFamily="34" charset="-120"/>
               </a:rPr>
-              <a:t>How traces get to Application Insights</a:t>
+              <a:t>Going further: the GitHub Copilot SDK</a:t>
             </a:r>
             <a:endParaRPr lang="en-US" sz="3200" dirty="0"/>
           </a:p>
         </p:txBody>
       </p:sp>
-      <p:pic>
-        <p:nvPicPr>
-          <p:cNvPr id="3" name="Image 0" descr="The app sends traces to the Container Apps environment, which forwards them to Application Insights, where you can query tokens and cost or open one question as a timeline"/>
-          <p:cNvPicPr>
-            <a:picLocks noChangeAspect="1"/>
-          </p:cNvPicPr>
-          <p:nvPr/>
-        </p:nvPicPr>
-        <p:blipFill>
-          <a:blip r:embed="rId3"/>
-          <a:stretch>
-            <a:fillRect/>
-          </a:stretch>
-        </p:blipFill>
-        <p:spPr>
-          <a:xfrm>
-            <a:off x="365760" y="1401693"/>
-            <a:ext cx="11457432" cy="3505974"/>
-          </a:xfrm>
-          <a:prstGeom prst="rect">
-            <a:avLst/>
-          </a:prstGeom>
-        </p:spPr>
-      </p:pic>
-      <p:sp>
-        <p:nvSpPr>
-          <p:cNvPr id="4" name="Shape 1"/>
-          <p:cNvSpPr/>
-          <p:nvPr/>
-        </p:nvSpPr>
-        <p:spPr>
-          <a:xfrm>
-            <a:off x="548640" y="5440680"/>
-            <a:ext cx="11091672" cy="960120"/>
+      <p:sp>
+        <p:nvSpPr>
+          <p:cNvPr id="3" name="Saw card"/>
+          <p:cNvSpPr/>
+          <p:nvPr/>
+        </p:nvSpPr>
+        <p:spPr>
+          <a:xfrm>
+            <a:off x="548640" y="1325880"/>
+            <a:ext cx="5134356" cy="2468880"/>
           </a:xfrm>
           <a:prstGeom prst="rect">
             <a:avLst/>
@@ -8766,30 +8483,30 @@
           <a:bodyPr/>
           <a:lstStyle/>
           <a:p>
-            <a:endParaRPr lang="en-ZA"/>
-          </a:p>
-        </p:txBody>
-      </p:sp>
-      <p:sp>
-        <p:nvSpPr>
-          <p:cNvPr id="5" name="Shape 2"/>
-          <p:cNvSpPr/>
-          <p:nvPr/>
-        </p:nvSpPr>
-        <p:spPr>
-          <a:xfrm>
-            <a:off x="548640" y="5440680"/>
-            <a:ext cx="82296" cy="960120"/>
+            <a:endParaRPr lang="en-US"/>
+          </a:p>
+        </p:txBody>
+      </p:sp>
+      <p:sp>
+        <p:nvSpPr>
+          <p:cNvPr id="4" name="Saw card bar"/>
+          <p:cNvSpPr/>
+          <p:nvPr/>
+        </p:nvSpPr>
+        <p:spPr>
+          <a:xfrm>
+            <a:off x="548640" y="1325880"/>
+            <a:ext cx="82296" cy="2468880"/>
           </a:xfrm>
           <a:prstGeom prst="rect">
             <a:avLst/>
           </a:prstGeom>
           <a:solidFill>
-            <a:srgbClr val="107C10"/>
+            <a:srgbClr val="5C2D91"/>
           </a:solidFill>
           <a:ln w="12700">
             <a:solidFill>
-              <a:srgbClr val="107C10"/>
+              <a:srgbClr val="5C2D91"/>
             </a:solidFill>
             <a:prstDash val="solid"/>
           </a:ln>
@@ -8798,29 +8515,29 @@
           <a:bodyPr/>
           <a:lstStyle/>
           <a:p>
-            <a:endParaRPr lang="en-ZA"/>
-          </a:p>
-        </p:txBody>
-      </p:sp>
-      <p:sp>
-        <p:nvSpPr>
-          <p:cNvPr id="6" name="Text 3"/>
-          <p:cNvSpPr/>
-          <p:nvPr/>
-        </p:nvSpPr>
-        <p:spPr>
-          <a:xfrm>
-            <a:off x="868680" y="5568696"/>
-            <a:ext cx="3566160" cy="274320"/>
-          </a:xfrm>
-          <a:prstGeom prst="rect">
-            <a:avLst/>
-          </a:prstGeom>
-          <a:noFill/>
-          <a:ln/>
-        </p:spPr>
-        <p:txBody>
-          <a:bodyPr wrap="square" lIns="0" tIns="0" rIns="0" bIns="0" rtlCol="0" anchor="ctr"/>
+            <a:endParaRPr lang="en-US"/>
+          </a:p>
+        </p:txBody>
+      </p:sp>
+      <p:sp>
+        <p:nvSpPr>
+          <p:cNvPr id="5" name="Saw label"/>
+          <p:cNvSpPr/>
+          <p:nvPr/>
+        </p:nvSpPr>
+        <p:spPr>
+          <a:xfrm>
+            <a:off x="914400" y="1645920"/>
+            <a:ext cx="4494276" cy="228600"/>
+          </a:xfrm>
+          <a:prstGeom prst="rect">
+            <a:avLst/>
+          </a:prstGeom>
+          <a:noFill/>
+          <a:ln/>
+        </p:spPr>
+        <p:txBody>
+          <a:bodyPr wrap="square" lIns="0" tIns="0" rIns="0" bIns="0" rtlCol="0" anchor="t"/>
           <a:lstStyle/>
           <a:p>
             <a:pPr marL="0" indent="0">
@@ -8829,13 +8546,13 @@
             <a:r>
               <a:rPr lang="en-US" sz="1300" kern="0" spc="300" dirty="0">
                 <a:solidFill>
-                  <a:srgbClr val="107C10"/>
+                  <a:srgbClr val="5C2D91"/>
                 </a:solidFill>
                 <a:latin typeface="Segoe UI Semibold" pitchFamily="34" charset="0"/>
                 <a:ea typeface="Segoe UI Semibold" pitchFamily="34" charset="-122"/>
                 <a:cs typeface="Segoe UI Semibold" pitchFamily="34" charset="-120"/>
               </a:rPr>
-              <a:t>READ</a:t>
+              <a:t>WHAT YOU JUST SAW</a:t>
             </a:r>
             <a:endParaRPr lang="en-US" sz="1300" dirty="0"/>
           </a:p>
@@ -8843,14 +8560,14 @@
       </p:sp>
       <p:sp>
         <p:nvSpPr>
-          <p:cNvPr id="7" name="Text 4"/>
-          <p:cNvSpPr/>
-          <p:nvPr/>
-        </p:nvSpPr>
-        <p:spPr>
-          <a:xfrm>
-            <a:off x="868680" y="5843016"/>
-            <a:ext cx="3566160" cy="457200"/>
+          <p:cNvPr id="6" name="Saw heading"/>
+          <p:cNvSpPr/>
+          <p:nvPr/>
+        </p:nvSpPr>
+        <p:spPr>
+          <a:xfrm>
+            <a:off x="914400" y="1965960"/>
+            <a:ext cx="4494276" cy="411480"/>
           </a:xfrm>
           <a:prstGeom prst="rect">
             <a:avLst/>
@@ -8866,39 +8583,221 @@
               <a:buNone/>
             </a:pPr>
             <a:r>
-              <a:rPr lang="en-US" sz="1300" dirty="0">
+              <a:rPr lang="en-US" sz="2400" dirty="0">
                 <a:solidFill>
                   <a:srgbClr val="242424"/>
+                </a:solidFill>
+                <a:latin typeface="Segoe UI Semibold" pitchFamily="34" charset="0"/>
+                <a:ea typeface="Segoe UI Semibold" pitchFamily="34" charset="-122"/>
+                <a:cs typeface="Segoe UI Semibold" pitchFamily="34" charset="-120"/>
+              </a:rPr>
+              <a:t>One question, one tool</a:t>
+            </a:r>
+            <a:endParaRPr lang="en-US" sz="2400" dirty="0"/>
+          </a:p>
+        </p:txBody>
+      </p:sp>
+      <p:sp>
+        <p:nvSpPr>
+          <p:cNvPr id="7" name="Saw body"/>
+          <p:cNvSpPr/>
+          <p:nvPr/>
+        </p:nvSpPr>
+        <p:spPr>
+          <a:xfrm>
+            <a:off x="914400" y="2468880"/>
+            <a:ext cx="4494276" cy="594360"/>
+          </a:xfrm>
+          <a:prstGeom prst="rect">
+            <a:avLst/>
+          </a:prstGeom>
+          <a:noFill/>
+          <a:ln/>
+        </p:spPr>
+        <p:txBody>
+          <a:bodyPr wrap="square" lIns="0" tIns="0" rIns="0" bIns="0" rtlCol="0" anchor="t"/>
+          <a:lstStyle/>
+          <a:p>
+            <a:pPr marL="0" indent="0">
+              <a:buNone/>
+            </a:pPr>
+            <a:r>
+              <a:rPr lang="en-US" sz="1600" dirty="0">
+                <a:solidFill>
+                  <a:srgbClr val="242424"/>
+                </a:solidFill>
+                <a:latin typeface="Segoe UI" pitchFamily="34" charset="0"/>
+                <a:ea typeface="Segoe UI" pitchFamily="34" charset="-122"/>
+                <a:cs typeface="Segoe UI" pitchFamily="34" charset="-120"/>
+              </a:rPr>
+              <a:t>In this app, the model asks to run your Java method, then answers your question.</a:t>
+            </a:r>
+            <a:endParaRPr lang="en-US" sz="1600" dirty="0"/>
+          </a:p>
+        </p:txBody>
+      </p:sp>
+      <p:sp>
+        <p:nvSpPr>
+          <p:cNvPr id="8" name="Saw code"/>
+          <p:cNvSpPr/>
+          <p:nvPr/>
+        </p:nvSpPr>
+        <p:spPr>
+          <a:xfrm>
+            <a:off x="914400" y="3200400"/>
+            <a:ext cx="4494276" cy="274320"/>
+          </a:xfrm>
+          <a:prstGeom prst="rect">
+            <a:avLst/>
+          </a:prstGeom>
+          <a:noFill/>
+          <a:ln/>
+        </p:spPr>
+        <p:txBody>
+          <a:bodyPr wrap="square" lIns="0" tIns="0" rIns="0" bIns="0" rtlCol="0" anchor="t"/>
+          <a:lstStyle/>
+          <a:p>
+            <a:pPr marL="0" indent="0">
+              <a:buNone/>
+            </a:pPr>
+            <a:r>
+              <a:rPr lang="en-US" sz="1600" dirty="0">
+                <a:solidFill>
+                  <a:srgbClr val="5C2D91"/>
                 </a:solidFill>
                 <a:latin typeface="Consolas" pitchFamily="34" charset="0"/>
                 <a:ea typeface="Consolas" pitchFamily="34" charset="-122"/>
                 <a:cs typeface="Consolas" pitchFamily="34" charset="-120"/>
               </a:rPr>
-              <a:t>pom.xml   application.properties   infra/app.bicep</a:t>
-            </a:r>
-            <a:endParaRPr lang="en-US" sz="1300" dirty="0"/>
-          </a:p>
-        </p:txBody>
-      </p:sp>
-      <p:sp>
-        <p:nvSpPr>
-          <p:cNvPr id="8" name="Text 5"/>
-          <p:cNvSpPr/>
-          <p:nvPr/>
-        </p:nvSpPr>
-        <p:spPr>
-          <a:xfrm>
-            <a:off x="4709160" y="5568696"/>
-            <a:ext cx="6675120" cy="274320"/>
-          </a:xfrm>
-          <a:prstGeom prst="rect">
-            <a:avLst/>
-          </a:prstGeom>
-          <a:noFill/>
-          <a:ln/>
-        </p:spPr>
-        <p:txBody>
-          <a:bodyPr wrap="square" lIns="0" tIns="0" rIns="0" bIns="0" rtlCol="0" anchor="ctr"/>
+              <a:t>@Tool</a:t>
+            </a:r>
+            <a:r>
+              <a:rPr lang="en-US" sz="1600" dirty="0">
+                <a:solidFill>
+                  <a:srgbClr val="242424"/>
+                </a:solidFill>
+                <a:latin typeface="Consolas" pitchFamily="34" charset="0"/>
+                <a:ea typeface="Consolas" pitchFamily="34" charset="-122"/>
+                <a:cs typeface="Consolas" pitchFamily="34" charset="-120"/>
+              </a:rPr>
+              <a:t xml:space="preserve"> listProducts()</a:t>
+            </a:r>
+            <a:endParaRPr lang="en-US" sz="1600" dirty="0"/>
+          </a:p>
+        </p:txBody>
+      </p:sp>
+      <p:cxnSp>
+        <p:nvCxnSpPr>
+          <p:cNvPr id="9" name="Arrow"/>
+          <p:cNvCxnSpPr/>
+          <p:nvPr/>
+        </p:nvCxnSpPr>
+        <p:spPr>
+          <a:xfrm>
+            <a:off x="5957316" y="2560320"/>
+            <a:ext cx="274320" cy="0"/>
+          </a:xfrm>
+          <a:prstGeom prst="straightConnector1">
+            <a:avLst/>
+          </a:prstGeom>
+          <a:ln w="28575">
+            <a:solidFill>
+              <a:srgbClr val="5C2D91"/>
+            </a:solidFill>
+            <a:tailEnd type="triangle" w="med" len="med"/>
+          </a:ln>
+        </p:spPr>
+      </p:cxnSp>
+      <p:sp>
+        <p:nvSpPr>
+          <p:cNvPr id="10" name="SDK card"/>
+          <p:cNvSpPr/>
+          <p:nvPr/>
+        </p:nvSpPr>
+        <p:spPr>
+          <a:xfrm>
+            <a:off x="6505956" y="1325880"/>
+            <a:ext cx="5134356" cy="2468880"/>
+          </a:xfrm>
+          <a:prstGeom prst="rect">
+            <a:avLst/>
+          </a:prstGeom>
+          <a:solidFill>
+            <a:srgbClr val="FFFFFF"/>
+          </a:solidFill>
+          <a:ln w="9525">
+            <a:solidFill>
+              <a:srgbClr val="DEDEDE"/>
+            </a:solidFill>
+            <a:prstDash val="solid"/>
+          </a:ln>
+          <a:effectLst>
+            <a:outerShdw blurRad="101600" dist="25400" dir="5400000" algn="bl" rotWithShape="0">
+              <a:srgbClr val="000000">
+                <a:alpha val="12000"/>
+              </a:srgbClr>
+            </a:outerShdw>
+          </a:effectLst>
+        </p:spPr>
+        <p:txBody>
+          <a:bodyPr/>
+          <a:lstStyle/>
+          <a:p>
+            <a:endParaRPr lang="en-US"/>
+          </a:p>
+        </p:txBody>
+      </p:sp>
+      <p:sp>
+        <p:nvSpPr>
+          <p:cNvPr id="11" name="SDK card bar"/>
+          <p:cNvSpPr/>
+          <p:nvPr/>
+        </p:nvSpPr>
+        <p:spPr>
+          <a:xfrm>
+            <a:off x="6505956" y="1325880"/>
+            <a:ext cx="82296" cy="2468880"/>
+          </a:xfrm>
+          <a:prstGeom prst="rect">
+            <a:avLst/>
+          </a:prstGeom>
+          <a:solidFill>
+            <a:srgbClr val="5C2D91"/>
+          </a:solidFill>
+          <a:ln w="12700">
+            <a:solidFill>
+              <a:srgbClr val="5C2D91"/>
+            </a:solidFill>
+            <a:prstDash val="solid"/>
+          </a:ln>
+        </p:spPr>
+        <p:txBody>
+          <a:bodyPr/>
+          <a:lstStyle/>
+          <a:p>
+            <a:endParaRPr lang="en-US"/>
+          </a:p>
+        </p:txBody>
+      </p:sp>
+      <p:sp>
+        <p:nvSpPr>
+          <p:cNvPr id="12" name="SDK label"/>
+          <p:cNvSpPr/>
+          <p:nvPr/>
+        </p:nvSpPr>
+        <p:spPr>
+          <a:xfrm>
+            <a:off x="6871716" y="1645920"/>
+            <a:ext cx="4494276" cy="228600"/>
+          </a:xfrm>
+          <a:prstGeom prst="rect">
+            <a:avLst/>
+          </a:prstGeom>
+          <a:noFill/>
+          <a:ln/>
+        </p:spPr>
+        <p:txBody>
+          <a:bodyPr wrap="square" lIns="0" tIns="0" rIns="0" bIns="0" rtlCol="0" anchor="t"/>
           <a:lstStyle/>
           <a:p>
             <a:pPr marL="0" indent="0">
@@ -8907,13 +8806,13 @@
             <a:r>
               <a:rPr lang="en-US" sz="1300" kern="0" spc="300" dirty="0">
                 <a:solidFill>
-                  <a:srgbClr val="107C10"/>
+                  <a:srgbClr val="5C2D91"/>
                 </a:solidFill>
                 <a:latin typeface="Segoe UI Semibold" pitchFamily="34" charset="0"/>
                 <a:ea typeface="Segoe UI Semibold" pitchFamily="34" charset="-122"/>
                 <a:cs typeface="Segoe UI Semibold" pitchFamily="34" charset="-120"/>
               </a:rPr>
-              <a:t>FIND</a:t>
+              <a:t>WITH THE COPILOT SDK</a:t>
             </a:r>
             <a:endParaRPr lang="en-US" sz="1300" dirty="0"/>
           </a:p>
@@ -8921,14 +8820,14 @@
       </p:sp>
       <p:sp>
         <p:nvSpPr>
-          <p:cNvPr id="9" name="Text 6"/>
-          <p:cNvSpPr/>
-          <p:nvPr/>
-        </p:nvSpPr>
-        <p:spPr>
-          <a:xfrm>
-            <a:off x="4709160" y="5843016"/>
-            <a:ext cx="6720840" cy="457200"/>
+          <p:cNvPr id="13" name="SDK heading"/>
+          <p:cNvSpPr/>
+          <p:nvPr/>
+        </p:nvSpPr>
+        <p:spPr>
+          <a:xfrm>
+            <a:off x="6871716" y="1965960"/>
+            <a:ext cx="4494276" cy="411480"/>
           </a:xfrm>
           <a:prstGeom prst="rect">
             <a:avLst/>
@@ -8944,7 +8843,46 @@
               <a:buNone/>
             </a:pPr>
             <a:r>
-              <a:rPr lang="en-US" sz="1400" dirty="0">
+              <a:rPr lang="en-US" sz="2400" dirty="0">
+                <a:solidFill>
+                  <a:srgbClr val="242424"/>
+                </a:solidFill>
+                <a:latin typeface="Segoe UI Semibold" pitchFamily="34" charset="0"/>
+                <a:ea typeface="Segoe UI Semibold" pitchFamily="34" charset="-122"/>
+                <a:cs typeface="Segoe UI Semibold" pitchFamily="34" charset="-120"/>
+              </a:rPr>
+              <a:t>One goal, many steps</a:t>
+            </a:r>
+            <a:endParaRPr lang="en-US" sz="2400" dirty="0"/>
+          </a:p>
+        </p:txBody>
+      </p:sp>
+      <p:sp>
+        <p:nvSpPr>
+          <p:cNvPr id="14" name="SDK body"/>
+          <p:cNvSpPr/>
+          <p:nvPr/>
+        </p:nvSpPr>
+        <p:spPr>
+          <a:xfrm>
+            <a:off x="6871716" y="2468880"/>
+            <a:ext cx="4494276" cy="594360"/>
+          </a:xfrm>
+          <a:prstGeom prst="rect">
+            <a:avLst/>
+          </a:prstGeom>
+          <a:noFill/>
+          <a:ln/>
+        </p:spPr>
+        <p:txBody>
+          <a:bodyPr wrap="square" lIns="0" tIns="0" rIns="0" bIns="0" rtlCol="0" anchor="t"/>
+          <a:lstStyle/>
+          <a:p>
+            <a:pPr marL="0" indent="0">
+              <a:buNone/>
+            </a:pPr>
+            <a:r>
+              <a:rPr lang="en-US" sz="1600" dirty="0">
                 <a:solidFill>
                   <a:srgbClr val="242424"/>
                 </a:solidFill>
@@ -8952,16 +8890,292 @@
                 <a:ea typeface="Segoe UI" pitchFamily="34" charset="-122"/>
                 <a:cs typeface="Segoe UI" pitchFamily="34" charset="-120"/>
               </a:rPr>
-              <a:t>How many model calls does one product question make, and why?</a:t>
-            </a:r>
-            <a:endParaRPr lang="en-US" sz="1400" dirty="0"/>
-          </a:p>
-          <a:p>
-            <a:pPr marL="0" indent="0">
-              <a:buNone/>
-            </a:pPr>
-            <a:r>
-              <a:rPr lang="en-US" sz="1400" dirty="0">
+              <a:t>Copilot's agent runs in your app. It plans and calls your Java tools until the job is done.</a:t>
+            </a:r>
+            <a:endParaRPr lang="en-US" sz="1600" dirty="0"/>
+          </a:p>
+        </p:txBody>
+      </p:sp>
+      <p:sp>
+        <p:nvSpPr>
+          <p:cNvPr id="15" name="SDK code"/>
+          <p:cNvSpPr/>
+          <p:nvPr/>
+        </p:nvSpPr>
+        <p:spPr>
+          <a:xfrm>
+            <a:off x="6871716" y="3200400"/>
+            <a:ext cx="4494276" cy="274320"/>
+          </a:xfrm>
+          <a:prstGeom prst="rect">
+            <a:avLst/>
+          </a:prstGeom>
+          <a:noFill/>
+          <a:ln/>
+        </p:spPr>
+        <p:txBody>
+          <a:bodyPr wrap="square" lIns="0" tIns="0" rIns="0" bIns="0" rtlCol="0" anchor="t"/>
+          <a:lstStyle/>
+          <a:p>
+            <a:pPr marL="0" indent="0">
+              <a:buNone/>
+            </a:pPr>
+            <a:r>
+              <a:rPr lang="en-US" sz="1600" dirty="0">
+                <a:solidFill>
+                  <a:srgbClr val="5C2D91"/>
+                </a:solidFill>
+                <a:latin typeface="Consolas" pitchFamily="34" charset="0"/>
+                <a:ea typeface="Consolas" pitchFamily="34" charset="-122"/>
+                <a:cs typeface="Consolas" pitchFamily="34" charset="-120"/>
+              </a:rPr>
+              <a:t>@CopilotTool</a:t>
+            </a:r>
+            <a:r>
+              <a:rPr lang="en-US" sz="1600" dirty="0">
+                <a:solidFill>
+                  <a:srgbClr val="242424"/>
+                </a:solidFill>
+                <a:latin typeface="Consolas" pitchFamily="34" charset="0"/>
+                <a:ea typeface="Consolas" pitchFamily="34" charset="-122"/>
+                <a:cs typeface="Consolas" pitchFamily="34" charset="-120"/>
+              </a:rPr>
+              <a:t xml:space="preserve"> listProducts()</a:t>
+            </a:r>
+            <a:endParaRPr lang="en-US" sz="1600" dirty="0"/>
+          </a:p>
+        </p:txBody>
+      </p:sp>
+      <p:sp>
+        <p:nvSpPr>
+          <p:cNvPr id="16" name="Java card"/>
+          <p:cNvSpPr/>
+          <p:nvPr/>
+        </p:nvSpPr>
+        <p:spPr>
+          <a:xfrm>
+            <a:off x="548640" y="4114800"/>
+            <a:ext cx="11091672" cy="1554480"/>
+          </a:xfrm>
+          <a:prstGeom prst="rect">
+            <a:avLst/>
+          </a:prstGeom>
+          <a:solidFill>
+            <a:srgbClr val="FFFFFF"/>
+          </a:solidFill>
+          <a:ln w="9525">
+            <a:solidFill>
+              <a:srgbClr val="DEDEDE"/>
+            </a:solidFill>
+            <a:prstDash val="solid"/>
+          </a:ln>
+          <a:effectLst>
+            <a:outerShdw blurRad="101600" dist="25400" dir="5400000" algn="bl" rotWithShape="0">
+              <a:srgbClr val="000000">
+                <a:alpha val="12000"/>
+              </a:srgbClr>
+            </a:outerShdw>
+          </a:effectLst>
+        </p:spPr>
+        <p:txBody>
+          <a:bodyPr/>
+          <a:lstStyle/>
+          <a:p>
+            <a:endParaRPr lang="en-US"/>
+          </a:p>
+        </p:txBody>
+      </p:sp>
+      <p:sp>
+        <p:nvSpPr>
+          <p:cNvPr id="17" name="Java card bar"/>
+          <p:cNvSpPr/>
+          <p:nvPr/>
+        </p:nvSpPr>
+        <p:spPr>
+          <a:xfrm>
+            <a:off x="548640" y="4114800"/>
+            <a:ext cx="82296" cy="1554480"/>
+          </a:xfrm>
+          <a:prstGeom prst="rect">
+            <a:avLst/>
+          </a:prstGeom>
+          <a:solidFill>
+            <a:srgbClr val="5C2D91"/>
+          </a:solidFill>
+          <a:ln w="12700">
+            <a:solidFill>
+              <a:srgbClr val="5C2D91"/>
+            </a:solidFill>
+            <a:prstDash val="solid"/>
+          </a:ln>
+        </p:spPr>
+        <p:txBody>
+          <a:bodyPr/>
+          <a:lstStyle/>
+          <a:p>
+            <a:endParaRPr lang="en-US"/>
+          </a:p>
+        </p:txBody>
+      </p:sp>
+      <p:sp>
+        <p:nvSpPr>
+          <p:cNvPr id="18" name="Maven label"/>
+          <p:cNvSpPr/>
+          <p:nvPr/>
+        </p:nvSpPr>
+        <p:spPr>
+          <a:xfrm>
+            <a:off x="914400" y="4434840"/>
+            <a:ext cx="4494276" cy="228600"/>
+          </a:xfrm>
+          <a:prstGeom prst="rect">
+            <a:avLst/>
+          </a:prstGeom>
+          <a:noFill/>
+          <a:ln/>
+        </p:spPr>
+        <p:txBody>
+          <a:bodyPr wrap="square" lIns="0" tIns="0" rIns="0" bIns="0" rtlCol="0" anchor="t"/>
+          <a:lstStyle/>
+          <a:p>
+            <a:pPr marL="0" indent="0">
+              <a:buNone/>
+            </a:pPr>
+            <a:r>
+              <a:rPr lang="en-US" sz="1300" kern="0" spc="300" dirty="0">
+                <a:solidFill>
+                  <a:srgbClr val="5C2D91"/>
+                </a:solidFill>
+                <a:latin typeface="Segoe UI Semibold" pitchFamily="34" charset="0"/>
+                <a:ea typeface="Segoe UI Semibold" pitchFamily="34" charset="-122"/>
+                <a:cs typeface="Segoe UI Semibold" pitchFamily="34" charset="-120"/>
+              </a:rPr>
+              <a:t>MAVEN DEPENDENCIES</a:t>
+            </a:r>
+            <a:endParaRPr lang="en-US" sz="1300" dirty="0"/>
+          </a:p>
+        </p:txBody>
+      </p:sp>
+      <p:sp>
+        <p:nvSpPr>
+          <p:cNvPr id="19" name="Maven artifact"/>
+          <p:cNvSpPr/>
+          <p:nvPr/>
+        </p:nvSpPr>
+        <p:spPr>
+          <a:xfrm>
+            <a:off x="914400" y="4754880"/>
+            <a:ext cx="4494276" cy="594360"/>
+          </a:xfrm>
+          <a:prstGeom prst="rect">
+            <a:avLst/>
+          </a:prstGeom>
+          <a:noFill/>
+          <a:ln/>
+        </p:spPr>
+        <p:txBody>
+          <a:bodyPr wrap="square" lIns="0" tIns="0" rIns="0" bIns="0" rtlCol="0" anchor="t"/>
+          <a:lstStyle/>
+          <a:p>
+            <a:pPr marL="0" indent="0">
+              <a:buNone/>
+            </a:pPr>
+            <a:r>
+              <a:rPr lang="en-US" sz="1600" dirty="0">
+                <a:solidFill>
+                  <a:srgbClr val="242424"/>
+                </a:solidFill>
+                <a:latin typeface="Consolas" pitchFamily="34" charset="0"/>
+                <a:ea typeface="Consolas" pitchFamily="34" charset="-122"/>
+                <a:cs typeface="Consolas" pitchFamily="34" charset="-120"/>
+              </a:rPr>
+              <a:t>com.github:copilot-sdk-java</a:t>
+            </a:r>
+          </a:p>
+          <a:p>
+            <a:pPr marL="0" indent="0">
+              <a:buNone/>
+            </a:pPr>
+            <a:r>
+              <a:rPr lang="en-US" sz="1600" dirty="0">
+                <a:solidFill>
+                  <a:srgbClr val="242424"/>
+                </a:solidFill>
+                <a:latin typeface="Consolas" pitchFamily="34" charset="0"/>
+                <a:ea typeface="Consolas" pitchFamily="34" charset="-122"/>
+                <a:cs typeface="Consolas" pitchFamily="34" charset="-120"/>
+              </a:rPr>
+              <a:t>com.github:copilot-sdk-java-runtime</a:t>
+            </a:r>
+            <a:endParaRPr lang="en-US" sz="1600" dirty="0"/>
+          </a:p>
+        </p:txBody>
+      </p:sp>
+      <p:sp>
+        <p:nvSpPr>
+          <p:cNvPr id="20" name="Works with label"/>
+          <p:cNvSpPr/>
+          <p:nvPr/>
+        </p:nvSpPr>
+        <p:spPr>
+          <a:xfrm>
+            <a:off x="6871716" y="4434840"/>
+            <a:ext cx="4494276" cy="228600"/>
+          </a:xfrm>
+          <a:prstGeom prst="rect">
+            <a:avLst/>
+          </a:prstGeom>
+          <a:noFill/>
+          <a:ln/>
+        </p:spPr>
+        <p:txBody>
+          <a:bodyPr wrap="square" lIns="0" tIns="0" rIns="0" bIns="0" rtlCol="0" anchor="t"/>
+          <a:lstStyle/>
+          <a:p>
+            <a:pPr marL="0" indent="0">
+              <a:buNone/>
+            </a:pPr>
+            <a:r>
+              <a:rPr lang="en-US" sz="1300" kern="0" spc="300" dirty="0">
+                <a:solidFill>
+                  <a:srgbClr val="5C2D91"/>
+                </a:solidFill>
+                <a:latin typeface="Segoe UI Semibold" pitchFamily="34" charset="0"/>
+                <a:ea typeface="Segoe UI Semibold" pitchFamily="34" charset="-122"/>
+                <a:cs typeface="Segoe UI Semibold" pitchFamily="34" charset="-120"/>
+              </a:rPr>
+              <a:t>WORKS WITH</a:t>
+            </a:r>
+            <a:endParaRPr lang="en-US" sz="1300" dirty="0"/>
+          </a:p>
+        </p:txBody>
+      </p:sp>
+      <p:sp>
+        <p:nvSpPr>
+          <p:cNvPr id="21" name="Works with text"/>
+          <p:cNvSpPr/>
+          <p:nvPr/>
+        </p:nvSpPr>
+        <p:spPr>
+          <a:xfrm>
+            <a:off x="6871716" y="4754880"/>
+            <a:ext cx="4494276" cy="594360"/>
+          </a:xfrm>
+          <a:prstGeom prst="rect">
+            <a:avLst/>
+          </a:prstGeom>
+          <a:noFill/>
+          <a:ln/>
+        </p:spPr>
+        <p:txBody>
+          <a:bodyPr wrap="square" lIns="0" tIns="0" rIns="0" bIns="0" rtlCol="0" anchor="t"/>
+          <a:lstStyle/>
+          <a:p>
+            <a:pPr marL="0" indent="0">
+              <a:buNone/>
+            </a:pPr>
+            <a:r>
+              <a:rPr lang="en-US" sz="1600" dirty="0">
                 <a:solidFill>
                   <a:srgbClr val="242424"/>
                 </a:solidFill>
@@ -8969,9 +9183,48 @@
                 <a:ea typeface="Segoe UI" pitchFamily="34" charset="-122"/>
                 <a:cs typeface="Segoe UI" pitchFamily="34" charset="-120"/>
               </a:rPr>
-              <a:t>About how much does one question cost?</a:t>
-            </a:r>
-            <a:endParaRPr lang="en-US" sz="1400" dirty="0"/>
+              <a:t>Your own Foundry model with managed identity: no keys. Or a GitHub Copilot subscription.</a:t>
+            </a:r>
+            <a:endParaRPr lang="en-US" sz="1600" dirty="0"/>
+          </a:p>
+        </p:txBody>
+      </p:sp>
+      <p:sp>
+        <p:nvSpPr>
+          <p:cNvPr id="22" name="Footnote"/>
+          <p:cNvSpPr/>
+          <p:nvPr/>
+        </p:nvSpPr>
+        <p:spPr>
+          <a:xfrm>
+            <a:off x="548640" y="5943600"/>
+            <a:ext cx="11091672" cy="274320"/>
+          </a:xfrm>
+          <a:prstGeom prst="rect">
+            <a:avLst/>
+          </a:prstGeom>
+          <a:noFill/>
+          <a:ln/>
+        </p:spPr>
+        <p:txBody>
+          <a:bodyPr wrap="square" lIns="0" tIns="0" rIns="0" bIns="0" rtlCol="0" anchor="t"/>
+          <a:lstStyle/>
+          <a:p>
+            <a:pPr marL="0" indent="0">
+              <a:buNone/>
+            </a:pPr>
+            <a:r>
+              <a:rPr lang="en-US" sz="1200" dirty="0">
+                <a:solidFill>
+                  <a:srgbClr val="5C5C5C"/>
+                </a:solidFill>
+                <a:latin typeface="Segoe UI" pitchFamily="34" charset="0"/>
+                <a:ea typeface="Segoe UI" pitchFamily="34" charset="-122"/>
+                <a:cs typeface="Segoe UI" pitchFamily="34" charset="-120"/>
+              </a:rPr>
+              <a:t>See it working in the step-3-copilot-sdk folder. The SDK's Java releases are still labeled preview. Learn more at github.com/github/copilot-sdk</a:t>
+            </a:r>
+            <a:endParaRPr lang="en-US" sz="1200" dirty="0"/>
           </a:p>
         </p:txBody>
       </p:sp>
@@ -8985,7 +9238,7 @@
 
 <file path=ppt/slides/slide9.xml><?xml version="1.0" encoding="utf-8"?>
 <p:sld xmlns:a="http://schemas.openxmlformats.org/drawingml/2006/main" xmlns:r="http://schemas.openxmlformats.org/officeDocument/2006/relationships" xmlns:p="http://schemas.openxmlformats.org/presentationml/2006/main">
-  <p:cSld name="Slide 9">
+  <p:cSld name="Copilot SDK question">
     <p:bg>
       <p:bgPr>
         <a:solidFill>
@@ -9035,13 +9288,13 @@
             <a:r>
               <a:rPr lang="en-US" sz="3200" dirty="0">
                 <a:solidFill>
-                  <a:srgbClr val="107C10"/>
+                  <a:srgbClr val="5C2D91"/>
                 </a:solidFill>
                 <a:latin typeface="Segoe UI Semibold" pitchFamily="34" charset="0"/>
                 <a:ea typeface="Segoe UI Semibold" pitchFamily="34" charset="-122"/>
                 <a:cs typeface="Segoe UI Semibold" pitchFamily="34" charset="-120"/>
               </a:rPr>
-              <a:t xml:space="preserve">Step 4   </a:t>
+              <a:t xml:space="preserve">Step 3   </a:t>
             </a:r>
             <a:r>
               <a:rPr lang="en-US" sz="3200" dirty="0">
@@ -9052,54 +9305,15 @@
                 <a:ea typeface="Segoe UI Semibold" pitchFamily="34" charset="-122"/>
                 <a:cs typeface="Segoe UI Semibold" pitchFamily="34" charset="-120"/>
               </a:rPr>
-              <a:t>One question, as a trace</a:t>
+              <a:t>How the Copilot SDK answers a question</a:t>
             </a:r>
             <a:endParaRPr lang="en-US" sz="3200" dirty="0"/>
-          </a:p>
-        </p:txBody>
-      </p:sp>
-      <p:sp>
-        <p:nvSpPr>
-          <p:cNvPr id="3" name="Text 1"/>
-          <p:cNvSpPr/>
-          <p:nvPr/>
-        </p:nvSpPr>
-        <p:spPr>
-          <a:xfrm>
-            <a:off x="548640" y="914400"/>
-            <a:ext cx="11064240" cy="365760"/>
-          </a:xfrm>
-          <a:prstGeom prst="rect">
-            <a:avLst/>
-          </a:prstGeom>
-          <a:noFill/>
-          <a:ln/>
-        </p:spPr>
-        <p:txBody>
-          <a:bodyPr wrap="square" lIns="0" tIns="0" rIns="0" bIns="0" rtlCol="0" anchor="ctr"/>
-          <a:lstStyle/>
-          <a:p>
-            <a:pPr marL="0" indent="0">
-              <a:buNone/>
-            </a:pPr>
-            <a:r>
-              <a:rPr lang="en-US" sz="1600" dirty="0">
-                <a:solidFill>
-                  <a:srgbClr val="5C5C5C"/>
-                </a:solidFill>
-                <a:latin typeface="Segoe UI" pitchFamily="34" charset="0"/>
-                <a:ea typeface="Segoe UI" pitchFamily="34" charset="-122"/>
-                <a:cs typeface="Segoe UI" pitchFamily="34" charset="-120"/>
-              </a:rPr>
-              <a:t>“Is the Summit Waterproof Jacket in stock?” Real data from step 4.</a:t>
-            </a:r>
-            <a:endParaRPr lang="en-US" sz="1600" dirty="0"/>
           </a:p>
         </p:txBody>
       </p:sp>
       <p:pic>
         <p:nvPicPr>
-          <p:cNvPr id="4" name="Image 0" descr="A 3.5-second request with a 1.5-second model call, a 1-millisecond tool call and a 1.9-second model call, using 549 input and 52 output tokens for $0.000081"/>
+          <p:cNvPr id="3" name="Image 0" descr="Ten numbered messages between you, the app, Copilot's agent, the listProducts tool and the model: the app hands the question to Copilot's agent, which calls the model twice and has the SDK run the Java tool once, then hands the answer back"/>
           <p:cNvPicPr>
             <a:picLocks noChangeAspect="1"/>
           </p:cNvPicPr>
@@ -9113,53 +9327,14 @@
         </p:blipFill>
         <p:spPr>
           <a:xfrm>
-            <a:off x="195682" y="1464535"/>
-            <a:ext cx="11731752" cy="3883210"/>
+            <a:off x="598322" y="1051560"/>
+            <a:ext cx="10995355" cy="5349240"/>
           </a:xfrm>
           <a:prstGeom prst="rect">
             <a:avLst/>
           </a:prstGeom>
         </p:spPr>
       </p:pic>
-      <p:sp>
-        <p:nvSpPr>
-          <p:cNvPr id="5" name="Text 2"/>
-          <p:cNvSpPr/>
-          <p:nvPr/>
-        </p:nvSpPr>
-        <p:spPr>
-          <a:xfrm>
-            <a:off x="548640" y="5577840"/>
-            <a:ext cx="11064240" cy="457200"/>
-          </a:xfrm>
-          <a:prstGeom prst="rect">
-            <a:avLst/>
-          </a:prstGeom>
-          <a:noFill/>
-          <a:ln/>
-        </p:spPr>
-        <p:txBody>
-          <a:bodyPr wrap="square" lIns="0" tIns="0" rIns="0" bIns="0" rtlCol="0" anchor="ctr"/>
-          <a:lstStyle/>
-          <a:p>
-            <a:pPr marL="0" indent="0">
-              <a:buNone/>
-            </a:pPr>
-            <a:r>
-              <a:rPr lang="en-US" sz="1800" dirty="0">
-                <a:solidFill>
-                  <a:srgbClr val="242424"/>
-                </a:solidFill>
-                <a:latin typeface="Segoe UI" pitchFamily="34" charset="0"/>
-                <a:ea typeface="Segoe UI" pitchFamily="34" charset="-122"/>
-                <a:cs typeface="Segoe UI" pitchFamily="34" charset="-120"/>
-              </a:rPr>
-              <a:t>Your Java method takes 1 ms. The model is where the time, and the cost, goes.</a:t>
-            </a:r>
-            <a:endParaRPr lang="en-US" sz="1800" dirty="0"/>
-          </a:p>
-        </p:txBody>
-      </p:sp>
     </p:spTree>
   </p:cSld>
   <p:clrMapOvr>

</xml_diff>

<commit_message>
Move slide explanations into the speaker notes
Keep titles, diagrams, short labels and the Read/Find prompts on the
workshop slides, and move explanatory sentences, caveats and footnotes
into the speaker notes. Crop the explanation callouts off the slide
copies of the step diagrams and the cost chart, and shorten the answers
on the check-your-answers slide so each sits beside its question.

Co-authored-by: Copilot <223556219+Copilot@users.noreply.github.com>
</commit_message>
<xml_diff>
--- a/docs/trail-store-workshop.pptx
+++ b/docs/trail-store-workshop.pptx
@@ -5,7 +5,7 @@
     <p:sldMasterId id="2147483648" r:id="rId1"/>
   </p:sldMasterIdLst>
   <p:notesMasterIdLst>
-    <p:notesMasterId r:id="rId14"/>
+    <p:notesMasterId r:id="rId17"/>
   </p:notesMasterIdLst>
   <p:sldIdLst>
     <p:sldId id="256" r:id="rId2"/>
@@ -15,14 +15,14 @@
     <p:sldId id="260" r:id="rId6"/>
     <p:sldId id="261" r:id="rId7"/>
     <p:sldId id="262" r:id="rId8"/>
-    <p:sldId id="268" r:id="rId19"/>
-    <p:sldId id="269" r:id="rId20"/>
-    <p:sldId id="263" r:id="rId9"/>
-    <p:sldId id="264" r:id="rId10"/>
-    <p:sldId id="265" r:id="rId11"/>
-    <p:sldId id="270" r:id="rId21"/>
-    <p:sldId id="266" r:id="rId12"/>
-    <p:sldId id="267" r:id="rId13"/>
+    <p:sldId id="268" r:id="rId9"/>
+    <p:sldId id="269" r:id="rId10"/>
+    <p:sldId id="263" r:id="rId11"/>
+    <p:sldId id="264" r:id="rId12"/>
+    <p:sldId id="265" r:id="rId13"/>
+    <p:sldId id="270" r:id="rId14"/>
+    <p:sldId id="266" r:id="rId15"/>
+    <p:sldId id="267" r:id="rId16"/>
   </p:sldIdLst>
   <p:sldSz cx="12192000" cy="6858000"/>
   <p:notesSz cx="6858000" cy="12192000"/>
@@ -384,7 +384,7 @@
           <a:p>
             <a:r>
               <a:rPr lang="en-US" dirty="0"/>
-              <a:t>The model is the cheap part: a question costs less than a hundredth of a cent. The main fixed cost is the container registry. The model's per-minute limit also caps the worst case.</a:t>
+              <a:t>The app doesn't say where traces go. On Azure, Container Apps tells it, with the standard OTEL_EXPORTER_OTLP_* settings. On your laptop, nothing is sent. The traces keep timings, the model name, token counts and tool names, but not the questions, and not the answers. Time: 8 minutes for step 4, including the next slide.</a:t>
             </a:r>
           </a:p>
         </p:txBody>
@@ -471,7 +471,7 @@
           <a:p>
             <a:r>
               <a:rPr lang="en-US" dirty="0"/>
-              <a:t>Go through the answers together. The details are in docs/workshop.md.</a:t>
+              <a:t>This is a real trace from step 4. Two model calls and one tool call. Your Java method takes 1 ms: the model is where the time, and the cost, goes. Here are the tokens, and here's the cost: less than a hundredth of a cent. The traces keep timings and token counts, not the questions or the answers.</a:t>
             </a:r>
           </a:p>
         </p:txBody>
@@ -558,7 +558,7 @@
           <a:p>
             <a:r>
               <a:rPr lang="en-US" dirty="0"/>
-              <a:t>Run it, ship it, add AI, see inside it. To try it yourself, run azd up in any step folder, and azd down --purge when you're done.</a:t>
+              <a:t>The model is the cheap part: a question costs less than a hundredth of a cent. On average, a question uses about 540 tokens in and 50 tokens out, at $0.10 per million tokens in and $0.50 per million out. That's about 8 cents for 1,000 questions. The apps scale to zero when they're idle, so they cost nothing while nobody uses them. The main fixed cost is the container registry: about $5 a month for each step you deploy. The model's per-minute limit also caps the worst case: it accepts at most 30 requests and 30,000 tokens a minute, so it costs at most about $0.90 an hour. These are Azure retail prices for Sweden Central, checked on 22 October 2026.</a:t>
             </a:r>
           </a:p>
         </p:txBody>
@@ -618,18 +618,6 @@
       </p:grpSpPr>
       <p:sp>
         <p:nvSpPr>
-          <p:cNvPr id="2" name="Slide Image Placeholder 1"/>
-          <p:cNvSpPr>
-            <a:spLocks noGrp="1" noRot="1" noChangeAspect="1"/>
-          </p:cNvSpPr>
-          <p:nvPr>
-            <p:ph type="sldImg"/>
-          </p:nvPr>
-        </p:nvSpPr>
-        <p:spPr/>
-      </p:sp>
-      <p:sp>
-        <p:nvSpPr>
           <p:cNvPr id="3" name="Notes Placeholder 2"/>
           <p:cNvSpPr>
             <a:spLocks noGrp="1"/>
@@ -644,41 +632,12 @@
           <a:lstStyle/>
           <a:p>
             <a:r>
-              <a:rPr lang="en-US" dirty="0"/>
-              <a:t>Two minutes for this slide and the next, and nothing for the room to do. In step 3, Spring AI sends one question to the model, and the model can ask for one Java method. The GitHub Copilot SDK goes further: it runs Copilot's agent inside your own app. You give it a goal, and it plans and calls your Java tools, step by step, until the job is done. You still write the tools as Java methods, with @CopilotTool instead of @Tool. You add two Maven dependencies: copilot-sdk-java, and copilot-sdk-java-runtime, which brings Copilot's agent runtime. It works with your own model in Microsoft Foundry, where the app signs in with its managed identity and needs no keys, as in step 3. It also works with a GitHub Copilot subscription, which needs a GitHub token instead. The bonus folder, step-3-copilot-sdk, builds this same assistant with the SDK: show Assistant.java and its live app if you have time. Copilot's agent can run commands and edit files, so the app switches all of that off and allows only the one tool. Be clear that the SDK's Java releases are still labeled preview, and @CopilotTool is still marked experimental.</a:t>
-            </a:r>
-          </a:p>
-        </p:txBody>
-      </p:sp>
-      <p:sp>
-        <p:nvSpPr>
-          <p:cNvPr id="4" name="Slide Number Placeholder 3"/>
-          <p:cNvSpPr>
-            <a:spLocks noGrp="1"/>
-          </p:cNvSpPr>
-          <p:nvPr>
-            <p:ph type="sldNum" sz="quarter" idx="10"/>
-          </p:nvPr>
-        </p:nvSpPr>
-        <p:spPr/>
-        <p:txBody>
-          <a:bodyPr/>
-          <a:lstStyle/>
-          <a:p>
-            <a:fld id="{F7021451-1387-4CA6-816F-3879F97B5CBC}" type="slidenum">
-              <a:rPr lang="en-US"/>
-              <a:t>8</a:t>
-            </a:fld>
-            <a:endParaRPr lang="en-US"/>
+              <a:t>Here's the whole journey in one picture. Step 1 is free. Once you deploy, the container registry is most of the bill: about $5 a month for each step. Adding AI costs about $1.25 more: a bigger app, plus 71 cents of tokens for 9,000 questions. Step 4's Log Analytics stays in the free 5 GB. The tokens: 9,000 questions at about 540 tokens in and 50 out is 5.3 million tokens, at $0.10 per million in and $0.50 per million out. All prices are Azure retail prices for Sweden Central.</a:t>
+            </a:r>
           </a:p>
         </p:txBody>
       </p:sp>
     </p:spTree>
-    <p:extLst>
-      <p:ext uri="{BB962C8B-B14F-4D97-AF65-F5344CB8AC3E}">
-        <p14:creationId xmlns:p14="http://schemas.microsoft.com/office/powerpoint/2010/main" val="2713590247"/>
-      </p:ext>
-    </p:extLst>
   </p:cSld>
   <p:clrMapOvr>
     <a:masterClrMapping/>
@@ -732,7 +691,31 @@
           <a:p>
             <a:r>
               <a:rPr lang="en-US" dirty="0"/>
-              <a:t>Follow the numbers. It's the same question as before, with the same two model calls and one tool call. What's new is Copilot's agent, which runs next to the app, in the same container. The app opens a session and hands the agent the question. From there, the agent does what Spring AI did: it calls the model, and when the model asks for list_products, the SDK runs our Java method. Then the agent calls the model again and hands back the answer, and the app deletes the session, so no questions stay on disk. The agent may call that one tool and nothing else: Copilot's tools for files and commands are switched off.</a:t>
+              <a:t>Go through the answers together. The details are in docs/workshop.md.</a:t>
+            </a:r>
+          </a:p>
+          <a:p>
+            <a:r>
+              <a:rPr lang="en-US" dirty="0"/>
+              <a:t>Step 1: there are six products, and the Summit Waterproof Jacket has 0 in stock in Catalog.java.</a:t>
+            </a:r>
+          </a:p>
+          <a:p>
+            <a:r>
+              <a:rPr lang="en-US" dirty="0"/>
+              <a:t>Step 2: minReplicas: 0 in app.bicep lets the app scale to zero. The app pulls its image with its managed identity, which has the AcrPull role on the registry.</a:t>
+            </a:r>
+          </a:p>
+          <a:p>
+            <a:r>
+              <a:rPr lang="en-US" dirty="0"/>
+              <a:t>Step 3: the app's managed identity has the Foundry User role. There's no API key: disableLocalAuth: true switches keys off.</a:t>
+            </a:r>
+          </a:p>
+          <a:p>
+            <a:r>
+              <a:rPr lang="en-US" dirty="0"/>
+              <a:t>Step 4: two model calls. In the first, the model asks for listProducts. In the second, it writes the answer from the tool's result. Off-topic questions, like the poem, usually need only one. A question costs about $0.00008, or about 8 cents for 1,000 questions.</a:t>
             </a:r>
           </a:p>
         </p:txBody>
@@ -754,7 +737,7 @@
           <a:p>
             <a:fld id="{F7021451-1387-4CA6-816F-3879F97B5CBC}" type="slidenum">
               <a:rPr lang="en-US"/>
-              <a:t>9</a:t>
+              <a:t>14</a:t>
             </a:fld>
             <a:endParaRPr lang="en-US"/>
           </a:p>
@@ -774,7 +757,7 @@
 </file>
 
 <file path=ppt/notesSlides/notesSlide15.xml><?xml version="1.0" encoding="utf-8"?>
-<p:notes xmlns:a="http://schemas.openxmlformats.org/drawingml/2006/main" xmlns:p="http://schemas.openxmlformats.org/presentationml/2006/main" xmlns:r="http://schemas.openxmlformats.org/officeDocument/2006/relationships">
+<p:notes xmlns:a="http://schemas.openxmlformats.org/drawingml/2006/main" xmlns:r="http://schemas.openxmlformats.org/officeDocument/2006/relationships" xmlns:p="http://schemas.openxmlformats.org/presentationml/2006/main">
   <p:cSld>
     <p:spTree>
       <p:nvGrpSpPr>
@@ -792,6 +775,18 @@
       </p:grpSpPr>
       <p:sp>
         <p:nvSpPr>
+          <p:cNvPr id="2" name="Slide Image Placeholder 1"/>
+          <p:cNvSpPr>
+            <a:spLocks noGrp="1" noRot="1" noChangeAspect="1"/>
+          </p:cNvSpPr>
+          <p:nvPr>
+            <p:ph type="sldImg"/>
+          </p:nvPr>
+        </p:nvSpPr>
+        <p:spPr/>
+      </p:sp>
+      <p:sp>
+        <p:nvSpPr>
           <p:cNvPr id="3" name="Notes Placeholder 2"/>
           <p:cNvSpPr>
             <a:spLocks noGrp="1"/>
@@ -806,12 +801,41 @@
           <a:lstStyle/>
           <a:p>
             <a:r>
-              <a:t>Here's the whole journey in one picture. Step 1 is free. Once you deploy, the container registry is most of the bill: about $5 a month for each step. Adding AI costs about $1.25 more: a bigger app, plus 71 cents of tokens for 9,000 questions. Step 4's Log Analytics stays in the free 5 GB.</a:t>
-            </a:r>
+              <a:rPr lang="en-US" dirty="0"/>
+              <a:t>Run it, ship it, add AI, see inside it. To try it yourself, run azd up in any step folder, and azd down --purge when you're done. The code, the diagrams and these slides are all in the repo.</a:t>
+            </a:r>
+          </a:p>
+        </p:txBody>
+      </p:sp>
+      <p:sp>
+        <p:nvSpPr>
+          <p:cNvPr id="4" name="Slide Number Placeholder 3"/>
+          <p:cNvSpPr>
+            <a:spLocks noGrp="1"/>
+          </p:cNvSpPr>
+          <p:nvPr>
+            <p:ph type="sldNum" sz="quarter" idx="10"/>
+          </p:nvPr>
+        </p:nvSpPr>
+        <p:spPr/>
+        <p:txBody>
+          <a:bodyPr/>
+          <a:lstStyle/>
+          <a:p>
+            <a:fld id="{F7021451-1387-4CA6-816F-3879F97B5CBC}" type="slidenum">
+              <a:rPr lang="en-US"/>
+              <a:t>15</a:t>
+            </a:fld>
+            <a:endParaRPr lang="en-US"/>
           </a:p>
         </p:txBody>
       </p:sp>
     </p:spTree>
+    <p:extLst>
+      <p:ext uri="{BB962C8B-B14F-4D97-AF65-F5344CB8AC3E}">
+        <p14:creationId xmlns:p14="http://schemas.microsoft.com/office/powerpoint/2010/main" val="1024086991"/>
+      </p:ext>
+    </p:extLst>
   </p:cSld>
   <p:clrMapOvr>
     <a:masterClrMapping/>
@@ -1213,7 +1237,7 @@
           <a:p>
             <a:r>
               <a:rPr lang="en-US" dirty="0"/>
-              <a:t>Follow the numbers: two calls to the model, and one call to our own Java code in between. The model can't see our catalog, so we give it a tool: one method with @Tool. There are no API keys: they're switched off in Foundry, and the app signs in with its managed identity. Time: 12 minutes for step 3, including the next three slides.</a:t>
+              <a:t>Follow the numbers: two calls to the model, and one call to our own Java code in between. The model can't see our catalog, so we give it a tool: one method with @Tool. There are no API keys: they're switched off in Foundry, and the app signs in with its managed identity. Guardrails keep the cost down: 300 characters in, 300 tokens out, and at most 30 requests a minute. Time: 12 minutes for step 3, including the next three slides.</a:t>
             </a:r>
           </a:p>
         </p:txBody>
@@ -1300,7 +1324,7 @@
           <a:p>
             <a:r>
               <a:rPr lang="en-US" dirty="0"/>
-              <a:t>Everyone: find the two files and answer the questions, then ask the store one question. The Summit jacket is out of stock, and the assistant says so, then suggests jackets that are in stock: real facts, not guesses. The poem question shows it stays on topic.</a:t>
+              <a:t>Everyone: find the two files and answer the questions, then ask the store one question. The Summit jacket is out of stock, and the assistant says so, then suggests jackets that are in stock: real facts, not guesses. The poem question shows it stays on topic. The whole room shares one model. If someone sees "could not answer right now", ask them to wait a few seconds and try again.</a:t>
             </a:r>
           </a:p>
         </p:txBody>
@@ -1387,7 +1411,7 @@
           <a:p>
             <a:r>
               <a:rPr lang="en-US" dirty="0"/>
-              <a:t>Container Apps tells the app where to send traces. Time: 8 minutes for step 4, including the next slide.</a:t>
+              <a:t>Two minutes for this slide and the next, and nothing for the room to do. In step 3, Spring AI sends one question to the model, and the model can ask for one Java method. The GitHub Copilot SDK goes further: it runs Copilot's agent inside your own app. You give it a goal, and it plans and calls your Java tools, step by step, until the job is done. You still write the tools as Java methods, with @CopilotTool instead of @Tool. You add two Maven dependencies: copilot-sdk-java, and copilot-sdk-java-runtime, which brings Copilot's agent runtime. It works with your own model in Microsoft Foundry, where the app signs in with its managed identity and needs no keys, as in step 3. It also works with a GitHub Copilot subscription, which needs a GitHub token instead. The bonus folder, step-3-copilot-sdk, builds this same assistant with the SDK: show Assistant.java and its live app if you have time. Copilot's agent can run commands and edit files, so the app switches all of that off and allows only the one tool. Be clear that the SDK's Java releases are still labeled preview, and @CopilotTool is still marked experimental.</a:t>
             </a:r>
           </a:p>
         </p:txBody>
@@ -1418,7 +1442,7 @@
     </p:spTree>
     <p:extLst>
       <p:ext uri="{BB962C8B-B14F-4D97-AF65-F5344CB8AC3E}">
-        <p14:creationId xmlns:p14="http://schemas.microsoft.com/office/powerpoint/2010/main" val="1024086991"/>
+        <p14:creationId xmlns:p14="http://schemas.microsoft.com/office/powerpoint/2010/main" val="2713590247"/>
       </p:ext>
     </p:extLst>
   </p:cSld>
@@ -1474,7 +1498,7 @@
           <a:p>
             <a:r>
               <a:rPr lang="en-US" dirty="0"/>
-              <a:t>This is a real trace from step 4. Two model calls and one tool call. Here are the tokens, and here's the cost: less than a hundredth of a cent. The traces keep timings and token counts, not the questions or the answers.</a:t>
+              <a:t>Follow the numbers. It's the same question as before, with the same two model calls and one tool call. What's new is Copilot's agent, which runs next to the app, in the same container. For each question, the app opens a new session and hands the question to the agent. From there, the agent does what Spring AI did: it calls the model, and when the model asks for list_products, the SDK runs our Java method. Then the agent calls the model again and hands back the answer, and the app deletes the session, so no questions stay on disk. The agent may call that one tool and nothing else: Copilot's tools for files and commands are switched off.</a:t>
             </a:r>
           </a:p>
         </p:txBody>
@@ -2237,14 +2261,15 @@
         </p:nvPicPr>
         <p:blipFill>
           <a:blip r:embed="rId3"/>
+          <a:srcRect l="2050" t="327" r="2100" b="40033"/>
           <a:stretch>
             <a:fillRect/>
           </a:stretch>
         </p:blipFill>
         <p:spPr>
           <a:xfrm>
-            <a:off x="365760" y="1401693"/>
-            <a:ext cx="11457432" cy="3505974"/>
+            <a:off x="454543" y="2055587"/>
+            <a:ext cx="11273985" cy="2146586"/>
           </a:xfrm>
           <a:prstGeom prst="rect">
             <a:avLst/>
@@ -2611,7 +2636,7 @@
                 <a:ea typeface="Segoe UI" pitchFamily="34" charset="-122"/>
                 <a:cs typeface="Segoe UI" pitchFamily="34" charset="-120"/>
               </a:rPr>
-              <a:t>“Is the Summit Waterproof Jacket in stock?” Real data from step 4.</a:t>
+              <a:t>“Is the Summit Waterproof Jacket in stock?”</a:t>
             </a:r>
             <a:endParaRPr lang="en-US" sz="1600" dirty="0"/>
           </a:p>
@@ -2627,59 +2652,21 @@
         </p:nvPicPr>
         <p:blipFill>
           <a:blip r:embed="rId3"/>
+          <a:srcRect l="2100" t="755" r="1500" b="6495"/>
           <a:stretch>
             <a:fillRect/>
           </a:stretch>
         </p:blipFill>
         <p:spPr>
           <a:xfrm>
-            <a:off x="195682" y="1464535"/>
-            <a:ext cx="11731752" cy="3883210"/>
+            <a:off x="455089" y="2042542"/>
+            <a:ext cx="11272928" cy="3590030"/>
           </a:xfrm>
           <a:prstGeom prst="rect">
             <a:avLst/>
           </a:prstGeom>
         </p:spPr>
       </p:pic>
-      <p:sp>
-        <p:nvSpPr>
-          <p:cNvPr id="5" name="Text 2"/>
-          <p:cNvSpPr/>
-          <p:nvPr/>
-        </p:nvSpPr>
-        <p:spPr>
-          <a:xfrm>
-            <a:off x="548640" y="5577840"/>
-            <a:ext cx="11064240" cy="457200"/>
-          </a:xfrm>
-          <a:prstGeom prst="rect">
-            <a:avLst/>
-          </a:prstGeom>
-          <a:noFill/>
-          <a:ln/>
-        </p:spPr>
-        <p:txBody>
-          <a:bodyPr wrap="square" lIns="0" tIns="0" rIns="0" bIns="0" rtlCol="0" anchor="ctr"/>
-          <a:lstStyle/>
-          <a:p>
-            <a:pPr marL="0" indent="0">
-              <a:buNone/>
-            </a:pPr>
-            <a:r>
-              <a:rPr lang="en-US" sz="1800" dirty="0">
-                <a:solidFill>
-                  <a:srgbClr val="242424"/>
-                </a:solidFill>
-                <a:latin typeface="Segoe UI" pitchFamily="34" charset="0"/>
-                <a:ea typeface="Segoe UI" pitchFamily="34" charset="-122"/>
-                <a:cs typeface="Segoe UI" pitchFamily="34" charset="-120"/>
-              </a:rPr>
-              <a:t>Your Java method takes 1 ms. The model is where the time, and the cost, goes.</a:t>
-            </a:r>
-            <a:endParaRPr lang="en-US" sz="1800" dirty="0"/>
-          </a:p>
-        </p:txBody>
-      </p:sp>
     </p:spTree>
   </p:cSld>
   <p:clrMapOvr>
@@ -2831,7 +2818,7 @@
         </p:nvSpPr>
         <p:spPr>
           <a:xfrm>
-            <a:off x="914400" y="1490472"/>
+            <a:off x="914400" y="1728216"/>
             <a:ext cx="4846320" cy="868680"/>
           </a:xfrm>
           <a:prstGeom prst="rect">
@@ -2870,7 +2857,7 @@
         </p:nvSpPr>
         <p:spPr>
           <a:xfrm>
-            <a:off x="914400" y="2377440"/>
+            <a:off x="914400" y="2596896"/>
             <a:ext cx="4846320" cy="384048"/>
           </a:xfrm>
           <a:prstGeom prst="rect">
@@ -2898,45 +2885,6 @@
               <a:t>per question</a:t>
             </a:r>
             <a:endParaRPr lang="en-US" sz="1800" dirty="0"/>
-          </a:p>
-        </p:txBody>
-      </p:sp>
-      <p:sp>
-        <p:nvSpPr>
-          <p:cNvPr id="7" name="Text 5"/>
-          <p:cNvSpPr/>
-          <p:nvPr/>
-        </p:nvSpPr>
-        <p:spPr>
-          <a:xfrm>
-            <a:off x="914400" y="2761488"/>
-            <a:ext cx="4846320" cy="457200"/>
-          </a:xfrm>
-          <a:prstGeom prst="rect">
-            <a:avLst/>
-          </a:prstGeom>
-          <a:noFill/>
-          <a:ln/>
-        </p:spPr>
-        <p:txBody>
-          <a:bodyPr wrap="square" lIns="0" tIns="0" rIns="0" bIns="0" rtlCol="0" anchor="t"/>
-          <a:lstStyle/>
-          <a:p>
-            <a:pPr marL="0" indent="0">
-              <a:buNone/>
-            </a:pPr>
-            <a:r>
-              <a:rPr lang="en-US" sz="1400" dirty="0">
-                <a:solidFill>
-                  <a:srgbClr val="5C5C5C"/>
-                </a:solidFill>
-                <a:latin typeface="Segoe UI" pitchFamily="34" charset="0"/>
-                <a:ea typeface="Segoe UI" pitchFamily="34" charset="-122"/>
-                <a:cs typeface="Segoe UI" pitchFamily="34" charset="-120"/>
-              </a:rPr>
-              <a:t>About 540 tokens in and 50 tokens out, on average</a:t>
-            </a:r>
-            <a:endParaRPr lang="en-US" sz="1400" dirty="0"/>
           </a:p>
         </p:txBody>
       </p:sp>
@@ -3019,7 +2967,7 @@
         </p:nvSpPr>
         <p:spPr>
           <a:xfrm>
-            <a:off x="6611112" y="1490472"/>
+            <a:off x="6611112" y="1728216"/>
             <a:ext cx="4846320" cy="868680"/>
           </a:xfrm>
           <a:prstGeom prst="rect">
@@ -3058,7 +3006,7 @@
         </p:nvSpPr>
         <p:spPr>
           <a:xfrm>
-            <a:off x="6611112" y="2377440"/>
+            <a:off x="6611112" y="2596896"/>
             <a:ext cx="4846320" cy="384048"/>
           </a:xfrm>
           <a:prstGeom prst="rect">
@@ -3086,45 +3034,6 @@
               <a:t>per 1,000 questions</a:t>
             </a:r>
             <a:endParaRPr lang="en-US" sz="1800" dirty="0"/>
-          </a:p>
-        </p:txBody>
-      </p:sp>
-      <p:sp>
-        <p:nvSpPr>
-          <p:cNvPr id="12" name="Text 10"/>
-          <p:cNvSpPr/>
-          <p:nvPr/>
-        </p:nvSpPr>
-        <p:spPr>
-          <a:xfrm>
-            <a:off x="6611112" y="2761488"/>
-            <a:ext cx="4846320" cy="457200"/>
-          </a:xfrm>
-          <a:prstGeom prst="rect">
-            <a:avLst/>
-          </a:prstGeom>
-          <a:noFill/>
-          <a:ln/>
-        </p:spPr>
-        <p:txBody>
-          <a:bodyPr wrap="square" lIns="0" tIns="0" rIns="0" bIns="0" rtlCol="0" anchor="t"/>
-          <a:lstStyle/>
-          <a:p>
-            <a:pPr marL="0" indent="0">
-              <a:buNone/>
-            </a:pPr>
-            <a:r>
-              <a:rPr lang="en-US" sz="1400" dirty="0">
-                <a:solidFill>
-                  <a:srgbClr val="5C5C5C"/>
-                </a:solidFill>
-                <a:latin typeface="Segoe UI" pitchFamily="34" charset="0"/>
-                <a:ea typeface="Segoe UI" pitchFamily="34" charset="-122"/>
-                <a:cs typeface="Segoe UI" pitchFamily="34" charset="-120"/>
-              </a:rPr>
-              <a:t>At $0.10 per 1M tokens in and $0.50 per 1M tokens out</a:t>
-            </a:r>
-            <a:endParaRPr lang="en-US" sz="1400" dirty="0"/>
           </a:p>
         </p:txBody>
       </p:sp>
@@ -3207,7 +3116,7 @@
         </p:nvSpPr>
         <p:spPr>
           <a:xfrm>
-            <a:off x="914400" y="3822192"/>
+            <a:off x="914400" y="4059936"/>
             <a:ext cx="4846320" cy="868680"/>
           </a:xfrm>
           <a:prstGeom prst="rect">
@@ -3246,7 +3155,7 @@
         </p:nvSpPr>
         <p:spPr>
           <a:xfrm>
-            <a:off x="914400" y="4709160"/>
+            <a:off x="914400" y="4928616"/>
             <a:ext cx="4846320" cy="384048"/>
           </a:xfrm>
           <a:prstGeom prst="rect">
@@ -3274,45 +3183,6 @@
               <a:t>while nobody uses it</a:t>
             </a:r>
             <a:endParaRPr lang="en-US" sz="1800" dirty="0"/>
-          </a:p>
-        </p:txBody>
-      </p:sp>
-      <p:sp>
-        <p:nvSpPr>
-          <p:cNvPr id="17" name="Text 15"/>
-          <p:cNvSpPr/>
-          <p:nvPr/>
-        </p:nvSpPr>
-        <p:spPr>
-          <a:xfrm>
-            <a:off x="914400" y="5093208"/>
-            <a:ext cx="4846320" cy="457200"/>
-          </a:xfrm>
-          <a:prstGeom prst="rect">
-            <a:avLst/>
-          </a:prstGeom>
-          <a:noFill/>
-          <a:ln/>
-        </p:spPr>
-        <p:txBody>
-          <a:bodyPr wrap="square" lIns="0" tIns="0" rIns="0" bIns="0" rtlCol="0" anchor="t"/>
-          <a:lstStyle/>
-          <a:p>
-            <a:pPr marL="0" indent="0">
-              <a:buNone/>
-            </a:pPr>
-            <a:r>
-              <a:rPr lang="en-US" sz="1400" dirty="0">
-                <a:solidFill>
-                  <a:srgbClr val="5C5C5C"/>
-                </a:solidFill>
-                <a:latin typeface="Segoe UI" pitchFamily="34" charset="0"/>
-                <a:ea typeface="Segoe UI" pitchFamily="34" charset="-122"/>
-                <a:cs typeface="Segoe UI" pitchFamily="34" charset="-120"/>
-              </a:rPr>
-              <a:t>The apps scale to zero when they're idle</a:t>
-            </a:r>
-            <a:endParaRPr lang="en-US" sz="1400" dirty="0"/>
           </a:p>
         </p:txBody>
       </p:sp>
@@ -3395,7 +3265,7 @@
         </p:nvSpPr>
         <p:spPr>
           <a:xfrm>
-            <a:off x="6611112" y="3822192"/>
+            <a:off x="6611112" y="4059936"/>
             <a:ext cx="4846320" cy="868680"/>
           </a:xfrm>
           <a:prstGeom prst="rect">
@@ -3434,7 +3304,7 @@
         </p:nvSpPr>
         <p:spPr>
           <a:xfrm>
-            <a:off x="6611112" y="4709160"/>
+            <a:off x="6611112" y="4928616"/>
             <a:ext cx="4846320" cy="384048"/>
           </a:xfrm>
           <a:prstGeom prst="rect">
@@ -3462,101 +3332,6 @@
               <a:t>a month per container registry</a:t>
             </a:r>
             <a:endParaRPr lang="en-US" sz="1800" dirty="0"/>
-          </a:p>
-        </p:txBody>
-      </p:sp>
-      <p:sp>
-        <p:nvSpPr>
-          <p:cNvPr id="22" name="Text 20"/>
-          <p:cNvSpPr/>
-          <p:nvPr/>
-        </p:nvSpPr>
-        <p:spPr>
-          <a:xfrm>
-            <a:off x="6611112" y="5093208"/>
-            <a:ext cx="4846320" cy="457200"/>
-          </a:xfrm>
-          <a:prstGeom prst="rect">
-            <a:avLst/>
-          </a:prstGeom>
-          <a:noFill/>
-          <a:ln/>
-        </p:spPr>
-        <p:txBody>
-          <a:bodyPr wrap="square" lIns="0" tIns="0" rIns="0" bIns="0" rtlCol="0" anchor="t"/>
-          <a:lstStyle/>
-          <a:p>
-            <a:pPr marL="0" indent="0">
-              <a:buNone/>
-            </a:pPr>
-            <a:r>
-              <a:rPr lang="en-US" sz="1400" dirty="0">
-                <a:solidFill>
-                  <a:srgbClr val="5C5C5C"/>
-                </a:solidFill>
-                <a:latin typeface="Segoe UI" pitchFamily="34" charset="0"/>
-                <a:ea typeface="Segoe UI" pitchFamily="34" charset="-122"/>
-                <a:cs typeface="Segoe UI" pitchFamily="34" charset="-120"/>
-              </a:rPr>
-              <a:t>The main fixed cost for each step you deploy</a:t>
-            </a:r>
-            <a:endParaRPr lang="en-US" sz="1400" dirty="0"/>
-          </a:p>
-        </p:txBody>
-      </p:sp>
-      <p:sp>
-        <p:nvSpPr>
-          <p:cNvPr id="23" name="Text 21"/>
-          <p:cNvSpPr/>
-          <p:nvPr/>
-        </p:nvSpPr>
-        <p:spPr>
-          <a:xfrm>
-            <a:off x="548640" y="5943600"/>
-            <a:ext cx="11091672" cy="457200"/>
-          </a:xfrm>
-          <a:prstGeom prst="rect">
-            <a:avLst/>
-          </a:prstGeom>
-          <a:noFill/>
-          <a:ln/>
-        </p:spPr>
-        <p:txBody>
-          <a:bodyPr wrap="square" lIns="0" tIns="0" rIns="0" bIns="0" rtlCol="0" anchor="t"/>
-          <a:lstStyle/>
-          <a:p>
-            <a:pPr marL="0" indent="0">
-              <a:buNone/>
-            </a:pPr>
-            <a:r>
-              <a:rPr lang="en-US" sz="1200" dirty="0">
-                <a:solidFill>
-                  <a:srgbClr val="5C5C5C"/>
-                </a:solidFill>
-                <a:latin typeface="Segoe UI" pitchFamily="34" charset="0"/>
-                <a:ea typeface="Segoe UI" pitchFamily="34" charset="-122"/>
-                <a:cs typeface="Segoe UI" pitchFamily="34" charset="-120"/>
-              </a:rPr>
-              <a:t>Azure retail prices for Sweden Central, checked on 22 October 2026.</a:t>
-            </a:r>
-            <a:endParaRPr lang="en-US" sz="1200" dirty="0"/>
-          </a:p>
-          <a:p>
-            <a:pPr marL="0" indent="0">
-              <a:buNone/>
-            </a:pPr>
-            <a:r>
-              <a:rPr lang="en-US" sz="1200" dirty="0">
-                <a:solidFill>
-                  <a:srgbClr val="5C5C5C"/>
-                </a:solidFill>
-                <a:latin typeface="Segoe UI" pitchFamily="34" charset="0"/>
-                <a:ea typeface="Segoe UI" pitchFamily="34" charset="-122"/>
-                <a:cs typeface="Segoe UI" pitchFamily="34" charset="-120"/>
-              </a:rPr>
-              <a:t>The model accepts at most 30 requests and 30,000 tokens a minute, so it costs at most about $0.90 an hour.</a:t>
-            </a:r>
-            <a:endParaRPr lang="en-US" sz="1200" dirty="0"/>
           </a:p>
         </p:txBody>
       </p:sp>
@@ -3569,7 +3344,7 @@
 </file>
 
 <file path=ppt/slides/slide13.xml><?xml version="1.0" encoding="utf-8"?>
-<p:sld xmlns:a="http://schemas.openxmlformats.org/drawingml/2006/main" xmlns:p="http://schemas.openxmlformats.org/presentationml/2006/main" xmlns:r="http://schemas.openxmlformats.org/officeDocument/2006/relationships">
+<p:sld xmlns:a="http://schemas.openxmlformats.org/drawingml/2006/main" xmlns:r="http://schemas.openxmlformats.org/officeDocument/2006/relationships" xmlns:p="http://schemas.openxmlformats.org/presentationml/2006/main">
   <p:cSld>
     <p:bg>
       <p:bgPr>
@@ -3585,7 +3360,14 @@
         <p:cNvGrpSpPr/>
         <p:nvPr/>
       </p:nvGrpSpPr>
-      <p:grpSpPr/>
+      <p:grpSpPr>
+        <a:xfrm>
+          <a:off x="0" y="0"/>
+          <a:ext cx="0" cy="0"/>
+          <a:chOff x="0" y="0"/>
+          <a:chExt cx="0" cy="0"/>
+        </a:xfrm>
+      </p:grpSpPr>
       <p:sp>
         <p:nvSpPr>
           <p:cNvPr id="2" name="Text 0"/>
@@ -3673,15 +3455,16 @@
           <p:nvPr/>
         </p:nvPicPr>
         <p:blipFill>
-          <a:blip r:embed="rId2"/>
+          <a:blip r:embed="rId3"/>
+          <a:srcRect l="2755" t="5535" r="1818" b="7673"/>
           <a:stretch>
             <a:fillRect/>
           </a:stretch>
         </p:blipFill>
         <p:spPr>
           <a:xfrm>
-            <a:off x="548640" y="1417320"/>
-            <a:ext cx="11064240" cy="4846320"/>
+            <a:off x="444309" y="1679026"/>
+            <a:ext cx="11293813" cy="4499267"/>
           </a:xfrm>
           <a:prstGeom prst="rect">
             <a:avLst/>
@@ -3892,6 +3675,9 @@
           <a:lstStyle/>
           <a:p>
             <a:pPr marL="0" indent="0">
+              <a:lnSpc>
+                <a:spcPts val="1800"/>
+              </a:lnSpc>
               <a:buNone/>
             </a:pPr>
             <a:r>
@@ -3909,6 +3695,9 @@
           </a:p>
           <a:p>
             <a:pPr marL="0" indent="0">
+              <a:lnSpc>
+                <a:spcPts val="1800"/>
+              </a:lnSpc>
               <a:buNone/>
             </a:pPr>
             <a:r>
@@ -3948,6 +3737,9 @@
           <a:lstStyle/>
           <a:p>
             <a:pPr marL="0" indent="0">
+              <a:lnSpc>
+                <a:spcPts val="1800"/>
+              </a:lnSpc>
               <a:buNone/>
             </a:pPr>
             <a:r>
@@ -3959,7 +3751,26 @@
                 <a:ea typeface="Segoe UI" pitchFamily="34" charset="-122"/>
                 <a:cs typeface="Segoe UI" pitchFamily="34" charset="-120"/>
               </a:rPr>
-              <a:t>Six. The Summit Waterproof Jacket has 0 in stock.</a:t>
+              <a:t>Six</a:t>
+            </a:r>
+          </a:p>
+          <a:p>
+            <a:pPr marL="0" indent="0">
+              <a:lnSpc>
+                <a:spcPts val="1800"/>
+              </a:lnSpc>
+              <a:buNone/>
+            </a:pPr>
+            <a:r>
+              <a:rPr lang="en-US" sz="1500" dirty="0">
+                <a:solidFill>
+                  <a:srgbClr val="242424"/>
+                </a:solidFill>
+                <a:latin typeface="Segoe UI" pitchFamily="34" charset="0"/>
+                <a:ea typeface="Segoe UI" pitchFamily="34" charset="-122"/>
+                <a:cs typeface="Segoe UI" pitchFamily="34" charset="-120"/>
+              </a:rPr>
+              <a:t>The Summit Waterproof Jacket</a:t>
             </a:r>
             <a:endParaRPr lang="en-US" sz="1500" dirty="0"/>
           </a:p>
@@ -4097,6 +3908,9 @@
           <a:lstStyle/>
           <a:p>
             <a:pPr marL="0" indent="0">
+              <a:lnSpc>
+                <a:spcPts val="1800"/>
+              </a:lnSpc>
               <a:buNone/>
             </a:pPr>
             <a:r>
@@ -4114,6 +3928,9 @@
           </a:p>
           <a:p>
             <a:pPr marL="0" indent="0">
+              <a:lnSpc>
+                <a:spcPts val="1800"/>
+              </a:lnSpc>
               <a:buNone/>
             </a:pPr>
             <a:r>
@@ -4153,6 +3970,9 @@
           <a:lstStyle/>
           <a:p>
             <a:pPr marL="0" indent="0">
+              <a:lnSpc>
+                <a:spcPts val="1800"/>
+              </a:lnSpc>
               <a:buNone/>
             </a:pPr>
             <a:r>
@@ -4166,6 +3986,14 @@
               </a:rPr>
               <a:t>minReplicas: 0</a:t>
             </a:r>
+          </a:p>
+          <a:p>
+            <a:pPr marL="0" indent="0">
+              <a:lnSpc>
+                <a:spcPts val="1800"/>
+              </a:lnSpc>
+              <a:buNone/>
+            </a:pPr>
             <a:r>
               <a:rPr lang="en-US" sz="1500" dirty="0">
                 <a:solidFill>
@@ -4175,7 +4003,7 @@
                 <a:ea typeface="Segoe UI" pitchFamily="34" charset="-122"/>
                 <a:cs typeface="Segoe UI" pitchFamily="34" charset="-120"/>
               </a:rPr>
-              <a:t>. The managed identity has the AcrPull role.</a:t>
+              <a:t>Managed identity with the AcrPull role</a:t>
             </a:r>
             <a:endParaRPr lang="en-US" sz="1500" dirty="0"/>
           </a:p>
@@ -4313,6 +4141,9 @@
           <a:lstStyle/>
           <a:p>
             <a:pPr marL="0" indent="0">
+              <a:lnSpc>
+                <a:spcPts val="1800"/>
+              </a:lnSpc>
               <a:buNone/>
             </a:pPr>
             <a:r>
@@ -4330,6 +4161,9 @@
           </a:p>
           <a:p>
             <a:pPr marL="0" indent="0">
+              <a:lnSpc>
+                <a:spcPts val="1800"/>
+              </a:lnSpc>
               <a:buNone/>
             </a:pPr>
             <a:r>
@@ -4369,6 +4203,9 @@
           <a:lstStyle/>
           <a:p>
             <a:pPr marL="0" indent="0">
+              <a:lnSpc>
+                <a:spcPts val="1800"/>
+              </a:lnSpc>
               <a:buNone/>
             </a:pPr>
             <a:r>
@@ -4380,7 +4217,26 @@
                 <a:ea typeface="Segoe UI" pitchFamily="34" charset="-122"/>
                 <a:cs typeface="Segoe UI" pitchFamily="34" charset="-120"/>
               </a:rPr>
-              <a:t xml:space="preserve">The managed identity has the Foundry User role. Keys are off: </a:t>
+              <a:t>Managed identity with the Foundry User role</a:t>
+            </a:r>
+          </a:p>
+          <a:p>
+            <a:pPr marL="0" indent="0">
+              <a:lnSpc>
+                <a:spcPts val="1800"/>
+              </a:lnSpc>
+              <a:buNone/>
+            </a:pPr>
+            <a:r>
+              <a:rPr lang="en-US" sz="1500" dirty="0">
+                <a:solidFill>
+                  <a:srgbClr val="242424"/>
+                </a:solidFill>
+                <a:latin typeface="Segoe UI" pitchFamily="34" charset="0"/>
+                <a:ea typeface="Segoe UI" pitchFamily="34" charset="-122"/>
+                <a:cs typeface="Segoe UI" pitchFamily="34" charset="-120"/>
+              </a:rPr>
+              <a:t xml:space="preserve">No: </a:t>
             </a:r>
             <a:r>
               <a:rPr lang="en-US" sz="1500" dirty="0">
@@ -4392,17 +4248,6 @@
                 <a:cs typeface="Consolas" pitchFamily="34" charset="-120"/>
               </a:rPr>
               <a:t>disableLocalAuth: true</a:t>
-            </a:r>
-            <a:r>
-              <a:rPr lang="en-US" sz="1500" dirty="0">
-                <a:solidFill>
-                  <a:srgbClr val="242424"/>
-                </a:solidFill>
-                <a:latin typeface="Segoe UI" pitchFamily="34" charset="0"/>
-                <a:ea typeface="Segoe UI" pitchFamily="34" charset="-122"/>
-                <a:cs typeface="Segoe UI" pitchFamily="34" charset="-120"/>
-              </a:rPr>
-              <a:t>.</a:t>
             </a:r>
             <a:endParaRPr lang="en-US" sz="1500" dirty="0"/>
           </a:p>
@@ -4540,6 +4385,9 @@
           <a:lstStyle/>
           <a:p>
             <a:pPr marL="0" indent="0">
+              <a:lnSpc>
+                <a:spcPts val="1800"/>
+              </a:lnSpc>
               <a:buNone/>
             </a:pPr>
             <a:r>
@@ -4557,6 +4405,9 @@
           </a:p>
           <a:p>
             <a:pPr marL="0" indent="0">
+              <a:lnSpc>
+                <a:spcPts val="1800"/>
+              </a:lnSpc>
               <a:buNone/>
             </a:pPr>
             <a:r>
@@ -4596,6 +4447,9 @@
           <a:lstStyle/>
           <a:p>
             <a:pPr marL="0" indent="0">
+              <a:lnSpc>
+                <a:spcPts val="1800"/>
+              </a:lnSpc>
               <a:buNone/>
             </a:pPr>
             <a:r>
@@ -4607,19 +4461,16 @@
                 <a:ea typeface="Segoe UI" pitchFamily="34" charset="-122"/>
                 <a:cs typeface="Segoe UI" pitchFamily="34" charset="-120"/>
               </a:rPr>
-              <a:t xml:space="preserve">Two: it asks for </a:t>
-            </a:r>
-            <a:r>
-              <a:rPr lang="en-US" sz="1500" dirty="0">
-                <a:solidFill>
-                  <a:srgbClr val="242424"/>
-                </a:solidFill>
-                <a:latin typeface="Consolas" pitchFamily="34" charset="0"/>
-                <a:ea typeface="Consolas" pitchFamily="34" charset="-122"/>
-                <a:cs typeface="Consolas" pitchFamily="34" charset="-120"/>
-              </a:rPr>
-              <a:t>listProducts</a:t>
-            </a:r>
+              <a:t>Two</a:t>
+            </a:r>
+          </a:p>
+          <a:p>
+            <a:pPr marL="0" indent="0">
+              <a:lnSpc>
+                <a:spcPts val="1800"/>
+              </a:lnSpc>
+              <a:buNone/>
+            </a:pPr>
             <a:r>
               <a:rPr lang="en-US" sz="1500" dirty="0">
                 <a:solidFill>
@@ -4629,7 +4480,7 @@
                 <a:ea typeface="Segoe UI" pitchFamily="34" charset="-122"/>
                 <a:cs typeface="Segoe UI" pitchFamily="34" charset="-120"/>
               </a:rPr>
-              <a:t>, then writes the answer. Off-topic questions usually need one. About $0.00008 each.</a:t>
+              <a:t>About $0.00008</a:t>
             </a:r>
             <a:endParaRPr lang="en-US" sz="1500" dirty="0"/>
           </a:p>
@@ -4952,45 +4803,6 @@
       </p:sp>
       <p:sp>
         <p:nvSpPr>
-          <p:cNvPr id="7" name="Text 5"/>
-          <p:cNvSpPr/>
-          <p:nvPr/>
-        </p:nvSpPr>
-        <p:spPr>
-          <a:xfrm>
-            <a:off x="8503920" y="3566160"/>
-            <a:ext cx="3017520" cy="822960"/>
-          </a:xfrm>
-          <a:prstGeom prst="rect">
-            <a:avLst/>
-          </a:prstGeom>
-          <a:noFill/>
-          <a:ln/>
-        </p:spPr>
-        <p:txBody>
-          <a:bodyPr wrap="square" lIns="0" tIns="0" rIns="0" bIns="0" rtlCol="0" anchor="t"/>
-          <a:lstStyle/>
-          <a:p>
-            <a:pPr marL="0" indent="0">
-              <a:buNone/>
-            </a:pPr>
-            <a:r>
-              <a:rPr lang="en-US" sz="1600" dirty="0">
-                <a:solidFill>
-                  <a:srgbClr val="F7F4EF"/>
-                </a:solidFill>
-                <a:latin typeface="Segoe UI" pitchFamily="34" charset="0"/>
-                <a:ea typeface="Segoe UI" pitchFamily="34" charset="-122"/>
-                <a:cs typeface="Segoe UI" pitchFamily="34" charset="-120"/>
-              </a:rPr>
-              <a:t>The code, diagrams and these slides are all in the repo.</a:t>
-            </a:r>
-            <a:endParaRPr lang="en-US" sz="1600" dirty="0"/>
-          </a:p>
-        </p:txBody>
-      </p:sp>
-      <p:sp>
-        <p:nvSpPr>
           <p:cNvPr id="8" name="Text 6"/>
           <p:cNvSpPr/>
           <p:nvPr/>
@@ -5100,45 +4912,6 @@
           </a:p>
         </p:txBody>
       </p:sp>
-      <p:sp>
-        <p:nvSpPr>
-          <p:cNvPr id="3" name="Text 1"/>
-          <p:cNvSpPr/>
-          <p:nvPr/>
-        </p:nvSpPr>
-        <p:spPr>
-          <a:xfrm>
-            <a:off x="548640" y="914400"/>
-            <a:ext cx="11064240" cy="365760"/>
-          </a:xfrm>
-          <a:prstGeom prst="rect">
-            <a:avLst/>
-          </a:prstGeom>
-          <a:noFill/>
-          <a:ln/>
-        </p:spPr>
-        <p:txBody>
-          <a:bodyPr wrap="square" lIns="0" tIns="0" rIns="0" bIns="0" rtlCol="0" anchor="ctr"/>
-          <a:lstStyle/>
-          <a:p>
-            <a:pPr marL="0" indent="0">
-              <a:buNone/>
-            </a:pPr>
-            <a:r>
-              <a:rPr lang="en-US" sz="1600" dirty="0">
-                <a:solidFill>
-                  <a:srgbClr val="5C5C5C"/>
-                </a:solidFill>
-                <a:latin typeface="Segoe UI" pitchFamily="34" charset="0"/>
-                <a:ea typeface="Segoe UI" pitchFamily="34" charset="-122"/>
-                <a:cs typeface="Segoe UI" pitchFamily="34" charset="-120"/>
-              </a:rPr>
-              <a:t>Each step is a folder in the repo, and each adds one idea to the step before it.</a:t>
-            </a:r>
-            <a:endParaRPr lang="en-US" sz="1600" dirty="0"/>
-          </a:p>
-        </p:txBody>
-      </p:sp>
       <p:pic>
         <p:nvPicPr>
           <p:cNvPr id="4" name="Image 0" descr="The four steps: 1, run it on your laptop; 2, ship it to Azure with azd up; 3, add an AI assistant with Microsoft Foundry; 4, see inside with OpenTelemetry"/>
@@ -5149,14 +4922,15 @@
         </p:nvPicPr>
         <p:blipFill>
           <a:blip r:embed="rId3"/>
+          <a:srcRect l="2700" t="579" r="2150" b="5499"/>
           <a:stretch>
             <a:fillRect/>
           </a:stretch>
         </p:blipFill>
         <p:spPr>
           <a:xfrm>
-            <a:off x="365760" y="1952649"/>
-            <a:ext cx="11457432" cy="3958543"/>
+            <a:off x="453839" y="1846262"/>
+            <a:ext cx="11275348" cy="3845350"/>
           </a:xfrm>
           <a:prstGeom prst="rect">
             <a:avLst/>
@@ -6862,14 +6636,15 @@
         </p:nvPicPr>
         <p:blipFill>
           <a:blip r:embed="rId3"/>
+          <a:srcRect l="2050" t="446" r="20750" b="6250"/>
           <a:stretch>
             <a:fillRect/>
           </a:stretch>
         </p:blipFill>
         <p:spPr>
           <a:xfrm>
-            <a:off x="365760" y="1229831"/>
-            <a:ext cx="11457432" cy="3849697"/>
+            <a:off x="933572" y="1036038"/>
+            <a:ext cx="10321809" cy="4191563"/>
           </a:xfrm>
           <a:prstGeom prst="rect">
             <a:avLst/>
@@ -7564,14 +7339,15 @@
         </p:nvPicPr>
         <p:blipFill>
           <a:blip r:embed="rId3"/>
+          <a:srcRect l="3000" t="0" r="3550" b="16633"/>
           <a:stretch>
             <a:fillRect/>
           </a:stretch>
         </p:blipFill>
         <p:spPr>
           <a:xfrm>
-            <a:off x="669283" y="1051560"/>
-            <a:ext cx="10850385" cy="5349240"/>
+            <a:off x="452086" y="1285627"/>
+            <a:ext cx="11278746" cy="4960476"/>
           </a:xfrm>
           <a:prstGeom prst="rect">
             <a:avLst/>
@@ -7965,7 +7741,7 @@
         </p:nvSpPr>
         <p:spPr>
           <a:xfrm>
-            <a:off x="6446520" y="3246120"/>
+            <a:off x="6446520" y="3711304"/>
             <a:ext cx="5193792" cy="320040"/>
           </a:xfrm>
           <a:prstGeom prst="rect">
@@ -8004,7 +7780,7 @@
         </p:nvSpPr>
         <p:spPr>
           <a:xfrm>
-            <a:off x="6446520" y="3639312"/>
+            <a:off x="6446520" y="4104496"/>
             <a:ext cx="5193792" cy="411480"/>
           </a:xfrm>
           <a:prstGeom prst="rect">
@@ -8043,7 +7819,7 @@
         </p:nvSpPr>
         <p:spPr>
           <a:xfrm>
-            <a:off x="6446520" y="3639312"/>
+            <a:off x="6446520" y="4104496"/>
             <a:ext cx="82296" cy="411480"/>
           </a:xfrm>
           <a:prstGeom prst="rect">
@@ -8075,7 +7851,7 @@
         </p:nvSpPr>
         <p:spPr>
           <a:xfrm>
-            <a:off x="6766560" y="3639312"/>
+            <a:off x="6766560" y="4104496"/>
             <a:ext cx="4645152" cy="411480"/>
           </a:xfrm>
           <a:prstGeom prst="rect">
@@ -8114,7 +7890,7 @@
         </p:nvSpPr>
         <p:spPr>
           <a:xfrm>
-            <a:off x="6446520" y="4279392"/>
+            <a:off x="6446520" y="4744576"/>
             <a:ext cx="5193792" cy="411480"/>
           </a:xfrm>
           <a:prstGeom prst="rect">
@@ -8153,7 +7929,7 @@
         </p:nvSpPr>
         <p:spPr>
           <a:xfrm>
-            <a:off x="6446520" y="4279392"/>
+            <a:off x="6446520" y="4744576"/>
             <a:ext cx="82296" cy="411480"/>
           </a:xfrm>
           <a:prstGeom prst="rect">
@@ -8185,7 +7961,7 @@
         </p:nvSpPr>
         <p:spPr>
           <a:xfrm>
-            <a:off x="6766560" y="4279392"/>
+            <a:off x="6766560" y="4744576"/>
             <a:ext cx="4645152" cy="411480"/>
           </a:xfrm>
           <a:prstGeom prst="rect">
@@ -8224,7 +8000,7 @@
         </p:nvSpPr>
         <p:spPr>
           <a:xfrm>
-            <a:off x="6446520" y="4919472"/>
+            <a:off x="6446520" y="5384656"/>
             <a:ext cx="5193792" cy="411480"/>
           </a:xfrm>
           <a:prstGeom prst="rect">
@@ -8263,7 +8039,7 @@
         </p:nvSpPr>
         <p:spPr>
           <a:xfrm>
-            <a:off x="6446520" y="4919472"/>
+            <a:off x="6446520" y="5384656"/>
             <a:ext cx="82296" cy="411480"/>
           </a:xfrm>
           <a:prstGeom prst="rect">
@@ -8295,7 +8071,7 @@
         </p:nvSpPr>
         <p:spPr>
           <a:xfrm>
-            <a:off x="6766560" y="4919472"/>
+            <a:off x="6766560" y="5384656"/>
             <a:ext cx="4645152" cy="411480"/>
           </a:xfrm>
           <a:prstGeom prst="rect">
@@ -8323,45 +8099,6 @@
               <a:t>“Write me a poem about the weather.”</a:t>
             </a:r>
             <a:endParaRPr lang="en-US" sz="1600" dirty="0"/>
-          </a:p>
-        </p:txBody>
-      </p:sp>
-      <p:sp>
-        <p:nvSpPr>
-          <p:cNvPr id="21" name="Text 18"/>
-          <p:cNvSpPr/>
-          <p:nvPr/>
-        </p:nvSpPr>
-        <p:spPr>
-          <a:xfrm>
-            <a:off x="6446520" y="5532120"/>
-            <a:ext cx="5193792" cy="457200"/>
-          </a:xfrm>
-          <a:prstGeom prst="rect">
-            <a:avLst/>
-          </a:prstGeom>
-          <a:noFill/>
-          <a:ln/>
-        </p:spPr>
-        <p:txBody>
-          <a:bodyPr wrap="square" lIns="0" tIns="0" rIns="0" bIns="0" rtlCol="0" anchor="t"/>
-          <a:lstStyle/>
-          <a:p>
-            <a:pPr marL="0" indent="0">
-              <a:buNone/>
-            </a:pPr>
-            <a:r>
-              <a:rPr lang="en-US" sz="1400" dirty="0">
-                <a:solidFill>
-                  <a:srgbClr val="5C5C5C"/>
-                </a:solidFill>
-                <a:latin typeface="Segoe UI" pitchFamily="34" charset="0"/>
-                <a:ea typeface="Segoe UI" pitchFamily="34" charset="-122"/>
-                <a:cs typeface="Segoe UI" pitchFamily="34" charset="-120"/>
-              </a:rPr>
-              <a:t>The whole room shares one model. If it can't answer, wait a few seconds and try again.</a:t>
-            </a:r>
-            <a:endParaRPr lang="en-US" sz="1400" dirty="0"/>
           </a:p>
         </p:txBody>
       </p:sp>
@@ -8457,7 +8194,7 @@
         <p:spPr>
           <a:xfrm>
             <a:off x="548640" y="1325880"/>
-            <a:ext cx="5134356" cy="2468880"/>
+            <a:ext cx="5134356" cy="1828800"/>
           </a:xfrm>
           <a:prstGeom prst="rect">
             <a:avLst/>
@@ -8496,7 +8233,7 @@
         <p:spPr>
           <a:xfrm>
             <a:off x="548640" y="1325880"/>
-            <a:ext cx="82296" cy="2468880"/>
+            <a:ext cx="82296" cy="1828800"/>
           </a:xfrm>
           <a:prstGeom prst="rect">
             <a:avLst/>
@@ -8599,52 +8336,13 @@
       </p:sp>
       <p:sp>
         <p:nvSpPr>
-          <p:cNvPr id="7" name="Saw body"/>
-          <p:cNvSpPr/>
-          <p:nvPr/>
-        </p:nvSpPr>
-        <p:spPr>
-          <a:xfrm>
-            <a:off x="914400" y="2468880"/>
-            <a:ext cx="4494276" cy="594360"/>
-          </a:xfrm>
-          <a:prstGeom prst="rect">
-            <a:avLst/>
-          </a:prstGeom>
-          <a:noFill/>
-          <a:ln/>
-        </p:spPr>
-        <p:txBody>
-          <a:bodyPr wrap="square" lIns="0" tIns="0" rIns="0" bIns="0" rtlCol="0" anchor="t"/>
-          <a:lstStyle/>
-          <a:p>
-            <a:pPr marL="0" indent="0">
-              <a:buNone/>
-            </a:pPr>
-            <a:r>
-              <a:rPr lang="en-US" sz="1600" dirty="0">
-                <a:solidFill>
-                  <a:srgbClr val="242424"/>
-                </a:solidFill>
-                <a:latin typeface="Segoe UI" pitchFamily="34" charset="0"/>
-                <a:ea typeface="Segoe UI" pitchFamily="34" charset="-122"/>
-                <a:cs typeface="Segoe UI" pitchFamily="34" charset="-120"/>
-              </a:rPr>
-              <a:t>In this app, the model asks to run your Java method, then answers your question.</a:t>
-            </a:r>
-            <a:endParaRPr lang="en-US" sz="1600" dirty="0"/>
-          </a:p>
-        </p:txBody>
-      </p:sp>
-      <p:sp>
-        <p:nvSpPr>
           <p:cNvPr id="8" name="Saw code"/>
           <p:cNvSpPr/>
           <p:nvPr/>
         </p:nvSpPr>
         <p:spPr>
           <a:xfrm>
-            <a:off x="914400" y="3200400"/>
+            <a:off x="914400" y="2560320"/>
             <a:ext cx="4494276" cy="274320"/>
           </a:xfrm>
           <a:prstGeom prst="rect">
@@ -8694,7 +8392,7 @@
         </p:nvCxnSpPr>
         <p:spPr>
           <a:xfrm>
-            <a:off x="5957316" y="2560320"/>
+            <a:off x="5957316" y="2240280"/>
             <a:ext cx="274320" cy="0"/>
           </a:xfrm>
           <a:prstGeom prst="straightConnector1">
@@ -8717,7 +8415,7 @@
         <p:spPr>
           <a:xfrm>
             <a:off x="6505956" y="1325880"/>
-            <a:ext cx="5134356" cy="2468880"/>
+            <a:ext cx="5134356" cy="1828800"/>
           </a:xfrm>
           <a:prstGeom prst="rect">
             <a:avLst/>
@@ -8756,7 +8454,7 @@
         <p:spPr>
           <a:xfrm>
             <a:off x="6505956" y="1325880"/>
-            <a:ext cx="82296" cy="2468880"/>
+            <a:ext cx="82296" cy="1828800"/>
           </a:xfrm>
           <a:prstGeom prst="rect">
             <a:avLst/>
@@ -8859,52 +8557,13 @@
       </p:sp>
       <p:sp>
         <p:nvSpPr>
-          <p:cNvPr id="14" name="SDK body"/>
-          <p:cNvSpPr/>
-          <p:nvPr/>
-        </p:nvSpPr>
-        <p:spPr>
-          <a:xfrm>
-            <a:off x="6871716" y="2468880"/>
-            <a:ext cx="4494276" cy="594360"/>
-          </a:xfrm>
-          <a:prstGeom prst="rect">
-            <a:avLst/>
-          </a:prstGeom>
-          <a:noFill/>
-          <a:ln/>
-        </p:spPr>
-        <p:txBody>
-          <a:bodyPr wrap="square" lIns="0" tIns="0" rIns="0" bIns="0" rtlCol="0" anchor="t"/>
-          <a:lstStyle/>
-          <a:p>
-            <a:pPr marL="0" indent="0">
-              <a:buNone/>
-            </a:pPr>
-            <a:r>
-              <a:rPr lang="en-US" sz="1600" dirty="0">
-                <a:solidFill>
-                  <a:srgbClr val="242424"/>
-                </a:solidFill>
-                <a:latin typeface="Segoe UI" pitchFamily="34" charset="0"/>
-                <a:ea typeface="Segoe UI" pitchFamily="34" charset="-122"/>
-                <a:cs typeface="Segoe UI" pitchFamily="34" charset="-120"/>
-              </a:rPr>
-              <a:t>Copilot's agent runs in your app. It plans and calls your Java tools until the job is done.</a:t>
-            </a:r>
-            <a:endParaRPr lang="en-US" sz="1600" dirty="0"/>
-          </a:p>
-        </p:txBody>
-      </p:sp>
-      <p:sp>
-        <p:nvSpPr>
           <p:cNvPr id="15" name="SDK code"/>
           <p:cNvSpPr/>
           <p:nvPr/>
         </p:nvSpPr>
         <p:spPr>
           <a:xfrm>
-            <a:off x="6871716" y="3200400"/>
+            <a:off x="6871716" y="2560320"/>
             <a:ext cx="4494276" cy="274320"/>
           </a:xfrm>
           <a:prstGeom prst="rect">
@@ -8954,7 +8613,7 @@
         </p:nvSpPr>
         <p:spPr>
           <a:xfrm>
-            <a:off x="548640" y="4114800"/>
+            <a:off x="548640" y="3474720"/>
             <a:ext cx="11091672" cy="1554480"/>
           </a:xfrm>
           <a:prstGeom prst="rect">
@@ -8993,7 +8652,7 @@
         </p:nvSpPr>
         <p:spPr>
           <a:xfrm>
-            <a:off x="548640" y="4114800"/>
+            <a:off x="548640" y="3474720"/>
             <a:ext cx="82296" cy="1554480"/>
           </a:xfrm>
           <a:prstGeom prst="rect">
@@ -9025,7 +8684,7 @@
         </p:nvSpPr>
         <p:spPr>
           <a:xfrm>
-            <a:off x="914400" y="4434840"/>
+            <a:off x="914400" y="3794760"/>
             <a:ext cx="4494276" cy="228600"/>
           </a:xfrm>
           <a:prstGeom prst="rect">
@@ -9064,7 +8723,7 @@
         </p:nvSpPr>
         <p:spPr>
           <a:xfrm>
-            <a:off x="914400" y="4754880"/>
+            <a:off x="914400" y="4114800"/>
             <a:ext cx="4494276" cy="594360"/>
           </a:xfrm>
           <a:prstGeom prst="rect">
@@ -9119,7 +8778,7 @@
         </p:nvSpPr>
         <p:spPr>
           <a:xfrm>
-            <a:off x="6871716" y="4434840"/>
+            <a:off x="6871716" y="3794760"/>
             <a:ext cx="4494276" cy="228600"/>
           </a:xfrm>
           <a:prstGeom prst="rect">
@@ -9158,7 +8817,7 @@
         </p:nvSpPr>
         <p:spPr>
           <a:xfrm>
-            <a:off x="6871716" y="4754880"/>
+            <a:off x="6871716" y="4114800"/>
             <a:ext cx="4494276" cy="594360"/>
           </a:xfrm>
           <a:prstGeom prst="rect">
@@ -9183,46 +8842,62 @@
                 <a:ea typeface="Segoe UI" pitchFamily="34" charset="-122"/>
                 <a:cs typeface="Segoe UI" pitchFamily="34" charset="-120"/>
               </a:rPr>
-              <a:t>Your own Foundry model with managed identity: no keys. Or a GitHub Copilot subscription.</a:t>
-            </a:r>
-            <a:endParaRPr lang="en-US" sz="1600" dirty="0"/>
-          </a:p>
-        </p:txBody>
-      </p:sp>
-      <p:sp>
-        <p:nvSpPr>
-          <p:cNvPr id="22" name="Footnote"/>
-          <p:cNvSpPr/>
-          <p:nvPr/>
-        </p:nvSpPr>
-        <p:spPr>
-          <a:xfrm>
-            <a:off x="548640" y="5943600"/>
-            <a:ext cx="11091672" cy="274320"/>
-          </a:xfrm>
-          <a:prstGeom prst="rect">
-            <a:avLst/>
-          </a:prstGeom>
-          <a:noFill/>
-          <a:ln/>
-        </p:spPr>
-        <p:txBody>
-          <a:bodyPr wrap="square" lIns="0" tIns="0" rIns="0" bIns="0" rtlCol="0" anchor="t"/>
-          <a:lstStyle/>
-          <a:p>
-            <a:pPr marL="0" indent="0">
-              <a:buNone/>
-            </a:pPr>
-            <a:r>
-              <a:rPr lang="en-US" sz="1200" dirty="0">
-                <a:solidFill>
-                  <a:srgbClr val="5C5C5C"/>
+              <a:t>Your own Foundry model, no keys</a:t>
+            </a:r>
+          </a:p>
+          <a:p>
+            <a:pPr marL="0" indent="0">
+              <a:buNone/>
+            </a:pPr>
+            <a:r>
+              <a:rPr lang="en-US" sz="1600" dirty="0">
+                <a:solidFill>
+                  <a:srgbClr val="242424"/>
                 </a:solidFill>
                 <a:latin typeface="Segoe UI" pitchFamily="34" charset="0"/>
                 <a:ea typeface="Segoe UI" pitchFamily="34" charset="-122"/>
                 <a:cs typeface="Segoe UI" pitchFamily="34" charset="-120"/>
               </a:rPr>
-              <a:t>See it working in the step-3-copilot-sdk folder. The SDK's Java releases are still labeled preview. Learn more at github.com/github/copilot-sdk</a:t>
+              <a:t>A GitHub Copilot subscription</a:t>
+            </a:r>
+            <a:endParaRPr lang="en-US" sz="1600" dirty="0"/>
+          </a:p>
+        </p:txBody>
+      </p:sp>
+      <p:sp>
+        <p:nvSpPr>
+          <p:cNvPr id="22" name="Footnote"/>
+          <p:cNvSpPr/>
+          <p:nvPr/>
+        </p:nvSpPr>
+        <p:spPr>
+          <a:xfrm>
+            <a:off x="548640" y="5303520"/>
+            <a:ext cx="11091672" cy="274320"/>
+          </a:xfrm>
+          <a:prstGeom prst="rect">
+            <a:avLst/>
+          </a:prstGeom>
+          <a:noFill/>
+          <a:ln/>
+        </p:spPr>
+        <p:txBody>
+          <a:bodyPr wrap="square" lIns="0" tIns="0" rIns="0" bIns="0" rtlCol="0" anchor="t"/>
+          <a:lstStyle/>
+          <a:p>
+            <a:pPr marL="0" indent="0">
+              <a:buNone/>
+            </a:pPr>
+            <a:r>
+              <a:rPr lang="en-US" sz="1200" dirty="0">
+                <a:solidFill>
+                  <a:srgbClr val="5C5C5C"/>
+                </a:solidFill>
+                <a:latin typeface="Segoe UI" pitchFamily="34" charset="0"/>
+                <a:ea typeface="Segoe UI" pitchFamily="34" charset="-122"/>
+                <a:cs typeface="Segoe UI" pitchFamily="34" charset="-120"/>
+              </a:rPr>
+              <a:t>step-3-copilot-sdk   ·   github.com/github/copilot-sdk</a:t>
             </a:r>
             <a:endParaRPr lang="en-US" sz="1200" dirty="0"/>
           </a:p>
@@ -9321,14 +8996,15 @@
         </p:nvPicPr>
         <p:blipFill>
           <a:blip r:embed="rId3"/>
+          <a:srcRect l="1600" t="0" r="1650" b="15108"/>
           <a:stretch>
             <a:fillRect/>
           </a:stretch>
         </p:blipFill>
         <p:spPr>
           <a:xfrm>
-            <a:off x="598322" y="1051560"/>
-            <a:ext cx="10995355" cy="5349240"/>
+            <a:off x="455433" y="1360160"/>
+            <a:ext cx="11272261" cy="4811828"/>
           </a:xfrm>
           <a:prstGeom prst="rect">
             <a:avLst/>

</xml_diff>